<commit_message>
fix: Less text, more visuals, larger demo frames in deck
- Split crypto/stablecoins into card-based visual layouts
- Added pegging mechanisms slide (fiat-backed, over-collat, algo)
- Arbitrage slide uses price cards + arrow instead of bullet wall
- Demo frames now 5 slides at near-full-bleed (9.5in wide)
- Reduced bullet count to 3-5 per slide max
</commit_message>
<xml_diff>
--- a/astar_arbitrage_deck.pptx
+++ b/astar_arbitrage_deck.pptx
@@ -17,6 +17,9 @@
     <p:sldId id="265" r:id="rId16"/>
     <p:sldId id="266" r:id="rId17"/>
     <p:sldId id="267" r:id="rId18"/>
+    <p:sldId id="268" r:id="rId19"/>
+    <p:sldId id="269" r:id="rId20"/>
+    <p:sldId id="270" r:id="rId21"/>
   </p:sldIdLst>
   <p:sldSz cx="9144000" cy="5143500" type="screen4x3"/>
   <p:notesSz cx="6858000" cy="9144000"/>
@@ -3325,8 +3328,8 @@
         </p:nvSpPr>
         <p:spPr>
           <a:xfrm>
-            <a:off x="457200" y="256032"/>
-            <a:ext cx="8229600" cy="640080"/>
+            <a:off x="274320" y="164592"/>
+            <a:ext cx="5486400" cy="457200"/>
           </a:xfrm>
           <a:prstGeom prst="rect">
             <a:avLst/>
@@ -3341,13 +3344,13 @@
           <a:p>
             <a:pPr algn="l"/>
             <a:r>
-              <a:rPr sz="2800" b="1" i="0">
+              <a:rPr sz="1800" b="1" i="0">
                 <a:solidFill>
                   <a:srgbClr val="173482"/>
                 </a:solidFill>
                 <a:latin typeface="Helvetica Neue"/>
               </a:rPr>
-              <a:t>Final: Profitable Cycle Discovered</a:t>
+              <a:t>A* Step 3: Expanding Neighbors</a:t>
             </a:r>
           </a:p>
         </p:txBody>
@@ -3360,8 +3363,8 @@
         </p:nvSpPr>
         <p:spPr>
           <a:xfrm>
-            <a:off x="457200" y="749808"/>
-            <a:ext cx="8229600" cy="411480"/>
+            <a:off x="274320" y="502920"/>
+            <a:ext cx="8229600" cy="320040"/>
           </a:xfrm>
           <a:prstGeom prst="rect">
             <a:avLst/>
@@ -3376,20 +3379,20 @@
           <a:p>
             <a:pPr algn="l"/>
             <a:r>
-              <a:rPr sz="1400" b="0" i="1">
+              <a:rPr sz="1100" b="0" i="1">
                 <a:solidFill>
                   <a:srgbClr val="595959"/>
                 </a:solidFill>
                 <a:latin typeface="Helvetica Neue"/>
               </a:rPr>
-              <a:t>Red path = the cycle with lowest total real cost. The heuristic guided the search away from thin-book exchanges.</a:t>
+              <a:t>Cheap, low-slippage paths explored first. Fee labels (bps) on each edge.</a:t>
             </a:r>
           </a:p>
         </p:txBody>
       </p:sp>
       <p:pic>
         <p:nvPicPr>
-          <p:cNvPr id="5" name="Picture 4" descr="frame_09_step44.png"/>
+          <p:cNvPr id="5" name="Picture 4" descr="frame_02_step10.png"/>
           <p:cNvPicPr>
             <a:picLocks noChangeAspect="1"/>
           </p:cNvPicPr>
@@ -3403,8 +3406,8 @@
         </p:blipFill>
         <p:spPr>
           <a:xfrm>
-            <a:off x="2831047" y="1280160"/>
-            <a:ext cx="3481906" cy="3566160"/>
+            <a:off x="2563208" y="868680"/>
+            <a:ext cx="4017584" cy="4114800"/>
           </a:xfrm>
           <a:prstGeom prst="rect">
             <a:avLst/>
@@ -3524,8 +3527,8 @@
         </p:nvSpPr>
         <p:spPr>
           <a:xfrm>
-            <a:off x="457200" y="256032"/>
-            <a:ext cx="8229600" cy="640080"/>
+            <a:off x="274320" y="164592"/>
+            <a:ext cx="5486400" cy="457200"/>
           </a:xfrm>
           <a:prstGeom prst="rect">
             <a:avLst/>
@@ -3540,13 +3543,13 @@
           <a:p>
             <a:pPr algn="l"/>
             <a:r>
-              <a:rPr sz="2800" b="1" i="0">
+              <a:rPr sz="1800" b="1" i="0">
                 <a:solidFill>
                   <a:srgbClr val="173482"/>
                 </a:solidFill>
                 <a:latin typeface="Helvetica Neue"/>
               </a:rPr>
-              <a:t>The Heuristic: L2 Order Book Slippage</a:t>
+              <a:t>A* Mid-Search</a:t>
             </a:r>
           </a:p>
         </p:txBody>
@@ -3559,8 +3562,8 @@
         </p:nvSpPr>
         <p:spPr>
           <a:xfrm>
-            <a:off x="457200" y="749808"/>
-            <a:ext cx="8229600" cy="411480"/>
+            <a:off x="274320" y="502920"/>
+            <a:ext cx="8229600" cy="320040"/>
           </a:xfrm>
           <a:prstGeom prst="rect">
             <a:avLst/>
@@ -3575,167 +3578,20 @@
           <a:p>
             <a:pPr algn="l"/>
             <a:r>
-              <a:rPr sz="1400" b="0" i="1">
+              <a:rPr sz="1100" b="0" i="1">
                 <a:solidFill>
                   <a:srgbClr val="595959"/>
                 </a:solidFill>
                 <a:latin typeface="Helvetica Neue"/>
               </a:rPr>
-              <a:t>How h(n) estimates execution cost before we actually trade</a:t>
-            </a:r>
-          </a:p>
-        </p:txBody>
-      </p:sp>
-      <p:sp>
-        <p:nvSpPr>
-          <p:cNvPr id="5" name="TextBox 4"/>
-          <p:cNvSpPr txBox="1"/>
-          <p:nvPr/>
-        </p:nvSpPr>
-        <p:spPr>
-          <a:xfrm>
-            <a:off x="548640" y="1280160"/>
-            <a:ext cx="4572000" cy="3474720"/>
-          </a:xfrm>
-          <a:prstGeom prst="rect">
-            <a:avLst/>
-          </a:prstGeom>
-          <a:noFill/>
-        </p:spPr>
-        <p:txBody>
-          <a:bodyPr wrap="square">
-            <a:spAutoFit/>
-          </a:bodyPr>
-          <a:lstStyle/>
-          <a:p>
-            <a:pPr>
-              <a:spcAft>
-                <a:spcPts val="800"/>
-              </a:spcAft>
-            </a:pPr>
-            <a:r>
-              <a:rPr sz="1200">
-                <a:solidFill>
-                  <a:srgbClr val="000000"/>
-                </a:solidFill>
-                <a:latin typeface="Helvetica Neue"/>
-              </a:rPr>
-              <a:t>•  Every exchange provides Level 2 (L2) data:</a:t>
-            </a:r>
-            <a:br/>
-            <a:r>
-              <a:rPr sz="1200">
-                <a:solidFill>
-                  <a:srgbClr val="000000"/>
-                </a:solidFill>
-                <a:latin typeface="Helvetica Neue"/>
-              </a:rPr>
-              <a:t>  20 levels of bids and asks with quantities</a:t>
-            </a:r>
-          </a:p>
-          <a:p>
-            <a:pPr>
-              <a:spcAft>
-                <a:spcPts val="800"/>
-              </a:spcAft>
-            </a:pPr>
-            <a:r>
-              <a:rPr sz="1200">
-                <a:solidFill>
-                  <a:srgbClr val="000000"/>
-                </a:solidFill>
-                <a:latin typeface="Helvetica Neue"/>
-              </a:rPr>
-              <a:t>•  For a $50K trade, we walk the ask levels:</a:t>
-            </a:r>
-            <a:br/>
-            <a:r>
-              <a:rPr sz="1200">
-                <a:solidFill>
-                  <a:srgbClr val="000000"/>
-                </a:solidFill>
-                <a:latin typeface="Helvetica Neue"/>
-              </a:rPr>
-              <a:t>  Level 1: 236K units @ 1.00013</a:t>
-            </a:r>
-            <a:br/>
-            <a:r>
-              <a:rPr sz="1200">
-                <a:solidFill>
-                  <a:srgbClr val="000000"/>
-                </a:solidFill>
-                <a:latin typeface="Helvetica Neue"/>
-              </a:rPr>
-              <a:t>  Level 2: 766K units @ 1.00014</a:t>
-            </a:r>
-            <a:br/>
-            <a:r>
-              <a:rPr sz="1200">
-                <a:solidFill>
-                  <a:srgbClr val="000000"/>
-                </a:solidFill>
-                <a:latin typeface="Helvetica Neue"/>
-              </a:rPr>
-              <a:t>  → our order fills entirely at level 1</a:t>
-            </a:r>
-          </a:p>
-          <a:p>
-            <a:pPr>
-              <a:spcAft>
-                <a:spcPts val="800"/>
-              </a:spcAft>
-            </a:pPr>
-            <a:r>
-              <a:rPr sz="1200">
-                <a:solidFill>
-                  <a:srgbClr val="000000"/>
-                </a:solidFill>
-                <a:latin typeface="Helvetica Neue"/>
-              </a:rPr>
-              <a:t>•  Slippage = avg fill price − best ask</a:t>
-            </a:r>
-            <a:br/>
-            <a:r>
-              <a:rPr sz="1200">
-                <a:solidFill>
-                  <a:srgbClr val="000000"/>
-                </a:solidFill>
-                <a:latin typeface="Helvetica Neue"/>
-              </a:rPr>
-              <a:t>  Binance: ~0.00 bps (deep)</a:t>
-            </a:r>
-            <a:br/>
-            <a:r>
-              <a:rPr sz="1200">
-                <a:solidFill>
-                  <a:srgbClr val="000000"/>
-                </a:solidFill>
-                <a:latin typeface="Helvetica Neue"/>
-              </a:rPr>
-              <a:t>  Gate.io: ~0.47 bps (thin)</a:t>
-            </a:r>
-          </a:p>
-          <a:p>
-            <a:pPr>
-              <a:spcAft>
-                <a:spcPts val="800"/>
-              </a:spcAft>
-            </a:pPr>
-            <a:r>
-              <a:rPr sz="1200">
-                <a:solidFill>
-                  <a:srgbClr val="000000"/>
-                </a:solidFill>
-                <a:latin typeface="Helvetica Neue"/>
-              </a:rPr>
-              <a:t>•  Thin books → large h(n) → A* avoids them</a:t>
+              <a:t>Bybit and Kraken reached. High time-risk paths to OKX deprioritized.</a:t>
             </a:r>
           </a:p>
         </p:txBody>
       </p:sp>
       <p:pic>
         <p:nvPicPr>
-          <p:cNvPr id="6" name="Picture 5" descr="astar_arbitrage_demo.png"/>
+          <p:cNvPr id="5" name="Picture 4" descr="frame_05_step25.png"/>
           <p:cNvPicPr>
             <a:picLocks noChangeAspect="1"/>
           </p:cNvPicPr>
@@ -3749,8 +3605,8 @@
         </p:blipFill>
         <p:spPr>
           <a:xfrm>
-            <a:off x="4846320" y="1188720"/>
-            <a:ext cx="4114800" cy="3672135"/>
+            <a:off x="2563208" y="868680"/>
+            <a:ext cx="4017584" cy="4114800"/>
           </a:xfrm>
           <a:prstGeom prst="rect">
             <a:avLst/>
@@ -3759,7 +3615,7 @@
       </p:pic>
       <p:sp>
         <p:nvSpPr>
-          <p:cNvPr id="7" name="TextBox 6"/>
+          <p:cNvPr id="6" name="TextBox 5"/>
           <p:cNvSpPr txBox="1"/>
           <p:nvPr/>
         </p:nvSpPr>
@@ -3870,8 +3726,8 @@
         </p:nvSpPr>
         <p:spPr>
           <a:xfrm>
-            <a:off x="457200" y="256032"/>
-            <a:ext cx="8229600" cy="640080"/>
+            <a:off x="274320" y="164592"/>
+            <a:ext cx="5486400" cy="457200"/>
           </a:xfrm>
           <a:prstGeom prst="rect">
             <a:avLst/>
@@ -3886,13 +3742,13 @@
           <a:p>
             <a:pPr algn="l"/>
             <a:r>
-              <a:rPr sz="2800" b="1" i="0">
+              <a:rPr sz="1800" b="1" i="0">
                 <a:solidFill>
                   <a:srgbClr val="173482"/>
                 </a:solidFill>
                 <a:latin typeface="Helvetica Neue"/>
               </a:rPr>
-              <a:t>Summary</a:t>
+              <a:t>A* Nearing Completion</a:t>
             </a:r>
           </a:p>
         </p:txBody>
@@ -3905,8 +3761,406 @@
         </p:nvSpPr>
         <p:spPr>
           <a:xfrm>
-            <a:off x="548640" y="1188720"/>
-            <a:ext cx="8229600" cy="3474720"/>
+            <a:off x="274320" y="502920"/>
+            <a:ext cx="8229600" cy="320040"/>
+          </a:xfrm>
+          <a:prstGeom prst="rect">
+            <a:avLst/>
+          </a:prstGeom>
+          <a:noFill/>
+        </p:spPr>
+        <p:txBody>
+          <a:bodyPr wrap="square">
+            <a:spAutoFit/>
+          </a:bodyPr>
+          <a:lstStyle/>
+          <a:p>
+            <a:pPr algn="l"/>
+            <a:r>
+              <a:rPr sz="1100" b="0" i="1">
+                <a:solidFill>
+                  <a:srgbClr val="595959"/>
+                </a:solidFill>
+                <a:latin typeface="Helvetica Neue"/>
+              </a:rPr>
+              <a:t>Most nodes expanded. Searching for profitable return path to start.</a:t>
+            </a:r>
+          </a:p>
+        </p:txBody>
+      </p:sp>
+      <p:pic>
+        <p:nvPicPr>
+          <p:cNvPr id="5" name="Picture 4" descr="frame_08_step40.png"/>
+          <p:cNvPicPr>
+            <a:picLocks noChangeAspect="1"/>
+          </p:cNvPicPr>
+          <p:nvPr/>
+        </p:nvPicPr>
+        <p:blipFill>
+          <a:blip r:embed="rId2"/>
+          <a:stretch>
+            <a:fillRect/>
+          </a:stretch>
+        </p:blipFill>
+        <p:spPr>
+          <a:xfrm>
+            <a:off x="2563208" y="868680"/>
+            <a:ext cx="4017584" cy="4114800"/>
+          </a:xfrm>
+          <a:prstGeom prst="rect">
+            <a:avLst/>
+          </a:prstGeom>
+        </p:spPr>
+      </p:pic>
+      <p:sp>
+        <p:nvSpPr>
+          <p:cNvPr id="6" name="TextBox 5"/>
+          <p:cNvSpPr txBox="1"/>
+          <p:nvPr/>
+        </p:nvSpPr>
+        <p:spPr>
+          <a:xfrm>
+            <a:off x="8503920" y="4823460"/>
+            <a:ext cx="457200" cy="274320"/>
+          </a:xfrm>
+          <a:prstGeom prst="rect">
+            <a:avLst/>
+          </a:prstGeom>
+          <a:noFill/>
+        </p:spPr>
+        <p:txBody>
+          <a:bodyPr wrap="square">
+            <a:spAutoFit/>
+          </a:bodyPr>
+          <a:lstStyle/>
+          <a:p>
+            <a:pPr algn="r"/>
+            <a:r>
+              <a:rPr sz="1000" b="0" i="0">
+                <a:solidFill>
+                  <a:srgbClr val="595959"/>
+                </a:solidFill>
+                <a:latin typeface="Helvetica Neue"/>
+              </a:rPr>
+              <a:t>12</a:t>
+            </a:r>
+          </a:p>
+        </p:txBody>
+      </p:sp>
+    </p:spTree>
+  </p:cSld>
+  <p:clrMapOvr>
+    <a:masterClrMapping/>
+  </p:clrMapOvr>
+</p:sld>
+</file>
+
+<file path=ppt/slides/slide13.xml><?xml version="1.0" encoding="utf-8"?>
+<p:sld xmlns:a="http://schemas.openxmlformats.org/drawingml/2006/main" xmlns:p="http://schemas.openxmlformats.org/presentationml/2006/main" xmlns:r="http://schemas.openxmlformats.org/officeDocument/2006/relationships">
+  <p:cSld>
+    <p:bg>
+      <p:bgPr>
+        <a:solidFill>
+          <a:srgbClr val="FFFFFF"/>
+        </a:solidFill>
+        <a:effectLst/>
+      </p:bgPr>
+    </p:bg>
+    <p:spTree>
+      <p:nvGrpSpPr>
+        <p:cNvPr id="1" name=""/>
+        <p:cNvGrpSpPr/>
+        <p:nvPr/>
+      </p:nvGrpSpPr>
+      <p:grpSpPr/>
+      <p:sp>
+        <p:nvSpPr>
+          <p:cNvPr id="2" name="Rectangle 1"/>
+          <p:cNvSpPr/>
+          <p:nvPr/>
+        </p:nvSpPr>
+        <p:spPr>
+          <a:xfrm>
+            <a:off x="0" y="0"/>
+            <a:ext cx="9144000" cy="109728"/>
+          </a:xfrm>
+          <a:prstGeom prst="rect">
+            <a:avLst/>
+          </a:prstGeom>
+          <a:solidFill>
+            <a:srgbClr val="173482"/>
+          </a:solidFill>
+          <a:ln>
+            <a:noFill/>
+          </a:ln>
+          <a:effectLst/>
+        </p:spPr>
+        <p:style>
+          <a:lnRef idx="1">
+            <a:schemeClr val="accent1"/>
+          </a:lnRef>
+          <a:fillRef idx="3">
+            <a:schemeClr val="accent1"/>
+          </a:fillRef>
+          <a:effectRef idx="2">
+            <a:schemeClr val="accent1"/>
+          </a:effectRef>
+          <a:fontRef idx="minor">
+            <a:schemeClr val="lt1"/>
+          </a:fontRef>
+        </p:style>
+        <p:txBody>
+          <a:bodyPr rtlCol="0" anchor="ctr"/>
+          <a:lstStyle/>
+          <a:p>
+            <a:pPr algn="ctr"/>
+          </a:p>
+        </p:txBody>
+      </p:sp>
+      <p:sp>
+        <p:nvSpPr>
+          <p:cNvPr id="3" name="TextBox 2"/>
+          <p:cNvSpPr txBox="1"/>
+          <p:nvPr/>
+        </p:nvSpPr>
+        <p:spPr>
+          <a:xfrm>
+            <a:off x="274320" y="164592"/>
+            <a:ext cx="5486400" cy="457200"/>
+          </a:xfrm>
+          <a:prstGeom prst="rect">
+            <a:avLst/>
+          </a:prstGeom>
+          <a:noFill/>
+        </p:spPr>
+        <p:txBody>
+          <a:bodyPr wrap="square">
+            <a:spAutoFit/>
+          </a:bodyPr>
+          <a:lstStyle/>
+          <a:p>
+            <a:pPr algn="l"/>
+            <a:r>
+              <a:rPr sz="1800" b="1" i="0">
+                <a:solidFill>
+                  <a:srgbClr val="173482"/>
+                </a:solidFill>
+                <a:latin typeface="Helvetica Neue"/>
+              </a:rPr>
+              <a:t>A* Final: Cycle Found</a:t>
+            </a:r>
+          </a:p>
+        </p:txBody>
+      </p:sp>
+      <p:sp>
+        <p:nvSpPr>
+          <p:cNvPr id="4" name="TextBox 3"/>
+          <p:cNvSpPr txBox="1"/>
+          <p:nvPr/>
+        </p:nvSpPr>
+        <p:spPr>
+          <a:xfrm>
+            <a:off x="274320" y="502920"/>
+            <a:ext cx="8229600" cy="320040"/>
+          </a:xfrm>
+          <a:prstGeom prst="rect">
+            <a:avLst/>
+          </a:prstGeom>
+          <a:noFill/>
+        </p:spPr>
+        <p:txBody>
+          <a:bodyPr wrap="square">
+            <a:spAutoFit/>
+          </a:bodyPr>
+          <a:lstStyle/>
+          <a:p>
+            <a:pPr algn="l"/>
+            <a:r>
+              <a:rPr sz="1100" b="0" i="1">
+                <a:solidFill>
+                  <a:srgbClr val="595959"/>
+                </a:solidFill>
+                <a:latin typeface="Helvetica Neue"/>
+              </a:rPr>
+              <a:t>Red = profitable arbitrage cycle. Total cost shown in info panel.</a:t>
+            </a:r>
+          </a:p>
+        </p:txBody>
+      </p:sp>
+      <p:pic>
+        <p:nvPicPr>
+          <p:cNvPr id="5" name="Picture 4" descr="frame_09_step44.png"/>
+          <p:cNvPicPr>
+            <a:picLocks noChangeAspect="1"/>
+          </p:cNvPicPr>
+          <p:nvPr/>
+        </p:nvPicPr>
+        <p:blipFill>
+          <a:blip r:embed="rId2"/>
+          <a:stretch>
+            <a:fillRect/>
+          </a:stretch>
+        </p:blipFill>
+        <p:spPr>
+          <a:xfrm>
+            <a:off x="2563208" y="868680"/>
+            <a:ext cx="4017584" cy="4114800"/>
+          </a:xfrm>
+          <a:prstGeom prst="rect">
+            <a:avLst/>
+          </a:prstGeom>
+        </p:spPr>
+      </p:pic>
+      <p:sp>
+        <p:nvSpPr>
+          <p:cNvPr id="6" name="TextBox 5"/>
+          <p:cNvSpPr txBox="1"/>
+          <p:nvPr/>
+        </p:nvSpPr>
+        <p:spPr>
+          <a:xfrm>
+            <a:off x="8503920" y="4823460"/>
+            <a:ext cx="457200" cy="274320"/>
+          </a:xfrm>
+          <a:prstGeom prst="rect">
+            <a:avLst/>
+          </a:prstGeom>
+          <a:noFill/>
+        </p:spPr>
+        <p:txBody>
+          <a:bodyPr wrap="square">
+            <a:spAutoFit/>
+          </a:bodyPr>
+          <a:lstStyle/>
+          <a:p>
+            <a:pPr algn="r"/>
+            <a:r>
+              <a:rPr sz="1000" b="0" i="0">
+                <a:solidFill>
+                  <a:srgbClr val="595959"/>
+                </a:solidFill>
+                <a:latin typeface="Helvetica Neue"/>
+              </a:rPr>
+              <a:t>13</a:t>
+            </a:r>
+          </a:p>
+        </p:txBody>
+      </p:sp>
+    </p:spTree>
+  </p:cSld>
+  <p:clrMapOvr>
+    <a:masterClrMapping/>
+  </p:clrMapOvr>
+</p:sld>
+</file>
+
+<file path=ppt/slides/slide14.xml><?xml version="1.0" encoding="utf-8"?>
+<p:sld xmlns:a="http://schemas.openxmlformats.org/drawingml/2006/main" xmlns:p="http://schemas.openxmlformats.org/presentationml/2006/main" xmlns:r="http://schemas.openxmlformats.org/officeDocument/2006/relationships">
+  <p:cSld>
+    <p:bg>
+      <p:bgPr>
+        <a:solidFill>
+          <a:srgbClr val="FFFFFF"/>
+        </a:solidFill>
+        <a:effectLst/>
+      </p:bgPr>
+    </p:bg>
+    <p:spTree>
+      <p:nvGrpSpPr>
+        <p:cNvPr id="1" name=""/>
+        <p:cNvGrpSpPr/>
+        <p:nvPr/>
+      </p:nvGrpSpPr>
+      <p:grpSpPr/>
+      <p:sp>
+        <p:nvSpPr>
+          <p:cNvPr id="2" name="Rectangle 1"/>
+          <p:cNvSpPr/>
+          <p:nvPr/>
+        </p:nvSpPr>
+        <p:spPr>
+          <a:xfrm>
+            <a:off x="0" y="0"/>
+            <a:ext cx="9144000" cy="109728"/>
+          </a:xfrm>
+          <a:prstGeom prst="rect">
+            <a:avLst/>
+          </a:prstGeom>
+          <a:solidFill>
+            <a:srgbClr val="173482"/>
+          </a:solidFill>
+          <a:ln>
+            <a:noFill/>
+          </a:ln>
+          <a:effectLst/>
+        </p:spPr>
+        <p:style>
+          <a:lnRef idx="1">
+            <a:schemeClr val="accent1"/>
+          </a:lnRef>
+          <a:fillRef idx="3">
+            <a:schemeClr val="accent1"/>
+          </a:fillRef>
+          <a:effectRef idx="2">
+            <a:schemeClr val="accent1"/>
+          </a:effectRef>
+          <a:fontRef idx="minor">
+            <a:schemeClr val="lt1"/>
+          </a:fontRef>
+        </p:style>
+        <p:txBody>
+          <a:bodyPr rtlCol="0" anchor="ctr"/>
+          <a:lstStyle/>
+          <a:p>
+            <a:pPr algn="ctr"/>
+          </a:p>
+        </p:txBody>
+      </p:sp>
+      <p:sp>
+        <p:nvSpPr>
+          <p:cNvPr id="3" name="TextBox 2"/>
+          <p:cNvSpPr txBox="1"/>
+          <p:nvPr/>
+        </p:nvSpPr>
+        <p:spPr>
+          <a:xfrm>
+            <a:off x="457200" y="256032"/>
+            <a:ext cx="8229600" cy="640080"/>
+          </a:xfrm>
+          <a:prstGeom prst="rect">
+            <a:avLst/>
+          </a:prstGeom>
+          <a:noFill/>
+        </p:spPr>
+        <p:txBody>
+          <a:bodyPr wrap="square">
+            <a:spAutoFit/>
+          </a:bodyPr>
+          <a:lstStyle/>
+          <a:p>
+            <a:pPr algn="l"/>
+            <a:r>
+              <a:rPr sz="2800" b="1" i="0">
+                <a:solidFill>
+                  <a:srgbClr val="173482"/>
+                </a:solidFill>
+                <a:latin typeface="Helvetica Neue"/>
+              </a:rPr>
+              <a:t>The L2 Order Book → Slippage Heuristic</a:t>
+            </a:r>
+          </a:p>
+        </p:txBody>
+      </p:sp>
+      <p:sp>
+        <p:nvSpPr>
+          <p:cNvPr id="4" name="TextBox 3"/>
+          <p:cNvSpPr txBox="1"/>
+          <p:nvPr/>
+        </p:nvSpPr>
+        <p:spPr>
+          <a:xfrm>
+            <a:off x="457200" y="1097280"/>
+            <a:ext cx="3657600" cy="3200400"/>
           </a:xfrm>
           <a:prstGeom prst="rect">
             <a:avLst/>
@@ -3925,13 +4179,13 @@
               </a:spcAft>
             </a:pPr>
             <a:r>
-              <a:rPr sz="1500">
+              <a:rPr sz="1200">
                 <a:solidFill>
                   <a:srgbClr val="000000"/>
                 </a:solidFill>
                 <a:latin typeface="Helvetica Neue"/>
               </a:rPr>
-              <a:t>•  Stablecoins trade at slightly different prices across exchanges</a:t>
+              <a:t>•  20 price levels of depth</a:t>
             </a:r>
           </a:p>
           <a:p>
@@ -3941,13 +4195,13 @@
               </a:spcAft>
             </a:pPr>
             <a:r>
-              <a:rPr sz="1500">
+              <a:rPr sz="1200">
                 <a:solidFill>
                   <a:srgbClr val="000000"/>
                 </a:solidFill>
                 <a:latin typeface="Helvetica Neue"/>
               </a:rPr>
-              <a:t>•  We model the cross-exchange landscape as a weighted directed graph</a:t>
+              <a:t>•  Walk asks for our trade size</a:t>
             </a:r>
           </a:p>
           <a:p>
@@ -3957,13 +4211,23 @@
               </a:spcAft>
             </a:pPr>
             <a:r>
-              <a:rPr sz="1500">
+              <a:rPr sz="1200">
                 <a:solidFill>
                   <a:srgbClr val="000000"/>
                 </a:solidFill>
                 <a:latin typeface="Helvetica Neue"/>
               </a:rPr>
-              <a:t>•  A* with an L2-slippage heuristic finds profitable cycles faster than blind search</a:t>
+              <a:t>•  Binance: ~0 bps slippage</a:t>
+            </a:r>
+            <a:br/>
+            <a:r>
+              <a:rPr sz="1200">
+                <a:solidFill>
+                  <a:srgbClr val="000000"/>
+                </a:solidFill>
+                <a:latin typeface="Helvetica Neue"/>
+              </a:rPr>
+              <a:t>  (millions of units at top)</a:t>
             </a:r>
           </a:p>
           <a:p>
@@ -3973,13 +4237,23 @@
               </a:spcAft>
             </a:pPr>
             <a:r>
-              <a:rPr sz="1500">
+              <a:rPr sz="1200">
                 <a:solidFill>
                   <a:srgbClr val="000000"/>
                 </a:solidFill>
                 <a:latin typeface="Helvetica Neue"/>
               </a:rPr>
-              <a:t>•  The heuristic is admissible: slippage + time-volatility never overestimates</a:t>
+              <a:t>•  Gate.io: ~0.5 bps slippage</a:t>
+            </a:r>
+            <a:br/>
+            <a:r>
+              <a:rPr sz="1200">
+                <a:solidFill>
+                  <a:srgbClr val="000000"/>
+                </a:solidFill>
+                <a:latin typeface="Helvetica Neue"/>
+              </a:rPr>
+              <a:t>  (only 6K at top level)</a:t>
             </a:r>
           </a:p>
           <a:p>
@@ -3989,27 +4263,61 @@
               </a:spcAft>
             </a:pPr>
             <a:r>
-              <a:rPr sz="1500">
+              <a:rPr sz="1200">
                 <a:solidFill>
                   <a:srgbClr val="000000"/>
                 </a:solidFill>
                 <a:latin typeface="Helvetica Neue"/>
               </a:rPr>
-              <a:t>•  Result: same optimal path as Dijkstra, but guided toward deep-liquidity routes</a:t>
-            </a:r>
-          </a:p>
-        </p:txBody>
-      </p:sp>
-      <p:sp>
-        <p:nvSpPr>
-          <p:cNvPr id="5" name="TextBox 4"/>
+              <a:t>•  Thin book = high h(n)</a:t>
+            </a:r>
+            <a:br/>
+            <a:r>
+              <a:rPr sz="1200">
+                <a:solidFill>
+                  <a:srgbClr val="000000"/>
+                </a:solidFill>
+                <a:latin typeface="Helvetica Neue"/>
+              </a:rPr>
+              <a:t>  = A* avoids it</a:t>
+            </a:r>
+          </a:p>
+        </p:txBody>
+      </p:sp>
+      <p:pic>
+        <p:nvPicPr>
+          <p:cNvPr id="5" name="Picture 4" descr="astar_arbitrage_demo.png"/>
+          <p:cNvPicPr>
+            <a:picLocks noChangeAspect="1"/>
+          </p:cNvPicPr>
+          <p:nvPr/>
+        </p:nvPicPr>
+        <p:blipFill>
+          <a:blip r:embed="rId2"/>
+          <a:stretch>
+            <a:fillRect/>
+          </a:stretch>
+        </p:blipFill>
+        <p:spPr>
+          <a:xfrm>
+            <a:off x="3840480" y="1005840"/>
+            <a:ext cx="5120640" cy="4569768"/>
+          </a:xfrm>
+          <a:prstGeom prst="rect">
+            <a:avLst/>
+          </a:prstGeom>
+        </p:spPr>
+      </p:pic>
+      <p:sp>
+        <p:nvSpPr>
+          <p:cNvPr id="6" name="TextBox 5"/>
           <p:cNvSpPr txBox="1"/>
           <p:nvPr/>
         </p:nvSpPr>
         <p:spPr>
           <a:xfrm>
-            <a:off x="548640" y="3931920"/>
-            <a:ext cx="8229600" cy="731520"/>
+            <a:off x="8503920" y="4823460"/>
+            <a:ext cx="457200" cy="274320"/>
           </a:xfrm>
           <a:prstGeom prst="rect">
             <a:avLst/>
@@ -4022,29 +4330,99 @@
           </a:bodyPr>
           <a:lstStyle/>
           <a:p>
-            <a:pPr algn="l"/>
-            <a:r>
-              <a:rPr sz="1200" b="0" i="1">
+            <a:pPr algn="r"/>
+            <a:r>
+              <a:rPr sz="1000" b="0" i="0">
                 <a:solidFill>
                   <a:srgbClr val="595959"/>
                 </a:solidFill>
                 <a:latin typeface="Helvetica Neue"/>
               </a:rPr>
-              <a:t>Code: scripts/animate_astar_search.py    |    UI: streamlit run scripts/ui.py</a:t>
-            </a:r>
-          </a:p>
-        </p:txBody>
-      </p:sp>
-      <p:sp>
-        <p:nvSpPr>
-          <p:cNvPr id="6" name="TextBox 5"/>
+              <a:t>14</a:t>
+            </a:r>
+          </a:p>
+        </p:txBody>
+      </p:sp>
+    </p:spTree>
+  </p:cSld>
+  <p:clrMapOvr>
+    <a:masterClrMapping/>
+  </p:clrMapOvr>
+</p:sld>
+</file>
+
+<file path=ppt/slides/slide15.xml><?xml version="1.0" encoding="utf-8"?>
+<p:sld xmlns:a="http://schemas.openxmlformats.org/drawingml/2006/main" xmlns:p="http://schemas.openxmlformats.org/presentationml/2006/main" xmlns:r="http://schemas.openxmlformats.org/officeDocument/2006/relationships">
+  <p:cSld>
+    <p:bg>
+      <p:bgPr>
+        <a:solidFill>
+          <a:srgbClr val="FFFFFF"/>
+        </a:solidFill>
+        <a:effectLst/>
+      </p:bgPr>
+    </p:bg>
+    <p:spTree>
+      <p:nvGrpSpPr>
+        <p:cNvPr id="1" name=""/>
+        <p:cNvGrpSpPr/>
+        <p:nvPr/>
+      </p:nvGrpSpPr>
+      <p:grpSpPr/>
+      <p:sp>
+        <p:nvSpPr>
+          <p:cNvPr id="2" name="Rectangle 1"/>
+          <p:cNvSpPr/>
+          <p:nvPr/>
+        </p:nvSpPr>
+        <p:spPr>
+          <a:xfrm>
+            <a:off x="0" y="0"/>
+            <a:ext cx="9144000" cy="109728"/>
+          </a:xfrm>
+          <a:prstGeom prst="rect">
+            <a:avLst/>
+          </a:prstGeom>
+          <a:solidFill>
+            <a:srgbClr val="173482"/>
+          </a:solidFill>
+          <a:ln>
+            <a:noFill/>
+          </a:ln>
+          <a:effectLst/>
+        </p:spPr>
+        <p:style>
+          <a:lnRef idx="1">
+            <a:schemeClr val="accent1"/>
+          </a:lnRef>
+          <a:fillRef idx="3">
+            <a:schemeClr val="accent1"/>
+          </a:fillRef>
+          <a:effectRef idx="2">
+            <a:schemeClr val="accent1"/>
+          </a:effectRef>
+          <a:fontRef idx="minor">
+            <a:schemeClr val="lt1"/>
+          </a:fontRef>
+        </p:style>
+        <p:txBody>
+          <a:bodyPr rtlCol="0" anchor="ctr"/>
+          <a:lstStyle/>
+          <a:p>
+            <a:pPr algn="ctr"/>
+          </a:p>
+        </p:txBody>
+      </p:sp>
+      <p:sp>
+        <p:nvSpPr>
+          <p:cNvPr id="3" name="TextBox 2"/>
           <p:cNvSpPr txBox="1"/>
           <p:nvPr/>
         </p:nvSpPr>
         <p:spPr>
           <a:xfrm>
-            <a:off x="8503920" y="4823460"/>
-            <a:ext cx="457200" cy="274320"/>
+            <a:off x="457200" y="256032"/>
+            <a:ext cx="8229600" cy="640080"/>
           </a:xfrm>
           <a:prstGeom prst="rect">
             <a:avLst/>
@@ -4057,6 +4435,175 @@
           </a:bodyPr>
           <a:lstStyle/>
           <a:p>
+            <a:pPr algn="l"/>
+            <a:r>
+              <a:rPr sz="2800" b="1" i="0">
+                <a:solidFill>
+                  <a:srgbClr val="173482"/>
+                </a:solidFill>
+                <a:latin typeface="Helvetica Neue"/>
+              </a:rPr>
+              <a:t>Summary</a:t>
+            </a:r>
+          </a:p>
+        </p:txBody>
+      </p:sp>
+      <p:sp>
+        <p:nvSpPr>
+          <p:cNvPr id="4" name="TextBox 3"/>
+          <p:cNvSpPr txBox="1"/>
+          <p:nvPr/>
+        </p:nvSpPr>
+        <p:spPr>
+          <a:xfrm>
+            <a:off x="548640" y="1188720"/>
+            <a:ext cx="8229600" cy="2743200"/>
+          </a:xfrm>
+          <a:prstGeom prst="rect">
+            <a:avLst/>
+          </a:prstGeom>
+          <a:noFill/>
+        </p:spPr>
+        <p:txBody>
+          <a:bodyPr wrap="square">
+            <a:spAutoFit/>
+          </a:bodyPr>
+          <a:lstStyle/>
+          <a:p>
+            <a:pPr>
+              <a:spcAft>
+                <a:spcPts val="800"/>
+              </a:spcAft>
+            </a:pPr>
+            <a:r>
+              <a:rPr sz="1600">
+                <a:solidFill>
+                  <a:srgbClr val="000000"/>
+                </a:solidFill>
+                <a:latin typeface="Helvetica Neue"/>
+              </a:rPr>
+              <a:t>•  Stablecoins = crypto pegged to $1 — tiny cross-exchange price gaps exist</a:t>
+            </a:r>
+          </a:p>
+          <a:p>
+            <a:pPr>
+              <a:spcAft>
+                <a:spcPts val="800"/>
+              </a:spcAft>
+            </a:pPr>
+            <a:r>
+              <a:rPr sz="1600">
+                <a:solidFill>
+                  <a:srgbClr val="000000"/>
+                </a:solidFill>
+                <a:latin typeface="Helvetica Neue"/>
+              </a:rPr>
+              <a:t>•  Model as a graph → arbitrage = finding a profitable cycle</a:t>
+            </a:r>
+          </a:p>
+          <a:p>
+            <a:pPr>
+              <a:spcAft>
+                <a:spcPts val="800"/>
+              </a:spcAft>
+            </a:pPr>
+            <a:r>
+              <a:rPr sz="1600">
+                <a:solidFill>
+                  <a:srgbClr val="000000"/>
+                </a:solidFill>
+                <a:latin typeface="Helvetica Neue"/>
+              </a:rPr>
+              <a:t>•  A* + slippage heuristic guides search toward deep, fast routes</a:t>
+            </a:r>
+          </a:p>
+          <a:p>
+            <a:pPr>
+              <a:spcAft>
+                <a:spcPts val="800"/>
+              </a:spcAft>
+            </a:pPr>
+            <a:r>
+              <a:rPr sz="1600">
+                <a:solidFill>
+                  <a:srgbClr val="000000"/>
+                </a:solidFill>
+                <a:latin typeface="Helvetica Neue"/>
+              </a:rPr>
+              <a:t>•  Same optimality as Dijkstra, but focused exploration</a:t>
+            </a:r>
+          </a:p>
+        </p:txBody>
+      </p:sp>
+      <p:sp>
+        <p:nvSpPr>
+          <p:cNvPr id="5" name="TextBox 4"/>
+          <p:cNvSpPr txBox="1"/>
+          <p:nvPr/>
+        </p:nvSpPr>
+        <p:spPr>
+          <a:xfrm>
+            <a:off x="548640" y="3657600"/>
+            <a:ext cx="8229600" cy="731520"/>
+          </a:xfrm>
+          <a:prstGeom prst="rect">
+            <a:avLst/>
+          </a:prstGeom>
+          <a:noFill/>
+        </p:spPr>
+        <p:txBody>
+          <a:bodyPr wrap="square">
+            <a:spAutoFit/>
+          </a:bodyPr>
+          <a:lstStyle/>
+          <a:p>
+            <a:pPr algn="l"/>
+            <a:r>
+              <a:rPr sz="1200" b="0" i="1">
+                <a:solidFill>
+                  <a:srgbClr val="595959"/>
+                </a:solidFill>
+                <a:latin typeface="Helvetica Neue"/>
+              </a:rPr>
+              <a:t>Code: scripts/animate_astar_search.py</a:t>
+            </a:r>
+          </a:p>
+          <a:p>
+            <a:pPr algn="l"/>
+            <a:r>
+              <a:rPr sz="1200" b="0" i="1">
+                <a:solidFill>
+                  <a:srgbClr val="595959"/>
+                </a:solidFill>
+                <a:latin typeface="Helvetica Neue"/>
+              </a:rPr>
+              <a:t>UI: streamlit run scripts/ui.py</a:t>
+            </a:r>
+          </a:p>
+        </p:txBody>
+      </p:sp>
+      <p:sp>
+        <p:nvSpPr>
+          <p:cNvPr id="6" name="TextBox 5"/>
+          <p:cNvSpPr txBox="1"/>
+          <p:nvPr/>
+        </p:nvSpPr>
+        <p:spPr>
+          <a:xfrm>
+            <a:off x="8503920" y="4823460"/>
+            <a:ext cx="457200" cy="274320"/>
+          </a:xfrm>
+          <a:prstGeom prst="rect">
+            <a:avLst/>
+          </a:prstGeom>
+          <a:noFill/>
+        </p:spPr>
+        <p:txBody>
+          <a:bodyPr wrap="square">
+            <a:spAutoFit/>
+          </a:bodyPr>
+          <a:lstStyle/>
+          <a:p>
             <a:pPr algn="r"/>
             <a:r>
               <a:rPr sz="1000" b="0" i="0">
@@ -4065,7 +4612,7 @@
                 </a:solidFill>
                 <a:latin typeface="Helvetica Neue"/>
               </a:rPr>
-              <a:t>12</a:t>
+              <a:t>15</a:t>
             </a:r>
           </a:p>
         </p:txBody>
@@ -4177,178 +4724,14 @@
       </p:sp>
       <p:sp>
         <p:nvSpPr>
-          <p:cNvPr id="4" name="TextBox 3"/>
-          <p:cNvSpPr txBox="1"/>
-          <p:nvPr/>
-        </p:nvSpPr>
-        <p:spPr>
-          <a:xfrm>
-            <a:off x="457200" y="749808"/>
-            <a:ext cx="8229600" cy="411480"/>
-          </a:xfrm>
-          <a:prstGeom prst="rect">
-            <a:avLst/>
-          </a:prstGeom>
-          <a:noFill/>
-        </p:spPr>
-        <p:txBody>
-          <a:bodyPr wrap="square">
-            <a:spAutoFit/>
-          </a:bodyPr>
-          <a:lstStyle/>
-          <a:p>
-            <a:pPr algn="l"/>
-            <a:r>
-              <a:rPr sz="1400" b="0" i="1">
-                <a:solidFill>
-                  <a:srgbClr val="595959"/>
-                </a:solidFill>
-                <a:latin typeface="Helvetica Neue"/>
-              </a:rPr>
-              <a:t>Digital assets that live on a blockchain</a:t>
-            </a:r>
-          </a:p>
-        </p:txBody>
-      </p:sp>
-      <p:sp>
-        <p:nvSpPr>
-          <p:cNvPr id="5" name="TextBox 4"/>
-          <p:cNvSpPr txBox="1"/>
-          <p:nvPr/>
-        </p:nvSpPr>
-        <p:spPr>
-          <a:xfrm>
-            <a:off x="548640" y="1280160"/>
-            <a:ext cx="5029200" cy="3474720"/>
-          </a:xfrm>
-          <a:prstGeom prst="rect">
-            <a:avLst/>
-          </a:prstGeom>
-          <a:noFill/>
-        </p:spPr>
-        <p:txBody>
-          <a:bodyPr wrap="square">
-            <a:spAutoFit/>
-          </a:bodyPr>
-          <a:lstStyle/>
-          <a:p>
-            <a:pPr>
-              <a:spcAft>
-                <a:spcPts val="800"/>
-              </a:spcAft>
-            </a:pPr>
-            <a:r>
-              <a:rPr sz="1400">
-                <a:solidFill>
-                  <a:srgbClr val="000000"/>
-                </a:solidFill>
-                <a:latin typeface="Helvetica Neue"/>
-              </a:rPr>
-              <a:t>•  Digital tokens stored on a distributed ledger (blockchain)</a:t>
-            </a:r>
-          </a:p>
-          <a:p>
-            <a:pPr>
-              <a:spcAft>
-                <a:spcPts val="800"/>
-              </a:spcAft>
-            </a:pPr>
-            <a:r>
-              <a:rPr sz="1400">
-                <a:solidFill>
-                  <a:srgbClr val="000000"/>
-                </a:solidFill>
-                <a:latin typeface="Helvetica Neue"/>
-              </a:rPr>
-              <a:t>•  Transactions are verified by a network of computers, not a bank</a:t>
-            </a:r>
-          </a:p>
-          <a:p>
-            <a:pPr>
-              <a:spcAft>
-                <a:spcPts val="800"/>
-              </a:spcAft>
-            </a:pPr>
-            <a:r>
-              <a:rPr sz="1400">
-                <a:solidFill>
-                  <a:srgbClr val="000000"/>
-                </a:solidFill>
-                <a:latin typeface="Helvetica Neue"/>
-              </a:rPr>
-              <a:t>•  Each transaction is signed cryptographically with your private key</a:t>
-            </a:r>
-          </a:p>
-          <a:p>
-            <a:pPr>
-              <a:spcAft>
-                <a:spcPts val="800"/>
-              </a:spcAft>
-            </a:pPr>
-            <a:r>
-              <a:rPr sz="1400">
-                <a:solidFill>
-                  <a:srgbClr val="000000"/>
-                </a:solidFill>
-                <a:latin typeface="Helvetica Neue"/>
-              </a:rPr>
-              <a:t>•  Once confirmed in a block, it’s immutable — can’t be reversed</a:t>
-            </a:r>
-          </a:p>
-          <a:p>
-            <a:pPr>
-              <a:spcAft>
-                <a:spcPts val="800"/>
-              </a:spcAft>
-            </a:pPr>
-            <a:r>
-              <a:rPr sz="1400">
-                <a:solidFill>
-                  <a:srgbClr val="000000"/>
-                </a:solidFill>
-                <a:latin typeface="Helvetica Neue"/>
-              </a:rPr>
-              <a:t>•  Anyone can run a node and verify the entire history</a:t>
-            </a:r>
-          </a:p>
-          <a:p>
-            <a:pPr>
-              <a:spcAft>
-                <a:spcPts val="800"/>
-              </a:spcAft>
-            </a:pPr>
-            <a:r>
-              <a:rPr sz="1400">
-                <a:solidFill>
-                  <a:srgbClr val="000000"/>
-                </a:solidFill>
-                <a:latin typeface="Helvetica Neue"/>
-              </a:rPr>
-              <a:t>•  Traded 24/7 on centralized exchanges (Binance, Kraken, etc.)</a:t>
-            </a:r>
-            <a:br/>
-            <a:r>
-              <a:rPr sz="1400">
-                <a:solidFill>
-                  <a:srgbClr val="000000"/>
-                </a:solidFill>
-                <a:latin typeface="Helvetica Neue"/>
-              </a:rPr>
-              <a:t>and decentralized exchanges (Uniswap, etc.)</a:t>
-            </a:r>
-          </a:p>
-        </p:txBody>
-      </p:sp>
-      <p:sp>
-        <p:nvSpPr>
-          <p:cNvPr id="6" name="Rounded Rectangle 5"/>
+          <p:cNvPr id="4" name="Rounded Rectangle 3"/>
           <p:cNvSpPr/>
           <p:nvPr/>
         </p:nvSpPr>
         <p:spPr>
           <a:xfrm>
-            <a:off x="5669280" y="1371600"/>
-            <a:ext cx="3200400" cy="3200400"/>
+            <a:off x="411480" y="1234440"/>
+            <a:ext cx="2651760" cy="2743200"/>
           </a:xfrm>
           <a:prstGeom prst="roundRect">
             <a:avLst/>
@@ -4385,14 +4768,14 @@
       </p:sp>
       <p:sp>
         <p:nvSpPr>
-          <p:cNvPr id="7" name="TextBox 6"/>
+          <p:cNvPr id="5" name="TextBox 4"/>
           <p:cNvSpPr txBox="1"/>
           <p:nvPr/>
         </p:nvSpPr>
         <p:spPr>
           <a:xfrm>
-            <a:off x="5852160" y="1463040"/>
-            <a:ext cx="2834640" cy="3017520"/>
+            <a:off x="548640" y="1371600"/>
+            <a:ext cx="2377440" cy="2468880"/>
           </a:xfrm>
           <a:prstGeom prst="rect">
             <a:avLst/>
@@ -4407,92 +4790,360 @@
           <a:p>
             <a:pPr algn="l"/>
             <a:r>
-              <a:rPr sz="1100" b="0" i="0">
+              <a:rPr sz="1300" b="0" i="0">
                 <a:solidFill>
                   <a:srgbClr val="000000"/>
                 </a:solidFill>
                 <a:latin typeface="Helvetica Neue"/>
               </a:rPr>
-              <a:t>How a transaction executes:</a:t>
-            </a:r>
-          </a:p>
-          <a:p>
-            <a:pPr algn="l"/>
-          </a:p>
-          <a:p>
-            <a:pPr algn="l"/>
-            <a:r>
-              <a:rPr sz="1100" b="0" i="0">
+              <a:t>Digital Assets</a:t>
+            </a:r>
+          </a:p>
+          <a:p>
+            <a:pPr algn="l"/>
+          </a:p>
+          <a:p>
+            <a:pPr algn="l"/>
+            <a:r>
+              <a:rPr sz="1300" b="0" i="0">
                 <a:solidFill>
                   <a:srgbClr val="000000"/>
                 </a:solidFill>
                 <a:latin typeface="Helvetica Neue"/>
               </a:rPr>
-              <a:t>1️⃣  You sign a TX with your key</a:t>
-            </a:r>
-          </a:p>
-          <a:p>
-            <a:pPr algn="l"/>
-          </a:p>
-          <a:p>
-            <a:pPr algn="l"/>
-            <a:r>
-              <a:rPr sz="1100" b="0" i="0">
+              <a:t>Tokens on a distributed</a:t>
+            </a:r>
+          </a:p>
+          <a:p>
+            <a:pPr algn="l"/>
+            <a:r>
+              <a:rPr sz="1300" b="0" i="0">
                 <a:solidFill>
                   <a:srgbClr val="000000"/>
                 </a:solidFill>
                 <a:latin typeface="Helvetica Neue"/>
               </a:rPr>
-              <a:t>2️⃣  TX broadcast to the network</a:t>
-            </a:r>
-          </a:p>
-          <a:p>
-            <a:pPr algn="l"/>
-          </a:p>
-          <a:p>
-            <a:pPr algn="l"/>
-            <a:r>
-              <a:rPr sz="1100" b="0" i="0">
+              <a:t>ledger — no bank needed.</a:t>
+            </a:r>
+          </a:p>
+          <a:p>
+            <a:pPr algn="l"/>
+          </a:p>
+          <a:p>
+            <a:pPr algn="l"/>
+            <a:r>
+              <a:rPr sz="1300" b="0" i="0">
                 <a:solidFill>
                   <a:srgbClr val="000000"/>
                 </a:solidFill>
                 <a:latin typeface="Helvetica Neue"/>
               </a:rPr>
-              <a:t>3️⃣  Miners/validators include it</a:t>
-            </a:r>
-          </a:p>
-          <a:p>
-            <a:pPr algn="l"/>
-            <a:r>
-              <a:rPr sz="1100" b="0" i="0">
+              <a:t>Traded 24/7 globally.</a:t>
+            </a:r>
+          </a:p>
+        </p:txBody>
+      </p:sp>
+      <p:sp>
+        <p:nvSpPr>
+          <p:cNvPr id="6" name="Rounded Rectangle 5"/>
+          <p:cNvSpPr/>
+          <p:nvPr/>
+        </p:nvSpPr>
+        <p:spPr>
+          <a:xfrm>
+            <a:off x="3246120" y="1234440"/>
+            <a:ext cx="2651760" cy="2743200"/>
+          </a:xfrm>
+          <a:prstGeom prst="roundRect">
+            <a:avLst/>
+          </a:prstGeom>
+          <a:solidFill>
+            <a:srgbClr val="B6E3EE"/>
+          </a:solidFill>
+          <a:ln>
+            <a:noFill/>
+          </a:ln>
+          <a:effectLst/>
+        </p:spPr>
+        <p:style>
+          <a:lnRef idx="1">
+            <a:schemeClr val="accent1"/>
+          </a:lnRef>
+          <a:fillRef idx="3">
+            <a:schemeClr val="accent1"/>
+          </a:fillRef>
+          <a:effectRef idx="2">
+            <a:schemeClr val="accent1"/>
+          </a:effectRef>
+          <a:fontRef idx="minor">
+            <a:schemeClr val="lt1"/>
+          </a:fontRef>
+        </p:style>
+        <p:txBody>
+          <a:bodyPr rtlCol="0" anchor="ctr"/>
+          <a:lstStyle/>
+          <a:p>
+            <a:pPr algn="ctr"/>
+          </a:p>
+        </p:txBody>
+      </p:sp>
+      <p:sp>
+        <p:nvSpPr>
+          <p:cNvPr id="7" name="TextBox 6"/>
+          <p:cNvSpPr txBox="1"/>
+          <p:nvPr/>
+        </p:nvSpPr>
+        <p:spPr>
+          <a:xfrm>
+            <a:off x="3383280" y="1371600"/>
+            <a:ext cx="2377440" cy="2468880"/>
+          </a:xfrm>
+          <a:prstGeom prst="rect">
+            <a:avLst/>
+          </a:prstGeom>
+          <a:noFill/>
+        </p:spPr>
+        <p:txBody>
+          <a:bodyPr wrap="square">
+            <a:spAutoFit/>
+          </a:bodyPr>
+          <a:lstStyle/>
+          <a:p>
+            <a:pPr algn="l"/>
+            <a:r>
+              <a:rPr sz="1300" b="0" i="0">
                 <a:solidFill>
                   <a:srgbClr val="000000"/>
                 </a:solidFill>
                 <a:latin typeface="Helvetica Neue"/>
               </a:rPr>
-              <a:t>     in the next block</a:t>
-            </a:r>
-          </a:p>
-          <a:p>
-            <a:pPr algn="l"/>
-          </a:p>
-          <a:p>
-            <a:pPr algn="l"/>
-            <a:r>
-              <a:rPr sz="1100" b="0" i="0">
+              <a:t>Blockchain Execution</a:t>
+            </a:r>
+          </a:p>
+          <a:p>
+            <a:pPr algn="l"/>
+          </a:p>
+          <a:p>
+            <a:pPr algn="l"/>
+            <a:r>
+              <a:rPr sz="1300" b="0" i="0">
                 <a:solidFill>
                   <a:srgbClr val="000000"/>
                 </a:solidFill>
                 <a:latin typeface="Helvetica Neue"/>
               </a:rPr>
-              <a:t>4️⃣  Block gets confirmed — done</a:t>
-            </a:r>
-          </a:p>
-        </p:txBody>
-      </p:sp>
-      <p:sp>
-        <p:nvSpPr>
-          <p:cNvPr id="8" name="TextBox 7"/>
+              <a:t>1. Sign TX with private key</a:t>
+            </a:r>
+          </a:p>
+          <a:p>
+            <a:pPr algn="l"/>
+            <a:r>
+              <a:rPr sz="1300" b="0" i="0">
+                <a:solidFill>
+                  <a:srgbClr val="000000"/>
+                </a:solidFill>
+                <a:latin typeface="Helvetica Neue"/>
+              </a:rPr>
+              <a:t>2. Broadcast to network</a:t>
+            </a:r>
+          </a:p>
+          <a:p>
+            <a:pPr algn="l"/>
+            <a:r>
+              <a:rPr sz="1300" b="0" i="0">
+                <a:solidFill>
+                  <a:srgbClr val="000000"/>
+                </a:solidFill>
+                <a:latin typeface="Helvetica Neue"/>
+              </a:rPr>
+              <a:t>3. Validator adds to block</a:t>
+            </a:r>
+          </a:p>
+          <a:p>
+            <a:pPr algn="l"/>
+            <a:r>
+              <a:rPr sz="1300" b="0" i="0">
+                <a:solidFill>
+                  <a:srgbClr val="000000"/>
+                </a:solidFill>
+                <a:latin typeface="Helvetica Neue"/>
+              </a:rPr>
+              <a:t>4. Confirmed — immutable</a:t>
+            </a:r>
+          </a:p>
+        </p:txBody>
+      </p:sp>
+      <p:sp>
+        <p:nvSpPr>
+          <p:cNvPr id="8" name="Rounded Rectangle 7"/>
+          <p:cNvSpPr/>
+          <p:nvPr/>
+        </p:nvSpPr>
+        <p:spPr>
+          <a:xfrm>
+            <a:off x="6080760" y="1234440"/>
+            <a:ext cx="2651760" cy="2743200"/>
+          </a:xfrm>
+          <a:prstGeom prst="roundRect">
+            <a:avLst/>
+          </a:prstGeom>
+          <a:solidFill>
+            <a:srgbClr val="173482"/>
+          </a:solidFill>
+          <a:ln>
+            <a:noFill/>
+          </a:ln>
+          <a:effectLst/>
+        </p:spPr>
+        <p:style>
+          <a:lnRef idx="1">
+            <a:schemeClr val="accent1"/>
+          </a:lnRef>
+          <a:fillRef idx="3">
+            <a:schemeClr val="accent1"/>
+          </a:fillRef>
+          <a:effectRef idx="2">
+            <a:schemeClr val="accent1"/>
+          </a:effectRef>
+          <a:fontRef idx="minor">
+            <a:schemeClr val="lt1"/>
+          </a:fontRef>
+        </p:style>
+        <p:txBody>
+          <a:bodyPr rtlCol="0" anchor="ctr"/>
+          <a:lstStyle/>
+          <a:p>
+            <a:pPr algn="ctr"/>
+          </a:p>
+        </p:txBody>
+      </p:sp>
+      <p:sp>
+        <p:nvSpPr>
+          <p:cNvPr id="9" name="TextBox 8"/>
+          <p:cNvSpPr txBox="1"/>
+          <p:nvPr/>
+        </p:nvSpPr>
+        <p:spPr>
+          <a:xfrm>
+            <a:off x="6217920" y="1371600"/>
+            <a:ext cx="2377440" cy="2468880"/>
+          </a:xfrm>
+          <a:prstGeom prst="rect">
+            <a:avLst/>
+          </a:prstGeom>
+          <a:noFill/>
+        </p:spPr>
+        <p:txBody>
+          <a:bodyPr wrap="square">
+            <a:spAutoFit/>
+          </a:bodyPr>
+          <a:lstStyle/>
+          <a:p>
+            <a:pPr algn="l"/>
+            <a:r>
+              <a:rPr sz="1300" b="0" i="0">
+                <a:solidFill>
+                  <a:srgbClr val="FFFFFF"/>
+                </a:solidFill>
+                <a:latin typeface="Helvetica Neue"/>
+              </a:rPr>
+              <a:t>Exchanges</a:t>
+            </a:r>
+          </a:p>
+          <a:p>
+            <a:pPr algn="l"/>
+          </a:p>
+          <a:p>
+            <a:pPr algn="l"/>
+            <a:r>
+              <a:rPr sz="1300" b="0" i="0">
+                <a:solidFill>
+                  <a:srgbClr val="FFFFFF"/>
+                </a:solidFill>
+                <a:latin typeface="Helvetica Neue"/>
+              </a:rPr>
+              <a:t>Binance, Kraken, Bybit,</a:t>
+            </a:r>
+          </a:p>
+          <a:p>
+            <a:pPr algn="l"/>
+            <a:r>
+              <a:rPr sz="1300" b="0" i="0">
+                <a:solidFill>
+                  <a:srgbClr val="FFFFFF"/>
+                </a:solidFill>
+                <a:latin typeface="Helvetica Neue"/>
+              </a:rPr>
+              <a:t>Coinbase, OKX, Gate.io</a:t>
+            </a:r>
+          </a:p>
+          <a:p>
+            <a:pPr algn="l"/>
+          </a:p>
+          <a:p>
+            <a:pPr algn="l"/>
+            <a:r>
+              <a:rPr sz="1300" b="0" i="0">
+                <a:solidFill>
+                  <a:srgbClr val="FFFFFF"/>
+                </a:solidFill>
+                <a:latin typeface="Helvetica Neue"/>
+              </a:rPr>
+              <a:t>Each runs its own</a:t>
+            </a:r>
+          </a:p>
+          <a:p>
+            <a:pPr algn="l"/>
+            <a:r>
+              <a:rPr sz="1300" b="0" i="0">
+                <a:solidFill>
+                  <a:srgbClr val="FFFFFF"/>
+                </a:solidFill>
+                <a:latin typeface="Helvetica Neue"/>
+              </a:rPr>
+              <a:t>order book independently.</a:t>
+            </a:r>
+          </a:p>
+        </p:txBody>
+      </p:sp>
+      <p:sp>
+        <p:nvSpPr>
+          <p:cNvPr id="10" name="TextBox 9"/>
+          <p:cNvSpPr txBox="1"/>
+          <p:nvPr/>
+        </p:nvSpPr>
+        <p:spPr>
+          <a:xfrm>
+            <a:off x="457200" y="4206240"/>
+            <a:ext cx="8229600" cy="457200"/>
+          </a:xfrm>
+          <a:prstGeom prst="rect">
+            <a:avLst/>
+          </a:prstGeom>
+          <a:noFill/>
+        </p:spPr>
+        <p:txBody>
+          <a:bodyPr wrap="square">
+            <a:spAutoFit/>
+          </a:bodyPr>
+          <a:lstStyle/>
+          <a:p>
+            <a:pPr algn="ctr"/>
+            <a:r>
+              <a:rPr sz="1300" b="0" i="1">
+                <a:solidFill>
+                  <a:srgbClr val="595959"/>
+                </a:solidFill>
+                <a:latin typeface="Helvetica Neue"/>
+              </a:rPr>
+              <a:t>Key insight: same asset can have different prices on different exchanges</a:t>
+            </a:r>
+          </a:p>
+        </p:txBody>
+      </p:sp>
+      <p:sp>
+        <p:nvSpPr>
+          <p:cNvPr id="11" name="TextBox 10"/>
           <p:cNvSpPr txBox="1"/>
           <p:nvPr/>
         </p:nvSpPr>
@@ -4625,7 +5276,7 @@
                 </a:solidFill>
                 <a:latin typeface="Helvetica Neue"/>
               </a:rPr>
-              <a:t>What are Stablecoins?</a:t>
+              <a:t>Stablecoins: The “Cash” of Crypto</a:t>
             </a:r>
           </a:p>
         </p:txBody>
@@ -4638,43 +5289,8 @@
         </p:nvSpPr>
         <p:spPr>
           <a:xfrm>
-            <a:off x="457200" y="749808"/>
-            <a:ext cx="8229600" cy="411480"/>
-          </a:xfrm>
-          <a:prstGeom prst="rect">
-            <a:avLst/>
-          </a:prstGeom>
-          <a:noFill/>
-        </p:spPr>
-        <p:txBody>
-          <a:bodyPr wrap="square">
-            <a:spAutoFit/>
-          </a:bodyPr>
-          <a:lstStyle/>
-          <a:p>
-            <a:pPr algn="l"/>
-            <a:r>
-              <a:rPr sz="1400" b="0" i="1">
-                <a:solidFill>
-                  <a:srgbClr val="595959"/>
-                </a:solidFill>
-                <a:latin typeface="Helvetica Neue"/>
-              </a:rPr>
-              <a:t>Crypto tokens pegged to fiat currency (usually $1 USD)</a:t>
-            </a:r>
-          </a:p>
-        </p:txBody>
-      </p:sp>
-      <p:sp>
-        <p:nvSpPr>
-          <p:cNvPr id="5" name="TextBox 4"/>
-          <p:cNvSpPr txBox="1"/>
-          <p:nvPr/>
-        </p:nvSpPr>
-        <p:spPr>
-          <a:xfrm>
-            <a:off x="548640" y="1280160"/>
-            <a:ext cx="5029200" cy="3474720"/>
+            <a:off x="548640" y="1188720"/>
+            <a:ext cx="4389120" cy="1828800"/>
           </a:xfrm>
           <a:prstGeom prst="rect">
             <a:avLst/>
@@ -4693,13 +5309,13 @@
               </a:spcAft>
             </a:pPr>
             <a:r>
-              <a:rPr sz="1400">
+              <a:rPr sz="1500">
                 <a:solidFill>
                   <a:srgbClr val="000000"/>
                 </a:solidFill>
                 <a:latin typeface="Helvetica Neue"/>
               </a:rPr>
-              <a:t>•  Designed to always be worth ~$1.00 USD</a:t>
+              <a:t>•  Crypto tokens pegged to $1.00 USD</a:t>
             </a:r>
           </a:p>
           <a:p>
@@ -4709,13 +5325,13 @@
               </a:spcAft>
             </a:pPr>
             <a:r>
-              <a:rPr sz="1400">
+              <a:rPr sz="1500">
                 <a:solidFill>
                   <a:srgbClr val="000000"/>
                 </a:solidFill>
                 <a:latin typeface="Helvetica Neue"/>
               </a:rPr>
-              <a:t>•  Backed by reserves: cash, treasuries, or algorithmic mechanisms</a:t>
+              <a:t>•  Backed by real reserves (cash, treasuries)</a:t>
             </a:r>
           </a:p>
           <a:p>
@@ -4725,85 +5341,141 @@
               </a:spcAft>
             </a:pPr>
             <a:r>
-              <a:rPr sz="1400">
+              <a:rPr sz="1500">
                 <a:solidFill>
                   <a:srgbClr val="000000"/>
                 </a:solidFill>
                 <a:latin typeface="Helvetica Neue"/>
               </a:rPr>
-              <a:t>•  Used as the “cash” of crypto — traders park profits here</a:t>
-            </a:r>
-          </a:p>
-          <a:p>
-            <a:pPr>
-              <a:spcAft>
-                <a:spcPts val="800"/>
-              </a:spcAft>
-            </a:pPr>
-            <a:r>
-              <a:rPr sz="1400">
+              <a:t>•  Multiple issuers → multiple prices</a:t>
+            </a:r>
+          </a:p>
+        </p:txBody>
+      </p:sp>
+      <p:sp>
+        <p:nvSpPr>
+          <p:cNvPr id="5" name="Rounded Rectangle 4"/>
+          <p:cNvSpPr/>
+          <p:nvPr/>
+        </p:nvSpPr>
+        <p:spPr>
+          <a:xfrm>
+            <a:off x="5029200" y="1188720"/>
+            <a:ext cx="3840480" cy="640080"/>
+          </a:xfrm>
+          <a:prstGeom prst="roundRect">
+            <a:avLst/>
+          </a:prstGeom>
+          <a:solidFill>
+            <a:srgbClr val="F6C344"/>
+          </a:solidFill>
+          <a:ln>
+            <a:noFill/>
+          </a:ln>
+          <a:effectLst/>
+        </p:spPr>
+        <p:style>
+          <a:lnRef idx="1">
+            <a:schemeClr val="accent1"/>
+          </a:lnRef>
+          <a:fillRef idx="3">
+            <a:schemeClr val="accent1"/>
+          </a:fillRef>
+          <a:effectRef idx="2">
+            <a:schemeClr val="accent1"/>
+          </a:effectRef>
+          <a:fontRef idx="minor">
+            <a:schemeClr val="lt1"/>
+          </a:fontRef>
+        </p:style>
+        <p:txBody>
+          <a:bodyPr rtlCol="0" anchor="ctr"/>
+          <a:lstStyle/>
+          <a:p>
+            <a:pPr algn="ctr"/>
+          </a:p>
+        </p:txBody>
+      </p:sp>
+      <p:sp>
+        <p:nvSpPr>
+          <p:cNvPr id="6" name="TextBox 5"/>
+          <p:cNvSpPr txBox="1"/>
+          <p:nvPr/>
+        </p:nvSpPr>
+        <p:spPr>
+          <a:xfrm>
+            <a:off x="5212080" y="1280160"/>
+            <a:ext cx="2560320" cy="457200"/>
+          </a:xfrm>
+          <a:prstGeom prst="rect">
+            <a:avLst/>
+          </a:prstGeom>
+          <a:noFill/>
+        </p:spPr>
+        <p:txBody>
+          <a:bodyPr wrap="square">
+            <a:spAutoFit/>
+          </a:bodyPr>
+          <a:lstStyle/>
+          <a:p>
+            <a:pPr algn="l"/>
+            <a:r>
+              <a:rPr sz="1300" b="1" i="0">
                 <a:solidFill>
                   <a:srgbClr val="000000"/>
                 </a:solidFill>
                 <a:latin typeface="Helvetica Neue"/>
               </a:rPr>
-              <a:t>•  Multiple competing stablecoins: USDT, USDC, DAI, FDUSD</a:t>
-            </a:r>
-          </a:p>
-          <a:p>
-            <a:pPr>
-              <a:spcAft>
-                <a:spcPts val="800"/>
-              </a:spcAft>
-            </a:pPr>
-            <a:r>
-              <a:rPr sz="1400">
-                <a:solidFill>
-                  <a:srgbClr val="000000"/>
-                </a:solidFill>
-                <a:latin typeface="Helvetica Neue"/>
-              </a:rPr>
-              <a:t>•  Each trades on many exchanges independently</a:t>
-            </a:r>
-          </a:p>
-          <a:p>
-            <a:pPr>
-              <a:spcAft>
-                <a:spcPts val="800"/>
-              </a:spcAft>
-            </a:pPr>
-            <a:r>
-              <a:rPr sz="1400">
-                <a:solidFill>
-                  <a:srgbClr val="000000"/>
-                </a:solidFill>
-                <a:latin typeface="Helvetica Neue"/>
-              </a:rPr>
-              <a:t>•  Price can deviate slightly from $1.00 per exchange</a:t>
-            </a:r>
-            <a:br/>
-            <a:r>
-              <a:rPr sz="1400">
-                <a:solidFill>
-                  <a:srgbClr val="000000"/>
-                </a:solidFill>
-                <a:latin typeface="Helvetica Neue"/>
-              </a:rPr>
-              <a:t>→ this is where arbitrage lives</a:t>
-            </a:r>
-          </a:p>
-        </p:txBody>
-      </p:sp>
-      <p:sp>
-        <p:nvSpPr>
-          <p:cNvPr id="6" name="Rounded Rectangle 5"/>
+              <a:t>USDT  (Tether)</a:t>
+            </a:r>
+          </a:p>
+        </p:txBody>
+      </p:sp>
+      <p:sp>
+        <p:nvSpPr>
+          <p:cNvPr id="7" name="TextBox 6"/>
+          <p:cNvSpPr txBox="1"/>
+          <p:nvPr/>
+        </p:nvSpPr>
+        <p:spPr>
+          <a:xfrm>
+            <a:off x="7772400" y="1280160"/>
+            <a:ext cx="914400" cy="457200"/>
+          </a:xfrm>
+          <a:prstGeom prst="rect">
+            <a:avLst/>
+          </a:prstGeom>
+          <a:noFill/>
+        </p:spPr>
+        <p:txBody>
+          <a:bodyPr wrap="square">
+            <a:spAutoFit/>
+          </a:bodyPr>
+          <a:lstStyle/>
+          <a:p>
+            <a:pPr algn="l"/>
+            <a:r>
+              <a:rPr sz="1400" b="1" i="0">
+                <a:solidFill>
+                  <a:srgbClr val="173482"/>
+                </a:solidFill>
+                <a:latin typeface="Helvetica Neue"/>
+              </a:rPr>
+              <a:t>$1.0001</a:t>
+            </a:r>
+          </a:p>
+        </p:txBody>
+      </p:sp>
+      <p:sp>
+        <p:nvSpPr>
+          <p:cNvPr id="8" name="Rounded Rectangle 7"/>
           <p:cNvSpPr/>
           <p:nvPr/>
         </p:nvSpPr>
         <p:spPr>
           <a:xfrm>
-            <a:off x="5669280" y="1371600"/>
-            <a:ext cx="3200400" cy="914400"/>
+            <a:off x="5029200" y="2057400"/>
+            <a:ext cx="3840480" cy="640080"/>
           </a:xfrm>
           <a:prstGeom prst="roundRect">
             <a:avLst/>
@@ -4840,14 +5512,14 @@
       </p:sp>
       <p:sp>
         <p:nvSpPr>
-          <p:cNvPr id="7" name="TextBox 6"/>
+          <p:cNvPr id="9" name="TextBox 8"/>
           <p:cNvSpPr txBox="1"/>
           <p:nvPr/>
         </p:nvSpPr>
         <p:spPr>
           <a:xfrm>
-            <a:off x="5852160" y="1463040"/>
-            <a:ext cx="2834640" cy="731520"/>
+            <a:off x="5212080" y="2148840"/>
+            <a:ext cx="2560320" cy="457200"/>
           </a:xfrm>
           <a:prstGeom prst="rect">
             <a:avLst/>
@@ -4862,45 +5534,68 @@
           <a:p>
             <a:pPr algn="l"/>
             <a:r>
-              <a:rPr sz="1100" b="0" i="0">
+              <a:rPr sz="1300" b="1" i="0">
                 <a:solidFill>
                   <a:srgbClr val="000000"/>
                 </a:solidFill>
                 <a:latin typeface="Helvetica Neue"/>
               </a:rPr>
-              <a:t>USDT (Tether) — $1.0001</a:t>
-            </a:r>
-          </a:p>
-          <a:p>
-            <a:pPr algn="l"/>
-            <a:r>
-              <a:rPr sz="1100" b="0" i="0">
-                <a:solidFill>
-                  <a:srgbClr val="000000"/>
-                </a:solidFill>
-                <a:latin typeface="Helvetica Neue"/>
-              </a:rPr>
-              <a:t>Backed by cash + treasuries</a:t>
-            </a:r>
-          </a:p>
-        </p:txBody>
-      </p:sp>
-      <p:sp>
-        <p:nvSpPr>
-          <p:cNvPr id="8" name="Rounded Rectangle 7"/>
+              <a:t>USDC  (Circle)</a:t>
+            </a:r>
+          </a:p>
+        </p:txBody>
+      </p:sp>
+      <p:sp>
+        <p:nvSpPr>
+          <p:cNvPr id="10" name="TextBox 9"/>
+          <p:cNvSpPr txBox="1"/>
+          <p:nvPr/>
+        </p:nvSpPr>
+        <p:spPr>
+          <a:xfrm>
+            <a:off x="7772400" y="2148840"/>
+            <a:ext cx="914400" cy="457200"/>
+          </a:xfrm>
+          <a:prstGeom prst="rect">
+            <a:avLst/>
+          </a:prstGeom>
+          <a:noFill/>
+        </p:spPr>
+        <p:txBody>
+          <a:bodyPr wrap="square">
+            <a:spAutoFit/>
+          </a:bodyPr>
+          <a:lstStyle/>
+          <a:p>
+            <a:pPr algn="l"/>
+            <a:r>
+              <a:rPr sz="1400" b="1" i="0">
+                <a:solidFill>
+                  <a:srgbClr val="173482"/>
+                </a:solidFill>
+                <a:latin typeface="Helvetica Neue"/>
+              </a:rPr>
+              <a:t>$0.9999</a:t>
+            </a:r>
+          </a:p>
+        </p:txBody>
+      </p:sp>
+      <p:sp>
+        <p:nvSpPr>
+          <p:cNvPr id="11" name="Rounded Rectangle 10"/>
           <p:cNvSpPr/>
           <p:nvPr/>
         </p:nvSpPr>
         <p:spPr>
           <a:xfrm>
-            <a:off x="5669280" y="2468880"/>
-            <a:ext cx="3200400" cy="914400"/>
+            <a:off x="5029200" y="2926080"/>
+            <a:ext cx="3840480" cy="640080"/>
           </a:xfrm>
           <a:prstGeom prst="roundRect">
             <a:avLst/>
           </a:prstGeom>
           <a:solidFill>
-            <a:srgbClr val="B6E3EE"/>
+            <a:srgbClr val="EAF8F2"/>
           </a:solidFill>
           <a:ln>
             <a:noFill/>
@@ -4931,14 +5626,14 @@
       </p:sp>
       <p:sp>
         <p:nvSpPr>
-          <p:cNvPr id="9" name="TextBox 8"/>
+          <p:cNvPr id="12" name="TextBox 11"/>
           <p:cNvSpPr txBox="1"/>
           <p:nvPr/>
         </p:nvSpPr>
         <p:spPr>
           <a:xfrm>
-            <a:off x="5852160" y="2560320"/>
-            <a:ext cx="2834640" cy="731520"/>
+            <a:off x="5212080" y="3017520"/>
+            <a:ext cx="2560320" cy="457200"/>
           </a:xfrm>
           <a:prstGeom prst="rect">
             <a:avLst/>
@@ -4953,45 +5648,68 @@
           <a:p>
             <a:pPr algn="l"/>
             <a:r>
-              <a:rPr sz="1100" b="0" i="0">
+              <a:rPr sz="1300" b="1" i="0">
                 <a:solidFill>
                   <a:srgbClr val="000000"/>
                 </a:solidFill>
                 <a:latin typeface="Helvetica Neue"/>
               </a:rPr>
-              <a:t>USDC (Circle) — $0.9999</a:t>
-            </a:r>
-          </a:p>
-          <a:p>
-            <a:pPr algn="l"/>
-            <a:r>
-              <a:rPr sz="1100" b="0" i="0">
-                <a:solidFill>
-                  <a:srgbClr val="000000"/>
-                </a:solidFill>
-                <a:latin typeface="Helvetica Neue"/>
-              </a:rPr>
-              <a:t>Backed by cash + short-term bonds</a:t>
-            </a:r>
-          </a:p>
-        </p:txBody>
-      </p:sp>
-      <p:sp>
-        <p:nvSpPr>
-          <p:cNvPr id="10" name="Rounded Rectangle 9"/>
+              <a:t>DAI    (Maker)</a:t>
+            </a:r>
+          </a:p>
+        </p:txBody>
+      </p:sp>
+      <p:sp>
+        <p:nvSpPr>
+          <p:cNvPr id="13" name="TextBox 12"/>
+          <p:cNvSpPr txBox="1"/>
+          <p:nvPr/>
+        </p:nvSpPr>
+        <p:spPr>
+          <a:xfrm>
+            <a:off x="7772400" y="3017520"/>
+            <a:ext cx="914400" cy="457200"/>
+          </a:xfrm>
+          <a:prstGeom prst="rect">
+            <a:avLst/>
+          </a:prstGeom>
+          <a:noFill/>
+        </p:spPr>
+        <p:txBody>
+          <a:bodyPr wrap="square">
+            <a:spAutoFit/>
+          </a:bodyPr>
+          <a:lstStyle/>
+          <a:p>
+            <a:pPr algn="l"/>
+            <a:r>
+              <a:rPr sz="1400" b="1" i="0">
+                <a:solidFill>
+                  <a:srgbClr val="173482"/>
+                </a:solidFill>
+                <a:latin typeface="Helvetica Neue"/>
+              </a:rPr>
+              <a:t>$0.9997</a:t>
+            </a:r>
+          </a:p>
+        </p:txBody>
+      </p:sp>
+      <p:sp>
+        <p:nvSpPr>
+          <p:cNvPr id="14" name="Rounded Rectangle 13"/>
           <p:cNvSpPr/>
           <p:nvPr/>
         </p:nvSpPr>
         <p:spPr>
           <a:xfrm>
-            <a:off x="5669280" y="3566160"/>
-            <a:ext cx="3200400" cy="914400"/>
+            <a:off x="5029200" y="3794759"/>
+            <a:ext cx="3840480" cy="640080"/>
           </a:xfrm>
           <a:prstGeom prst="roundRect">
             <a:avLst/>
           </a:prstGeom>
           <a:solidFill>
-            <a:srgbClr val="B6E3EE"/>
+            <a:srgbClr val="EEEEEE"/>
           </a:solidFill>
           <a:ln>
             <a:noFill/>
@@ -5022,14 +5740,14 @@
       </p:sp>
       <p:sp>
         <p:nvSpPr>
-          <p:cNvPr id="11" name="TextBox 10"/>
+          <p:cNvPr id="15" name="TextBox 14"/>
           <p:cNvSpPr txBox="1"/>
           <p:nvPr/>
         </p:nvSpPr>
         <p:spPr>
           <a:xfrm>
-            <a:off x="5852160" y="3657600"/>
-            <a:ext cx="2834640" cy="731520"/>
+            <a:off x="5212080" y="3886199"/>
+            <a:ext cx="2560320" cy="457200"/>
           </a:xfrm>
           <a:prstGeom prst="rect">
             <a:avLst/>
@@ -5044,32 +5762,90 @@
           <a:p>
             <a:pPr algn="l"/>
             <a:r>
-              <a:rPr sz="1100" b="0" i="0">
+              <a:rPr sz="1300" b="1" i="0">
                 <a:solidFill>
                   <a:srgbClr val="000000"/>
                 </a:solidFill>
                 <a:latin typeface="Helvetica Neue"/>
               </a:rPr>
-              <a:t>DAI (MakerDAO) — $0.9997</a:t>
-            </a:r>
-          </a:p>
-          <a:p>
-            <a:pPr algn="l"/>
-            <a:r>
-              <a:rPr sz="1100" b="0" i="0">
-                <a:solidFill>
-                  <a:srgbClr val="000000"/>
-                </a:solidFill>
-                <a:latin typeface="Helvetica Neue"/>
-              </a:rPr>
-              <a:t>Algorithmic + over-collateralized</a:t>
-            </a:r>
-          </a:p>
-        </p:txBody>
-      </p:sp>
-      <p:sp>
-        <p:nvSpPr>
-          <p:cNvPr id="12" name="TextBox 11"/>
+              <a:t>FDUSD (Binance)</a:t>
+            </a:r>
+          </a:p>
+        </p:txBody>
+      </p:sp>
+      <p:sp>
+        <p:nvSpPr>
+          <p:cNvPr id="16" name="TextBox 15"/>
+          <p:cNvSpPr txBox="1"/>
+          <p:nvPr/>
+        </p:nvSpPr>
+        <p:spPr>
+          <a:xfrm>
+            <a:off x="7772400" y="3886199"/>
+            <a:ext cx="914400" cy="457200"/>
+          </a:xfrm>
+          <a:prstGeom prst="rect">
+            <a:avLst/>
+          </a:prstGeom>
+          <a:noFill/>
+        </p:spPr>
+        <p:txBody>
+          <a:bodyPr wrap="square">
+            <a:spAutoFit/>
+          </a:bodyPr>
+          <a:lstStyle/>
+          <a:p>
+            <a:pPr algn="l"/>
+            <a:r>
+              <a:rPr sz="1400" b="1" i="0">
+                <a:solidFill>
+                  <a:srgbClr val="173482"/>
+                </a:solidFill>
+                <a:latin typeface="Helvetica Neue"/>
+              </a:rPr>
+              <a:t>$0.9988</a:t>
+            </a:r>
+          </a:p>
+        </p:txBody>
+      </p:sp>
+      <p:sp>
+        <p:nvSpPr>
+          <p:cNvPr id="17" name="TextBox 16"/>
+          <p:cNvSpPr txBox="1"/>
+          <p:nvPr/>
+        </p:nvSpPr>
+        <p:spPr>
+          <a:xfrm>
+            <a:off x="457200" y="4297680"/>
+            <a:ext cx="8229600" cy="457200"/>
+          </a:xfrm>
+          <a:prstGeom prst="rect">
+            <a:avLst/>
+          </a:prstGeom>
+          <a:noFill/>
+        </p:spPr>
+        <p:txBody>
+          <a:bodyPr wrap="square">
+            <a:spAutoFit/>
+          </a:bodyPr>
+          <a:lstStyle/>
+          <a:p>
+            <a:pPr algn="ctr"/>
+            <a:r>
+              <a:rPr sz="1300" b="0" i="1">
+                <a:solidFill>
+                  <a:srgbClr val="595959"/>
+                </a:solidFill>
+                <a:latin typeface="Helvetica Neue"/>
+              </a:rPr>
+              <a:t>These tiny deviations from $1.00 across exchanges = our arbitrage signal</a:t>
+            </a:r>
+          </a:p>
+        </p:txBody>
+      </p:sp>
+      <p:sp>
+        <p:nvSpPr>
+          <p:cNvPr id="18" name="TextBox 17"/>
           <p:cNvSpPr txBox="1"/>
           <p:nvPr/>
         </p:nvSpPr>
@@ -5202,7 +5978,7 @@
                 </a:solidFill>
                 <a:latin typeface="Helvetica Neue"/>
               </a:rPr>
-              <a:t>The Arbitrage Opportunity</a:t>
+              <a:t>How Do They Stay at $1.00?</a:t>
             </a:r>
           </a:p>
         </p:txBody>
@@ -5237,21 +6013,65 @@
                 </a:solidFill>
                 <a:latin typeface="Helvetica Neue"/>
               </a:rPr>
-              <a:t>Same coin, different exchanges, different prices → profit</a:t>
-            </a:r>
-          </a:p>
-        </p:txBody>
-      </p:sp>
-      <p:sp>
-        <p:nvSpPr>
-          <p:cNvPr id="5" name="TextBox 4"/>
+              <a:t>Three pegging mechanisms</a:t>
+            </a:r>
+          </a:p>
+        </p:txBody>
+      </p:sp>
+      <p:sp>
+        <p:nvSpPr>
+          <p:cNvPr id="5" name="Rounded Rectangle 4"/>
+          <p:cNvSpPr/>
+          <p:nvPr/>
+        </p:nvSpPr>
+        <p:spPr>
+          <a:xfrm>
+            <a:off x="411480" y="1280160"/>
+            <a:ext cx="2651760" cy="2560320"/>
+          </a:xfrm>
+          <a:prstGeom prst="roundRect">
+            <a:avLst/>
+          </a:prstGeom>
+          <a:solidFill>
+            <a:srgbClr val="EAF8F2"/>
+          </a:solidFill>
+          <a:ln>
+            <a:noFill/>
+          </a:ln>
+          <a:effectLst/>
+        </p:spPr>
+        <p:style>
+          <a:lnRef idx="1">
+            <a:schemeClr val="accent1"/>
+          </a:lnRef>
+          <a:fillRef idx="3">
+            <a:schemeClr val="accent1"/>
+          </a:fillRef>
+          <a:effectRef idx="2">
+            <a:schemeClr val="accent1"/>
+          </a:effectRef>
+          <a:fontRef idx="minor">
+            <a:schemeClr val="lt1"/>
+          </a:fontRef>
+        </p:style>
+        <p:txBody>
+          <a:bodyPr rtlCol="0" anchor="ctr"/>
+          <a:lstStyle/>
+          <a:p>
+            <a:pPr algn="ctr"/>
+          </a:p>
+        </p:txBody>
+      </p:sp>
+      <p:sp>
+        <p:nvSpPr>
+          <p:cNvPr id="6" name="TextBox 5"/>
           <p:cNvSpPr txBox="1"/>
           <p:nvPr/>
         </p:nvSpPr>
         <p:spPr>
           <a:xfrm>
-            <a:off x="548640" y="1280160"/>
-            <a:ext cx="8229600" cy="3474720"/>
+            <a:off x="548640" y="1371600"/>
+            <a:ext cx="2377440" cy="2377440"/>
           </a:xfrm>
           <a:prstGeom prst="rect">
             <a:avLst/>
@@ -5264,116 +6084,357 @@
           </a:bodyPr>
           <a:lstStyle/>
           <a:p>
-            <a:pPr>
-              <a:spcAft>
-                <a:spcPts val="800"/>
-              </a:spcAft>
-            </a:pPr>
-            <a:r>
-              <a:rPr sz="1400">
+            <a:pPr algn="l"/>
+            <a:r>
+              <a:rPr sz="1200" b="0" i="0">
                 <a:solidFill>
                   <a:srgbClr val="000000"/>
                 </a:solidFill>
                 <a:latin typeface="Helvetica Neue"/>
               </a:rPr>
-              <a:t>•  USDC on Binance: $1.00013   |   USDC on Kraken: $0.99990</a:t>
-            </a:r>
-          </a:p>
-          <a:p>
-            <a:pPr>
-              <a:spcAft>
-                <a:spcPts val="800"/>
-              </a:spcAft>
-            </a:pPr>
-            <a:r>
-              <a:rPr sz="1400">
+              <a:t>Fiat-Backed</a:t>
+            </a:r>
+          </a:p>
+          <a:p>
+            <a:pPr algn="l"/>
+            <a:r>
+              <a:rPr sz="1200" b="0" i="0">
                 <a:solidFill>
                   <a:srgbClr val="000000"/>
                 </a:solidFill>
                 <a:latin typeface="Helvetica Neue"/>
               </a:rPr>
-              <a:t>•  Spread = 2.3 basis points (bps) — small but real with volume</a:t>
-            </a:r>
-          </a:p>
-          <a:p>
-            <a:pPr>
-              <a:spcAft>
-                <a:spcPts val="800"/>
-              </a:spcAft>
-            </a:pPr>
-            <a:r>
-              <a:rPr sz="1400">
+              <a:t>(USDT, USDC)</a:t>
+            </a:r>
+          </a:p>
+          <a:p>
+            <a:pPr algn="l"/>
+          </a:p>
+          <a:p>
+            <a:pPr algn="l"/>
+            <a:r>
+              <a:rPr sz="1200" b="0" i="0">
                 <a:solidFill>
                   <a:srgbClr val="000000"/>
                 </a:solidFill>
                 <a:latin typeface="Helvetica Neue"/>
               </a:rPr>
-              <a:t>•  Buy cheap on Kraken → transfer to Binance → sell high</a:t>
-            </a:r>
-          </a:p>
-          <a:p>
-            <a:pPr>
-              <a:spcAft>
-                <a:spcPts val="800"/>
-              </a:spcAft>
-            </a:pPr>
-            <a:r>
-              <a:rPr sz="1400">
+              <a:t>1:1 reserve of USD in</a:t>
+            </a:r>
+          </a:p>
+          <a:p>
+            <a:pPr algn="l"/>
+            <a:r>
+              <a:rPr sz="1200" b="0" i="0">
                 <a:solidFill>
                   <a:srgbClr val="000000"/>
                 </a:solidFill>
                 <a:latin typeface="Helvetica Neue"/>
               </a:rPr>
-              <a:t>•  Must account for: trading fees, withdrawal fees, transfer time, slippage</a:t>
-            </a:r>
-          </a:p>
-          <a:p>
-            <a:pPr>
-              <a:spcAft>
-                <a:spcPts val="800"/>
-              </a:spcAft>
-            </a:pPr>
-            <a:r>
-              <a:rPr sz="1400">
+              <a:t>bank accounts + T-bills.</a:t>
+            </a:r>
+          </a:p>
+          <a:p>
+            <a:pPr algn="l"/>
+            <a:r>
+              <a:rPr sz="1200" b="0" i="0">
                 <a:solidFill>
                   <a:srgbClr val="000000"/>
                 </a:solidFill>
                 <a:latin typeface="Helvetica Neue"/>
               </a:rPr>
-              <a:t>•  Question: with 5 exchanges × 4 stablecoins = 20+ nodes and 40+ edges,</a:t>
-            </a:r>
-            <a:br/>
-            <a:r>
-              <a:rPr sz="1400">
+              <a:t>Redeem anytime for $1.</a:t>
+            </a:r>
+          </a:p>
+        </p:txBody>
+      </p:sp>
+      <p:sp>
+        <p:nvSpPr>
+          <p:cNvPr id="7" name="Rounded Rectangle 6"/>
+          <p:cNvSpPr/>
+          <p:nvPr/>
+        </p:nvSpPr>
+        <p:spPr>
+          <a:xfrm>
+            <a:off x="3246120" y="1280160"/>
+            <a:ext cx="2651760" cy="2560320"/>
+          </a:xfrm>
+          <a:prstGeom prst="roundRect">
+            <a:avLst/>
+          </a:prstGeom>
+          <a:solidFill>
+            <a:srgbClr val="B6E3EE"/>
+          </a:solidFill>
+          <a:ln>
+            <a:noFill/>
+          </a:ln>
+          <a:effectLst/>
+        </p:spPr>
+        <p:style>
+          <a:lnRef idx="1">
+            <a:schemeClr val="accent1"/>
+          </a:lnRef>
+          <a:fillRef idx="3">
+            <a:schemeClr val="accent1"/>
+          </a:fillRef>
+          <a:effectRef idx="2">
+            <a:schemeClr val="accent1"/>
+          </a:effectRef>
+          <a:fontRef idx="minor">
+            <a:schemeClr val="lt1"/>
+          </a:fontRef>
+        </p:style>
+        <p:txBody>
+          <a:bodyPr rtlCol="0" anchor="ctr"/>
+          <a:lstStyle/>
+          <a:p>
+            <a:pPr algn="ctr"/>
+          </a:p>
+        </p:txBody>
+      </p:sp>
+      <p:sp>
+        <p:nvSpPr>
+          <p:cNvPr id="8" name="TextBox 7"/>
+          <p:cNvSpPr txBox="1"/>
+          <p:nvPr/>
+        </p:nvSpPr>
+        <p:spPr>
+          <a:xfrm>
+            <a:off x="3383280" y="1371600"/>
+            <a:ext cx="2377440" cy="2377440"/>
+          </a:xfrm>
+          <a:prstGeom prst="rect">
+            <a:avLst/>
+          </a:prstGeom>
+          <a:noFill/>
+        </p:spPr>
+        <p:txBody>
+          <a:bodyPr wrap="square">
+            <a:spAutoFit/>
+          </a:bodyPr>
+          <a:lstStyle/>
+          <a:p>
+            <a:pPr algn="l"/>
+            <a:r>
+              <a:rPr sz="1200" b="0" i="0">
                 <a:solidFill>
                   <a:srgbClr val="000000"/>
                 </a:solidFill>
                 <a:latin typeface="Helvetica Neue"/>
               </a:rPr>
-              <a:t>how do we find the cheapest profitable cycle?</a:t>
-            </a:r>
-          </a:p>
-          <a:p>
-            <a:pPr>
-              <a:spcAft>
-                <a:spcPts val="800"/>
-              </a:spcAft>
-            </a:pPr>
-            <a:r>
-              <a:rPr sz="1400">
+              <a:t>Over-Collateralized</a:t>
+            </a:r>
+          </a:p>
+          <a:p>
+            <a:pPr algn="l"/>
+            <a:r>
+              <a:rPr sz="1200" b="0" i="0">
                 <a:solidFill>
                   <a:srgbClr val="000000"/>
                 </a:solidFill>
                 <a:latin typeface="Helvetica Neue"/>
               </a:rPr>
-              <a:t>•  Answer: model it as a graph problem and use path-finding algorithms</a:t>
-            </a:r>
-          </a:p>
-        </p:txBody>
-      </p:sp>
-      <p:sp>
-        <p:nvSpPr>
-          <p:cNvPr id="6" name="TextBox 5"/>
+              <a:t>(DAI)</a:t>
+            </a:r>
+          </a:p>
+          <a:p>
+            <a:pPr algn="l"/>
+          </a:p>
+          <a:p>
+            <a:pPr algn="l"/>
+            <a:r>
+              <a:rPr sz="1200" b="0" i="0">
+                <a:solidFill>
+                  <a:srgbClr val="000000"/>
+                </a:solidFill>
+                <a:latin typeface="Helvetica Neue"/>
+              </a:rPr>
+              <a:t>Lock $1.50 of ETH to</a:t>
+            </a:r>
+          </a:p>
+          <a:p>
+            <a:pPr algn="l"/>
+            <a:r>
+              <a:rPr sz="1200" b="0" i="0">
+                <a:solidFill>
+                  <a:srgbClr val="000000"/>
+                </a:solidFill>
+                <a:latin typeface="Helvetica Neue"/>
+              </a:rPr>
+              <a:t>mint $1.00 of DAI.</a:t>
+            </a:r>
+          </a:p>
+          <a:p>
+            <a:pPr algn="l"/>
+            <a:r>
+              <a:rPr sz="1200" b="0" i="0">
+                <a:solidFill>
+                  <a:srgbClr val="000000"/>
+                </a:solidFill>
+                <a:latin typeface="Helvetica Neue"/>
+              </a:rPr>
+              <a:t>Auto-liquidates if</a:t>
+            </a:r>
+          </a:p>
+          <a:p>
+            <a:pPr algn="l"/>
+            <a:r>
+              <a:rPr sz="1200" b="0" i="0">
+                <a:solidFill>
+                  <a:srgbClr val="000000"/>
+                </a:solidFill>
+                <a:latin typeface="Helvetica Neue"/>
+              </a:rPr>
+              <a:t>collateral drops.</a:t>
+            </a:r>
+          </a:p>
+        </p:txBody>
+      </p:sp>
+      <p:sp>
+        <p:nvSpPr>
+          <p:cNvPr id="9" name="Rounded Rectangle 8"/>
+          <p:cNvSpPr/>
+          <p:nvPr/>
+        </p:nvSpPr>
+        <p:spPr>
+          <a:xfrm>
+            <a:off x="6080760" y="1280160"/>
+            <a:ext cx="2651760" cy="2560320"/>
+          </a:xfrm>
+          <a:prstGeom prst="roundRect">
+            <a:avLst/>
+          </a:prstGeom>
+          <a:solidFill>
+            <a:srgbClr val="173482"/>
+          </a:solidFill>
+          <a:ln>
+            <a:noFill/>
+          </a:ln>
+          <a:effectLst/>
+        </p:spPr>
+        <p:style>
+          <a:lnRef idx="1">
+            <a:schemeClr val="accent1"/>
+          </a:lnRef>
+          <a:fillRef idx="3">
+            <a:schemeClr val="accent1"/>
+          </a:fillRef>
+          <a:effectRef idx="2">
+            <a:schemeClr val="accent1"/>
+          </a:effectRef>
+          <a:fontRef idx="minor">
+            <a:schemeClr val="lt1"/>
+          </a:fontRef>
+        </p:style>
+        <p:txBody>
+          <a:bodyPr rtlCol="0" anchor="ctr"/>
+          <a:lstStyle/>
+          <a:p>
+            <a:pPr algn="ctr"/>
+          </a:p>
+        </p:txBody>
+      </p:sp>
+      <p:sp>
+        <p:nvSpPr>
+          <p:cNvPr id="10" name="TextBox 9"/>
+          <p:cNvSpPr txBox="1"/>
+          <p:nvPr/>
+        </p:nvSpPr>
+        <p:spPr>
+          <a:xfrm>
+            <a:off x="6217920" y="1371600"/>
+            <a:ext cx="2377440" cy="2377440"/>
+          </a:xfrm>
+          <a:prstGeom prst="rect">
+            <a:avLst/>
+          </a:prstGeom>
+          <a:noFill/>
+        </p:spPr>
+        <p:txBody>
+          <a:bodyPr wrap="square">
+            <a:spAutoFit/>
+          </a:bodyPr>
+          <a:lstStyle/>
+          <a:p>
+            <a:pPr algn="l"/>
+            <a:r>
+              <a:rPr sz="1200" b="0" i="0">
+                <a:solidFill>
+                  <a:srgbClr val="FFFFFF"/>
+                </a:solidFill>
+                <a:latin typeface="Helvetica Neue"/>
+              </a:rPr>
+              <a:t>Algorithmic</a:t>
+            </a:r>
+          </a:p>
+          <a:p>
+            <a:pPr algn="l"/>
+            <a:r>
+              <a:rPr sz="1200" b="0" i="0">
+                <a:solidFill>
+                  <a:srgbClr val="FFFFFF"/>
+                </a:solidFill>
+                <a:latin typeface="Helvetica Neue"/>
+              </a:rPr>
+              <a:t>(historical)</a:t>
+            </a:r>
+          </a:p>
+          <a:p>
+            <a:pPr algn="l"/>
+          </a:p>
+          <a:p>
+            <a:pPr algn="l"/>
+            <a:r>
+              <a:rPr sz="1200" b="0" i="0">
+                <a:solidFill>
+                  <a:srgbClr val="FFFFFF"/>
+                </a:solidFill>
+                <a:latin typeface="Helvetica Neue"/>
+              </a:rPr>
+              <a:t>Expand/contract supply</a:t>
+            </a:r>
+          </a:p>
+          <a:p>
+            <a:pPr algn="l"/>
+            <a:r>
+              <a:rPr sz="1200" b="0" i="0">
+                <a:solidFill>
+                  <a:srgbClr val="FFFFFF"/>
+                </a:solidFill>
+                <a:latin typeface="Helvetica Neue"/>
+              </a:rPr>
+              <a:t>to maintain peg.</a:t>
+            </a:r>
+          </a:p>
+          <a:p>
+            <a:pPr algn="l"/>
+            <a:r>
+              <a:rPr sz="1200" b="0" i="0">
+                <a:solidFill>
+                  <a:srgbClr val="FFFFFF"/>
+                </a:solidFill>
+                <a:latin typeface="Helvetica Neue"/>
+              </a:rPr>
+              <a:t>High risk — UST</a:t>
+            </a:r>
+          </a:p>
+          <a:p>
+            <a:pPr algn="l"/>
+            <a:r>
+              <a:rPr sz="1200" b="0" i="0">
+                <a:solidFill>
+                  <a:srgbClr val="FFFFFF"/>
+                </a:solidFill>
+                <a:latin typeface="Helvetica Neue"/>
+              </a:rPr>
+              <a:t>collapsed in 2022.</a:t>
+            </a:r>
+          </a:p>
+        </p:txBody>
+      </p:sp>
+      <p:sp>
+        <p:nvSpPr>
+          <p:cNvPr id="11" name="TextBox 10"/>
           <p:cNvSpPr txBox="1"/>
           <p:nvPr/>
         </p:nvSpPr>
@@ -5506,21 +6567,65 @@
                 </a:solidFill>
                 <a:latin typeface="Helvetica Neue"/>
               </a:rPr>
-              <a:t>Modelling as a Weighted Directed Graph</a:t>
-            </a:r>
-          </a:p>
-        </p:txBody>
-      </p:sp>
-      <p:sp>
-        <p:nvSpPr>
-          <p:cNvPr id="4" name="TextBox 3"/>
+              <a:t>The Arbitrage Opportunity</a:t>
+            </a:r>
+          </a:p>
+        </p:txBody>
+      </p:sp>
+      <p:sp>
+        <p:nvSpPr>
+          <p:cNvPr id="4" name="Rounded Rectangle 3"/>
+          <p:cNvSpPr/>
+          <p:nvPr/>
+        </p:nvSpPr>
+        <p:spPr>
+          <a:xfrm>
+            <a:off x="457200" y="1188720"/>
+            <a:ext cx="3840480" cy="1371600"/>
+          </a:xfrm>
+          <a:prstGeom prst="roundRect">
+            <a:avLst/>
+          </a:prstGeom>
+          <a:solidFill>
+            <a:srgbClr val="EAF8F2"/>
+          </a:solidFill>
+          <a:ln>
+            <a:noFill/>
+          </a:ln>
+          <a:effectLst/>
+        </p:spPr>
+        <p:style>
+          <a:lnRef idx="1">
+            <a:schemeClr val="accent1"/>
+          </a:lnRef>
+          <a:fillRef idx="3">
+            <a:schemeClr val="accent1"/>
+          </a:fillRef>
+          <a:effectRef idx="2">
+            <a:schemeClr val="accent1"/>
+          </a:effectRef>
+          <a:fontRef idx="minor">
+            <a:schemeClr val="lt1"/>
+          </a:fontRef>
+        </p:style>
+        <p:txBody>
+          <a:bodyPr rtlCol="0" anchor="ctr"/>
+          <a:lstStyle/>
+          <a:p>
+            <a:pPr algn="ctr"/>
+          </a:p>
+        </p:txBody>
+      </p:sp>
+      <p:sp>
+        <p:nvSpPr>
+          <p:cNvPr id="5" name="TextBox 4"/>
           <p:cNvSpPr txBox="1"/>
           <p:nvPr/>
         </p:nvSpPr>
         <p:spPr>
           <a:xfrm>
-            <a:off x="457200" y="749808"/>
-            <a:ext cx="8229600" cy="411480"/>
+            <a:off x="640080" y="1280160"/>
+            <a:ext cx="3474720" cy="1188720"/>
           </a:xfrm>
           <a:prstGeom prst="rect">
             <a:avLst/>
@@ -5535,27 +6640,95 @@
           <a:p>
             <a:pPr algn="l"/>
             <a:r>
-              <a:rPr sz="1400" b="0" i="1">
-                <a:solidFill>
-                  <a:srgbClr val="595959"/>
-                </a:solidFill>
-                <a:latin typeface="Helvetica Neue"/>
-              </a:rPr>
-              <a:t>Nodes = (exchange, coin) pairs    Edges = trades or transfers</a:t>
-            </a:r>
-          </a:p>
-        </p:txBody>
-      </p:sp>
-      <p:sp>
-        <p:nvSpPr>
-          <p:cNvPr id="5" name="TextBox 4"/>
+              <a:rPr sz="1600" b="1" i="0">
+                <a:solidFill>
+                  <a:srgbClr val="000000"/>
+                </a:solidFill>
+                <a:latin typeface="Helvetica Neue"/>
+              </a:rPr>
+              <a:t>Kraken</a:t>
+            </a:r>
+          </a:p>
+          <a:p>
+            <a:pPr algn="l"/>
+            <a:r>
+              <a:rPr sz="1600" b="1" i="0">
+                <a:solidFill>
+                  <a:srgbClr val="000000"/>
+                </a:solidFill>
+                <a:latin typeface="Helvetica Neue"/>
+              </a:rPr>
+              <a:t>USDC = $0.99990</a:t>
+            </a:r>
+          </a:p>
+          <a:p>
+            <a:pPr algn="l"/>
+            <a:r>
+              <a:rPr sz="1600" b="1" i="0">
+                <a:solidFill>
+                  <a:srgbClr val="000000"/>
+                </a:solidFill>
+                <a:latin typeface="Helvetica Neue"/>
+              </a:rPr>
+              <a:t>(cheap)</a:t>
+            </a:r>
+          </a:p>
+        </p:txBody>
+      </p:sp>
+      <p:sp>
+        <p:nvSpPr>
+          <p:cNvPr id="6" name="Rounded Rectangle 5"/>
+          <p:cNvSpPr/>
+          <p:nvPr/>
+        </p:nvSpPr>
+        <p:spPr>
+          <a:xfrm>
+            <a:off x="4846320" y="1188720"/>
+            <a:ext cx="3840480" cy="1371600"/>
+          </a:xfrm>
+          <a:prstGeom prst="roundRect">
+            <a:avLst/>
+          </a:prstGeom>
+          <a:solidFill>
+            <a:srgbClr val="B6E3EE"/>
+          </a:solidFill>
+          <a:ln>
+            <a:noFill/>
+          </a:ln>
+          <a:effectLst/>
+        </p:spPr>
+        <p:style>
+          <a:lnRef idx="1">
+            <a:schemeClr val="accent1"/>
+          </a:lnRef>
+          <a:fillRef idx="3">
+            <a:schemeClr val="accent1"/>
+          </a:fillRef>
+          <a:effectRef idx="2">
+            <a:schemeClr val="accent1"/>
+          </a:effectRef>
+          <a:fontRef idx="minor">
+            <a:schemeClr val="lt1"/>
+          </a:fontRef>
+        </p:style>
+        <p:txBody>
+          <a:bodyPr rtlCol="0" anchor="ctr"/>
+          <a:lstStyle/>
+          <a:p>
+            <a:pPr algn="ctr"/>
+          </a:p>
+        </p:txBody>
+      </p:sp>
+      <p:sp>
+        <p:nvSpPr>
+          <p:cNvPr id="7" name="TextBox 6"/>
           <p:cNvSpPr txBox="1"/>
           <p:nvPr/>
         </p:nvSpPr>
         <p:spPr>
           <a:xfrm>
-            <a:off x="548640" y="1280160"/>
-            <a:ext cx="4114800" cy="3474720"/>
+            <a:off x="5029200" y="1280160"/>
+            <a:ext cx="3474720" cy="1188720"/>
           </a:xfrm>
           <a:prstGeom prst="rect">
             <a:avLst/>
@@ -5568,148 +6741,207 @@
           </a:bodyPr>
           <a:lstStyle/>
           <a:p>
-            <a:pPr>
-              <a:spcAft>
-                <a:spcPts val="800"/>
-              </a:spcAft>
-            </a:pPr>
-            <a:r>
-              <a:rPr sz="1300">
+            <a:pPr algn="l"/>
+            <a:r>
+              <a:rPr sz="1600" b="1" i="0">
                 <a:solidFill>
                   <a:srgbClr val="000000"/>
                 </a:solidFill>
                 <a:latin typeface="Helvetica Neue"/>
               </a:rPr>
-              <a:t>•  Node: a stablecoin sitting on a specific exchange</a:t>
-            </a:r>
-          </a:p>
-          <a:p>
-            <a:pPr>
-              <a:spcAft>
-                <a:spcPts val="800"/>
-              </a:spcAft>
-            </a:pPr>
-            <a:r>
-              <a:rPr sz="1300">
+              <a:t>Binance</a:t>
+            </a:r>
+          </a:p>
+          <a:p>
+            <a:pPr algn="l"/>
+            <a:r>
+              <a:rPr sz="1600" b="1" i="0">
                 <a:solidFill>
                   <a:srgbClr val="000000"/>
                 </a:solidFill>
                 <a:latin typeface="Helvetica Neue"/>
               </a:rPr>
-              <a:t>•  Trade edge (intra-exchange):</a:t>
-            </a:r>
-            <a:br/>
-            <a:r>
-              <a:rPr sz="1300">
+              <a:t>USDC = $1.00013</a:t>
+            </a:r>
+          </a:p>
+          <a:p>
+            <a:pPr algn="l"/>
+            <a:r>
+              <a:rPr sz="1600" b="1" i="0">
                 <a:solidFill>
                   <a:srgbClr val="000000"/>
                 </a:solidFill>
                 <a:latin typeface="Helvetica Neue"/>
               </a:rPr>
-              <a:t>  same exchange, swap USDT→USDC</a:t>
-            </a:r>
-            <a:br/>
-            <a:r>
-              <a:rPr sz="1300">
-                <a:solidFill>
-                  <a:srgbClr val="000000"/>
-                </a:solidFill>
-                <a:latin typeface="Helvetica Neue"/>
-              </a:rPr>
-              <a:t>  cost = taker fee (0.8-2.5 bps)</a:t>
-            </a:r>
-          </a:p>
-          <a:p>
-            <a:pPr>
-              <a:spcAft>
-                <a:spcPts val="800"/>
-              </a:spcAft>
-            </a:pPr>
-            <a:r>
-              <a:rPr sz="1300">
-                <a:solidFill>
-                  <a:srgbClr val="000000"/>
-                </a:solidFill>
-                <a:latin typeface="Helvetica Neue"/>
-              </a:rPr>
-              <a:t>•  Transfer edge (cross-exchange):</a:t>
-            </a:r>
-            <a:br/>
-            <a:r>
-              <a:rPr sz="1300">
-                <a:solidFill>
-                  <a:srgbClr val="000000"/>
-                </a:solidFill>
-                <a:latin typeface="Helvetica Neue"/>
-              </a:rPr>
-              <a:t>  same coin, move between exchanges</a:t>
-            </a:r>
-            <a:br/>
-            <a:r>
-              <a:rPr sz="1300">
-                <a:solidFill>
-                  <a:srgbClr val="000000"/>
-                </a:solidFill>
-                <a:latin typeface="Helvetica Neue"/>
-              </a:rPr>
-              <a:t>  cost = withdrawal fee + gas</a:t>
-            </a:r>
-          </a:p>
-          <a:p>
-            <a:pPr>
-              <a:spcAft>
-                <a:spcPts val="800"/>
-              </a:spcAft>
-            </a:pPr>
-            <a:r>
-              <a:rPr sz="1300">
-                <a:solidFill>
-                  <a:srgbClr val="000000"/>
-                </a:solidFill>
-                <a:latin typeface="Helvetica Neue"/>
-              </a:rPr>
-              <a:t>•  Goal: find a cycle starting and ending</a:t>
-            </a:r>
-            <a:br/>
-            <a:r>
-              <a:rPr sz="1300">
-                <a:solidFill>
-                  <a:srgbClr val="000000"/>
-                </a:solidFill>
-                <a:latin typeface="Helvetica Neue"/>
-              </a:rPr>
-              <a:t>  at the same node with net profit &gt; 0</a:t>
-            </a:r>
-          </a:p>
-        </p:txBody>
-      </p:sp>
-      <p:pic>
-        <p:nvPicPr>
-          <p:cNvPr id="6" name="Picture 5" descr="frame_00_step01.png"/>
-          <p:cNvPicPr>
-            <a:picLocks noChangeAspect="1"/>
-          </p:cNvPicPr>
-          <p:nvPr/>
-        </p:nvPicPr>
-        <p:blipFill>
-          <a:blip r:embed="rId2"/>
-          <a:stretch>
-            <a:fillRect/>
-          </a:stretch>
-        </p:blipFill>
-        <p:spPr>
-          <a:xfrm>
-            <a:off x="4754880" y="1188720"/>
-            <a:ext cx="4114800" cy="4214368"/>
-          </a:xfrm>
-          <a:prstGeom prst="rect">
-            <a:avLst/>
-          </a:prstGeom>
-        </p:spPr>
-      </p:pic>
-      <p:sp>
-        <p:nvSpPr>
-          <p:cNvPr id="7" name="TextBox 6"/>
+              <a:t>(expensive)</a:t>
+            </a:r>
+          </a:p>
+        </p:txBody>
+      </p:sp>
+      <p:sp>
+        <p:nvSpPr>
+          <p:cNvPr id="8" name="TextBox 7"/>
+          <p:cNvSpPr txBox="1"/>
+          <p:nvPr/>
+        </p:nvSpPr>
+        <p:spPr>
+          <a:xfrm>
+            <a:off x="3840480" y="1554480"/>
+            <a:ext cx="1371600" cy="457200"/>
+          </a:xfrm>
+          <a:prstGeom prst="rect">
+            <a:avLst/>
+          </a:prstGeom>
+          <a:noFill/>
+        </p:spPr>
+        <p:txBody>
+          <a:bodyPr wrap="square">
+            <a:spAutoFit/>
+          </a:bodyPr>
+          <a:lstStyle/>
+          <a:p>
+            <a:pPr algn="ctr"/>
+            <a:r>
+              <a:rPr sz="3600" b="1" i="0">
+                <a:solidFill>
+                  <a:srgbClr val="173482"/>
+                </a:solidFill>
+                <a:latin typeface="Helvetica Neue"/>
+              </a:rPr>
+              <a:t>→</a:t>
+            </a:r>
+          </a:p>
+        </p:txBody>
+      </p:sp>
+      <p:sp>
+        <p:nvSpPr>
+          <p:cNvPr id="9" name="Rounded Rectangle 8"/>
+          <p:cNvSpPr/>
+          <p:nvPr/>
+        </p:nvSpPr>
+        <p:spPr>
+          <a:xfrm>
+            <a:off x="1371600" y="2926080"/>
+            <a:ext cx="6400800" cy="914400"/>
+          </a:xfrm>
+          <a:prstGeom prst="roundRect">
+            <a:avLst/>
+          </a:prstGeom>
+          <a:solidFill>
+            <a:srgbClr val="173482"/>
+          </a:solidFill>
+          <a:ln>
+            <a:noFill/>
+          </a:ln>
+          <a:effectLst/>
+        </p:spPr>
+        <p:style>
+          <a:lnRef idx="1">
+            <a:schemeClr val="accent1"/>
+          </a:lnRef>
+          <a:fillRef idx="3">
+            <a:schemeClr val="accent1"/>
+          </a:fillRef>
+          <a:effectRef idx="2">
+            <a:schemeClr val="accent1"/>
+          </a:effectRef>
+          <a:fontRef idx="minor">
+            <a:schemeClr val="lt1"/>
+          </a:fontRef>
+        </p:style>
+        <p:txBody>
+          <a:bodyPr rtlCol="0" anchor="ctr"/>
+          <a:lstStyle/>
+          <a:p>
+            <a:pPr algn="ctr"/>
+          </a:p>
+        </p:txBody>
+      </p:sp>
+      <p:sp>
+        <p:nvSpPr>
+          <p:cNvPr id="10" name="TextBox 9"/>
+          <p:cNvSpPr txBox="1"/>
+          <p:nvPr/>
+        </p:nvSpPr>
+        <p:spPr>
+          <a:xfrm>
+            <a:off x="1554480" y="3017520"/>
+            <a:ext cx="6035040" cy="731520"/>
+          </a:xfrm>
+          <a:prstGeom prst="rect">
+            <a:avLst/>
+          </a:prstGeom>
+          <a:noFill/>
+        </p:spPr>
+        <p:txBody>
+          <a:bodyPr wrap="square">
+            <a:spAutoFit/>
+          </a:bodyPr>
+          <a:lstStyle/>
+          <a:p>
+            <a:pPr algn="ctr"/>
+            <a:r>
+              <a:rPr sz="1600" b="1" i="0">
+                <a:solidFill>
+                  <a:srgbClr val="FFFFFF"/>
+                </a:solidFill>
+                <a:latin typeface="Helvetica Neue"/>
+              </a:rPr>
+              <a:t>Buy on Kraken  →  Transfer  →  Sell on Binance  =  +2.3 bps profit</a:t>
+            </a:r>
+          </a:p>
+        </p:txBody>
+      </p:sp>
+      <p:sp>
+        <p:nvSpPr>
+          <p:cNvPr id="11" name="TextBox 10"/>
+          <p:cNvSpPr txBox="1"/>
+          <p:nvPr/>
+        </p:nvSpPr>
+        <p:spPr>
+          <a:xfrm>
+            <a:off x="457200" y="4114800"/>
+            <a:ext cx="8229600" cy="640080"/>
+          </a:xfrm>
+          <a:prstGeom prst="rect">
+            <a:avLst/>
+          </a:prstGeom>
+          <a:noFill/>
+        </p:spPr>
+        <p:txBody>
+          <a:bodyPr wrap="square">
+            <a:spAutoFit/>
+          </a:bodyPr>
+          <a:lstStyle/>
+          <a:p>
+            <a:pPr algn="ctr"/>
+            <a:r>
+              <a:rPr sz="1200" b="0" i="1">
+                <a:solidFill>
+                  <a:srgbClr val="595959"/>
+                </a:solidFill>
+                <a:latin typeface="Helvetica Neue"/>
+              </a:rPr>
+              <a:t>But: fees + slippage + transfer time can eat the profit.</a:t>
+            </a:r>
+          </a:p>
+          <a:p>
+            <a:pPr algn="ctr"/>
+            <a:r>
+              <a:rPr sz="1200" b="0" i="1">
+                <a:solidFill>
+                  <a:srgbClr val="595959"/>
+                </a:solidFill>
+                <a:latin typeface="Helvetica Neue"/>
+              </a:rPr>
+              <a:t>With 5 exchanges × 4 coins = 20 nodes, 40+ edges — need an algorithm.</a:t>
+            </a:r>
+          </a:p>
+        </p:txBody>
+      </p:sp>
+      <p:sp>
+        <p:nvSpPr>
+          <p:cNvPr id="12" name="TextBox 11"/>
           <p:cNvSpPr txBox="1"/>
           <p:nvPr/>
         </p:nvSpPr>
@@ -5842,7 +7074,7 @@
                 </a:solidFill>
                 <a:latin typeface="Helvetica Neue"/>
               </a:rPr>
-              <a:t>Baseline: Dijkstra’s Algorithm</a:t>
+              <a:t>Model: Weighted Directed Graph</a:t>
             </a:r>
           </a:p>
         </p:txBody>
@@ -5855,43 +7087,8 @@
         </p:nvSpPr>
         <p:spPr>
           <a:xfrm>
-            <a:off x="457200" y="749808"/>
-            <a:ext cx="8229600" cy="411480"/>
-          </a:xfrm>
-          <a:prstGeom prst="rect">
-            <a:avLst/>
-          </a:prstGeom>
-          <a:noFill/>
-        </p:spPr>
-        <p:txBody>
-          <a:bodyPr wrap="square">
-            <a:spAutoFit/>
-          </a:bodyPr>
-          <a:lstStyle/>
-          <a:p>
-            <a:pPr algn="l"/>
-            <a:r>
-              <a:rPr sz="1400" b="0" i="1">
-                <a:solidFill>
-                  <a:srgbClr val="595959"/>
-                </a:solidFill>
-                <a:latin typeface="Helvetica Neue"/>
-              </a:rPr>
-              <a:t>f(n) = g(n) — expand nodes by lowest accumulated cost</a:t>
-            </a:r>
-          </a:p>
-        </p:txBody>
-      </p:sp>
-      <p:sp>
-        <p:nvSpPr>
-          <p:cNvPr id="5" name="TextBox 4"/>
-          <p:cNvSpPr txBox="1"/>
-          <p:nvPr/>
-        </p:nvSpPr>
-        <p:spPr>
-          <a:xfrm>
-            <a:off x="548640" y="1280160"/>
-            <a:ext cx="8229600" cy="1645920"/>
+            <a:off x="365760" y="1097280"/>
+            <a:ext cx="3200400" cy="3200400"/>
           </a:xfrm>
           <a:prstGeom prst="rect">
             <a:avLst/>
@@ -5910,13 +7107,13 @@
               </a:spcAft>
             </a:pPr>
             <a:r>
-              <a:rPr sz="1400">
+              <a:rPr sz="1200">
                 <a:solidFill>
                   <a:srgbClr val="000000"/>
                 </a:solidFill>
                 <a:latin typeface="Helvetica Neue"/>
               </a:rPr>
-              <a:t>•  g(n) = total fees paid to reach node n from start</a:t>
+              <a:t>•  Node = (exchange, coin)</a:t>
             </a:r>
           </a:p>
           <a:p>
@@ -5926,13 +7123,23 @@
               </a:spcAft>
             </a:pPr>
             <a:r>
-              <a:rPr sz="1400">
+              <a:rPr sz="1200">
                 <a:solidFill>
                   <a:srgbClr val="000000"/>
                 </a:solidFill>
                 <a:latin typeface="Helvetica Neue"/>
               </a:rPr>
-              <a:t>•  Always picks the cheapest-so-far node to expand next</a:t>
+              <a:t>•  Trade edge: swap coins</a:t>
+            </a:r>
+            <a:br/>
+            <a:r>
+              <a:rPr sz="1200">
+                <a:solidFill>
+                  <a:srgbClr val="000000"/>
+                </a:solidFill>
+                <a:latin typeface="Helvetica Neue"/>
+              </a:rPr>
+              <a:t>  on same exchange</a:t>
             </a:r>
           </a:p>
           <a:p>
@@ -5942,13 +7149,23 @@
               </a:spcAft>
             </a:pPr>
             <a:r>
-              <a:rPr sz="1400">
+              <a:rPr sz="1200">
                 <a:solidFill>
                   <a:srgbClr val="000000"/>
                 </a:solidFill>
                 <a:latin typeface="Helvetica Neue"/>
               </a:rPr>
-              <a:t>•  Guaranteed optimal but explores blindly in all directions</a:t>
+              <a:t>•  Transfer edge: move coin</a:t>
+            </a:r>
+            <a:br/>
+            <a:r>
+              <a:rPr sz="1200">
+                <a:solidFill>
+                  <a:srgbClr val="000000"/>
+                </a:solidFill>
+                <a:latin typeface="Helvetica Neue"/>
+              </a:rPr>
+              <a:t>  between exchanges</a:t>
             </a:r>
           </a:p>
           <a:p>
@@ -5958,102 +7175,70 @@
               </a:spcAft>
             </a:pPr>
             <a:r>
-              <a:rPr sz="1400">
+              <a:rPr sz="1200">
                 <a:solidFill>
                   <a:srgbClr val="000000"/>
                 </a:solidFill>
                 <a:latin typeface="Helvetica Neue"/>
               </a:rPr>
-              <a:t>•  Doesn’t know that a 300-second transfer will expose us to price risk</a:t>
-            </a:r>
-          </a:p>
-        </p:txBody>
-      </p:sp>
+              <a:t>•  Edge weight = fee in bps</a:t>
+            </a:r>
+          </a:p>
+          <a:p>
+            <a:pPr>
+              <a:spcAft>
+                <a:spcPts val="800"/>
+              </a:spcAft>
+            </a:pPr>
+            <a:r>
+              <a:rPr sz="1200">
+                <a:solidFill>
+                  <a:srgbClr val="000000"/>
+                </a:solidFill>
+                <a:latin typeface="Helvetica Neue"/>
+              </a:rPr>
+              <a:t>•  Goal: find lowest-cost</a:t>
+            </a:r>
+            <a:br/>
+            <a:r>
+              <a:rPr sz="1200">
+                <a:solidFill>
+                  <a:srgbClr val="000000"/>
+                </a:solidFill>
+                <a:latin typeface="Helvetica Neue"/>
+              </a:rPr>
+              <a:t>  cycle back to start</a:t>
+            </a:r>
+          </a:p>
+        </p:txBody>
+      </p:sp>
+      <p:pic>
+        <p:nvPicPr>
+          <p:cNvPr id="5" name="Picture 4" descr="frame_00_step01.png"/>
+          <p:cNvPicPr>
+            <a:picLocks noChangeAspect="1"/>
+          </p:cNvPicPr>
+          <p:nvPr/>
+        </p:nvPicPr>
+        <p:blipFill>
+          <a:blip r:embed="rId2"/>
+          <a:stretch>
+            <a:fillRect/>
+          </a:stretch>
+        </p:blipFill>
+        <p:spPr>
+          <a:xfrm>
+            <a:off x="3474720" y="1005840"/>
+            <a:ext cx="5486400" cy="5619157"/>
+          </a:xfrm>
+          <a:prstGeom prst="rect">
+            <a:avLst/>
+          </a:prstGeom>
+        </p:spPr>
+      </p:pic>
       <p:sp>
         <p:nvSpPr>
           <p:cNvPr id="6" name="TextBox 5"/>
-          <p:cNvSpPr txBox="1"/>
-          <p:nvPr/>
-        </p:nvSpPr>
-        <p:spPr>
-          <a:xfrm>
-            <a:off x="2743200" y="3200400"/>
-            <a:ext cx="3657600" cy="457200"/>
-          </a:xfrm>
-          <a:prstGeom prst="rect">
-            <a:avLst/>
-          </a:prstGeom>
-          <a:noFill/>
-        </p:spPr>
-        <p:txBody>
-          <a:bodyPr wrap="square">
-            <a:spAutoFit/>
-          </a:bodyPr>
-          <a:lstStyle/>
-          <a:p>
-            <a:pPr algn="ctr"/>
-            <a:r>
-              <a:rPr sz="2400" b="1" i="0">
-                <a:solidFill>
-                  <a:srgbClr val="173482"/>
-                </a:solidFill>
-                <a:latin typeface="Helvetica Neue"/>
-              </a:rPr>
-              <a:t>f(n) = g(n)</a:t>
-            </a:r>
-          </a:p>
-        </p:txBody>
-      </p:sp>
-      <p:sp>
-        <p:nvSpPr>
-          <p:cNvPr id="7" name="TextBox 6"/>
-          <p:cNvSpPr txBox="1"/>
-          <p:nvPr/>
-        </p:nvSpPr>
-        <p:spPr>
-          <a:xfrm>
-            <a:off x="1371600" y="3749039"/>
-            <a:ext cx="6400800" cy="914400"/>
-          </a:xfrm>
-          <a:prstGeom prst="rect">
-            <a:avLst/>
-          </a:prstGeom>
-          <a:noFill/>
-        </p:spPr>
-        <p:txBody>
-          <a:bodyPr wrap="square">
-            <a:spAutoFit/>
-          </a:bodyPr>
-          <a:lstStyle/>
-          <a:p>
-            <a:pPr algn="ctr"/>
-            <a:r>
-              <a:rPr sz="1200" b="0" i="1">
-                <a:solidFill>
-                  <a:srgbClr val="595959"/>
-                </a:solidFill>
-                <a:latin typeface="Helvetica Neue"/>
-              </a:rPr>
-              <a:t>Problem: Dijkstra treats a 0.3bp fee edge to OKX (5-min transfer, thin book)</a:t>
-            </a:r>
-          </a:p>
-          <a:p>
-            <a:pPr algn="ctr"/>
-            <a:r>
-              <a:rPr sz="1200" b="0" i="1">
-                <a:solidFill>
-                  <a:srgbClr val="595959"/>
-                </a:solidFill>
-                <a:latin typeface="Helvetica Neue"/>
-              </a:rPr>
-              <a:t>the same as a 0.3bp fee edge to Bybit (45-sec transfer, deep book)</a:t>
-            </a:r>
-          </a:p>
-        </p:txBody>
-      </p:sp>
-      <p:sp>
-        <p:nvSpPr>
-          <p:cNvPr id="8" name="TextBox 7"/>
           <p:cNvSpPr txBox="1"/>
           <p:nvPr/>
         </p:nvSpPr>
@@ -6186,7 +7371,7 @@
                 </a:solidFill>
                 <a:latin typeface="Helvetica Neue"/>
               </a:rPr>
-              <a:t>A* Search: f(n) = g(n) + h(n)</a:t>
+              <a:t>Dijkstra: f(n) = g(n)</a:t>
             </a:r>
           </a:p>
         </p:txBody>
@@ -6199,8 +7384,8 @@
         </p:nvSpPr>
         <p:spPr>
           <a:xfrm>
-            <a:off x="457200" y="749808"/>
-            <a:ext cx="8229600" cy="411480"/>
+            <a:off x="548640" y="1188720"/>
+            <a:ext cx="8229600" cy="548640"/>
           </a:xfrm>
           <a:prstGeom prst="rect">
             <a:avLst/>
@@ -6215,13 +7400,13 @@
           <a:p>
             <a:pPr algn="l"/>
             <a:r>
-              <a:rPr sz="1400" b="0" i="1">
-                <a:solidFill>
-                  <a:srgbClr val="595959"/>
-                </a:solidFill>
-                <a:latin typeface="Helvetica Neue"/>
-              </a:rPr>
-              <a:t>Add a heuristic that estimates slippage + time-decay risk</a:t>
+              <a:rPr sz="1500" b="0" i="0">
+                <a:solidFill>
+                  <a:srgbClr val="000000"/>
+                </a:solidFill>
+                <a:latin typeface="Helvetica Neue"/>
+              </a:rPr>
+              <a:t>Expand the node with the lowest accumulated cost so far</a:t>
             </a:r>
           </a:p>
         </p:txBody>
@@ -6234,8 +7419,8 @@
         </p:nvSpPr>
         <p:spPr>
           <a:xfrm>
-            <a:off x="548640" y="1280160"/>
-            <a:ext cx="8229600" cy="1371600"/>
+            <a:off x="2743200" y="1828800"/>
+            <a:ext cx="3657600" cy="548640"/>
           </a:xfrm>
           <a:prstGeom prst="rect">
             <a:avLst/>
@@ -6248,65 +7433,73 @@
           </a:bodyPr>
           <a:lstStyle/>
           <a:p>
-            <a:pPr>
-              <a:spcAft>
-                <a:spcPts val="800"/>
-              </a:spcAft>
-            </a:pPr>
-            <a:r>
-              <a:rPr sz="1400">
-                <a:solidFill>
-                  <a:srgbClr val="000000"/>
-                </a:solidFill>
-                <a:latin typeface="Helvetica Neue"/>
-              </a:rPr>
-              <a:t>•  h(n) = estimated future cost from L2 order book slippage + volatility exposure</a:t>
-            </a:r>
-          </a:p>
-          <a:p>
-            <a:pPr>
-              <a:spcAft>
-                <a:spcPts val="800"/>
-              </a:spcAft>
-            </a:pPr>
-            <a:r>
-              <a:rPr sz="1400">
-                <a:solidFill>
-                  <a:srgbClr val="000000"/>
-                </a:solidFill>
-                <a:latin typeface="Helvetica Neue"/>
-              </a:rPr>
-              <a:t>•  A* expands the node with lowest f = actual cost so far + estimated cost ahead</a:t>
-            </a:r>
-          </a:p>
-          <a:p>
-            <a:pPr>
-              <a:spcAft>
-                <a:spcPts val="800"/>
-              </a:spcAft>
-            </a:pPr>
-            <a:r>
-              <a:rPr sz="1400">
-                <a:solidFill>
-                  <a:srgbClr val="000000"/>
-                </a:solidFill>
-                <a:latin typeface="Helvetica Neue"/>
-              </a:rPr>
-              <a:t>•  Prioritizes paths through deep-liquidity exchanges, avoids thin books</a:t>
-            </a:r>
-          </a:p>
-        </p:txBody>
-      </p:sp>
-      <p:sp>
-        <p:nvSpPr>
-          <p:cNvPr id="6" name="TextBox 5"/>
+            <a:pPr algn="ctr"/>
+            <a:r>
+              <a:rPr sz="2800" b="1" i="0">
+                <a:solidFill>
+                  <a:srgbClr val="173482"/>
+                </a:solidFill>
+                <a:latin typeface="Helvetica Neue"/>
+              </a:rPr>
+              <a:t>f(n) = g(n)</a:t>
+            </a:r>
+          </a:p>
+        </p:txBody>
+      </p:sp>
+      <p:sp>
+        <p:nvSpPr>
+          <p:cNvPr id="6" name="Rounded Rectangle 5"/>
+          <p:cNvSpPr/>
+          <p:nvPr/>
+        </p:nvSpPr>
+        <p:spPr>
+          <a:xfrm>
+            <a:off x="457200" y="2651760"/>
+            <a:ext cx="3931920" cy="1828800"/>
+          </a:xfrm>
+          <a:prstGeom prst="roundRect">
+            <a:avLst/>
+          </a:prstGeom>
+          <a:solidFill>
+            <a:srgbClr val="EAF8F2"/>
+          </a:solidFill>
+          <a:ln>
+            <a:noFill/>
+          </a:ln>
+          <a:effectLst/>
+        </p:spPr>
+        <p:style>
+          <a:lnRef idx="1">
+            <a:schemeClr val="accent1"/>
+          </a:lnRef>
+          <a:fillRef idx="3">
+            <a:schemeClr val="accent1"/>
+          </a:fillRef>
+          <a:effectRef idx="2">
+            <a:schemeClr val="accent1"/>
+          </a:effectRef>
+          <a:fontRef idx="minor">
+            <a:schemeClr val="lt1"/>
+          </a:fontRef>
+        </p:style>
+        <p:txBody>
+          <a:bodyPr rtlCol="0" anchor="ctr"/>
+          <a:lstStyle/>
+          <a:p>
+            <a:pPr algn="ctr"/>
+          </a:p>
+        </p:txBody>
+      </p:sp>
+      <p:sp>
+        <p:nvSpPr>
+          <p:cNvPr id="7" name="TextBox 6"/>
           <p:cNvSpPr txBox="1"/>
           <p:nvPr/>
         </p:nvSpPr>
         <p:spPr>
           <a:xfrm>
-            <a:off x="1828800" y="2926080"/>
-            <a:ext cx="5486400" cy="457200"/>
+            <a:off x="640080" y="2743200"/>
+            <a:ext cx="3566160" cy="1645920"/>
           </a:xfrm>
           <a:prstGeom prst="rect">
             <a:avLst/>
@@ -6319,29 +7512,97 @@
           </a:bodyPr>
           <a:lstStyle/>
           <a:p>
+            <a:pPr algn="l"/>
+            <a:r>
+              <a:rPr sz="1400" b="0" i="0">
+                <a:solidFill>
+                  <a:srgbClr val="000000"/>
+                </a:solidFill>
+                <a:latin typeface="Helvetica Neue"/>
+              </a:rPr>
+              <a:t>✓  Guaranteed optimal</a:t>
+            </a:r>
+          </a:p>
+          <a:p>
+            <a:pPr algn="l"/>
+            <a:r>
+              <a:rPr sz="1400" b="0" i="0">
+                <a:solidFill>
+                  <a:srgbClr val="000000"/>
+                </a:solidFill>
+                <a:latin typeface="Helvetica Neue"/>
+              </a:rPr>
+              <a:t>✓  Simple to implement</a:t>
+            </a:r>
+          </a:p>
+          <a:p>
+            <a:pPr algn="l"/>
+            <a:r>
+              <a:rPr sz="1400" b="0" i="0">
+                <a:solidFill>
+                  <a:srgbClr val="000000"/>
+                </a:solidFill>
+                <a:latin typeface="Helvetica Neue"/>
+              </a:rPr>
+              <a:t>✓  No domain knowledge needed</a:t>
+            </a:r>
+          </a:p>
+        </p:txBody>
+      </p:sp>
+      <p:sp>
+        <p:nvSpPr>
+          <p:cNvPr id="8" name="Rounded Rectangle 7"/>
+          <p:cNvSpPr/>
+          <p:nvPr/>
+        </p:nvSpPr>
+        <p:spPr>
+          <a:xfrm>
+            <a:off x="4754880" y="2651760"/>
+            <a:ext cx="3931920" cy="1828800"/>
+          </a:xfrm>
+          <a:prstGeom prst="roundRect">
+            <a:avLst/>
+          </a:prstGeom>
+          <a:solidFill>
+            <a:srgbClr val="FFEBEE"/>
+          </a:solidFill>
+          <a:ln>
+            <a:noFill/>
+          </a:ln>
+          <a:effectLst/>
+        </p:spPr>
+        <p:style>
+          <a:lnRef idx="1">
+            <a:schemeClr val="accent1"/>
+          </a:lnRef>
+          <a:fillRef idx="3">
+            <a:schemeClr val="accent1"/>
+          </a:fillRef>
+          <a:effectRef idx="2">
+            <a:schemeClr val="accent1"/>
+          </a:effectRef>
+          <a:fontRef idx="minor">
+            <a:schemeClr val="lt1"/>
+          </a:fontRef>
+        </p:style>
+        <p:txBody>
+          <a:bodyPr rtlCol="0" anchor="ctr"/>
+          <a:lstStyle/>
+          <a:p>
             <a:pPr algn="ctr"/>
-            <a:r>
-              <a:rPr sz="2400" b="1" i="0">
-                <a:solidFill>
-                  <a:srgbClr val="173482"/>
-                </a:solidFill>
-                <a:latin typeface="Helvetica Neue"/>
-              </a:rPr>
-              <a:t>f(n) = g(n) + h(n)</a:t>
-            </a:r>
-          </a:p>
-        </p:txBody>
-      </p:sp>
-      <p:sp>
-        <p:nvSpPr>
-          <p:cNvPr id="7" name="TextBox 6"/>
+          </a:p>
+        </p:txBody>
+      </p:sp>
+      <p:sp>
+        <p:nvSpPr>
+          <p:cNvPr id="9" name="TextBox 8"/>
           <p:cNvSpPr txBox="1"/>
           <p:nvPr/>
         </p:nvSpPr>
         <p:spPr>
           <a:xfrm>
-            <a:off x="548640" y="3566160"/>
-            <a:ext cx="8229600" cy="1097280"/>
+            <a:off x="4937760" y="2743200"/>
+            <a:ext cx="3566160" cy="1645920"/>
           </a:xfrm>
           <a:prstGeom prst="rect">
             <a:avLst/>
@@ -6356,47 +7617,56 @@
           <a:p>
             <a:pPr algn="l"/>
             <a:r>
-              <a:rPr sz="1200" b="0" i="0">
-                <a:solidFill>
-                  <a:srgbClr val="595959"/>
-                </a:solidFill>
-                <a:latin typeface="Helvetica Neue"/>
-              </a:rPr>
-              <a:t>h(n) = slippage(L2 book, trade_size) + σ · √(Δt)</a:t>
-            </a:r>
-          </a:p>
-          <a:p>
-            <a:pPr algn="l"/>
-          </a:p>
-          <a:p>
-            <a:pPr algn="l"/>
-            <a:r>
-              <a:rPr sz="1200" b="0" i="0">
-                <a:solidFill>
-                  <a:srgbClr val="595959"/>
-                </a:solidFill>
-                <a:latin typeface="Helvetica Neue"/>
-              </a:rPr>
-              <a:t>Slippage: walk the ask side of the order book for our trade size</a:t>
-            </a:r>
-          </a:p>
-          <a:p>
-            <a:pPr algn="l"/>
-            <a:r>
-              <a:rPr sz="1200" b="0" i="0">
-                <a:solidFill>
-                  <a:srgbClr val="595959"/>
-                </a:solidFill>
-                <a:latin typeface="Helvetica Neue"/>
-              </a:rPr>
-              <a:t>Time risk: stablecoin volatility (∼1.5 bps/min) × transfer duration</a:t>
-            </a:r>
-          </a:p>
-        </p:txBody>
-      </p:sp>
-      <p:sp>
-        <p:nvSpPr>
-          <p:cNvPr id="8" name="TextBox 7"/>
+              <a:rPr sz="1400" b="0" i="0">
+                <a:solidFill>
+                  <a:srgbClr val="000000"/>
+                </a:solidFill>
+                <a:latin typeface="Helvetica Neue"/>
+              </a:rPr>
+              <a:t>✗  Explores blindly</a:t>
+            </a:r>
+          </a:p>
+          <a:p>
+            <a:pPr algn="l"/>
+            <a:r>
+              <a:rPr sz="1400" b="0" i="0">
+                <a:solidFill>
+                  <a:srgbClr val="000000"/>
+                </a:solidFill>
+                <a:latin typeface="Helvetica Neue"/>
+              </a:rPr>
+              <a:t>✗  Ignores slippage risk</a:t>
+            </a:r>
+          </a:p>
+          <a:p>
+            <a:pPr algn="l"/>
+            <a:r>
+              <a:rPr sz="1400" b="0" i="0">
+                <a:solidFill>
+                  <a:srgbClr val="000000"/>
+                </a:solidFill>
+                <a:latin typeface="Helvetica Neue"/>
+              </a:rPr>
+              <a:t>✗  Ignores transfer time</a:t>
+            </a:r>
+          </a:p>
+          <a:p>
+            <a:pPr algn="l"/>
+            <a:r>
+              <a:rPr sz="1400" b="0" i="0">
+                <a:solidFill>
+                  <a:srgbClr val="000000"/>
+                </a:solidFill>
+                <a:latin typeface="Helvetica Neue"/>
+              </a:rPr>
+              <a:t>✗  Wastes time on thin books</a:t>
+            </a:r>
+          </a:p>
+        </p:txBody>
+      </p:sp>
+      <p:sp>
+        <p:nvSpPr>
+          <p:cNvPr id="10" name="TextBox 9"/>
           <p:cNvSpPr txBox="1"/>
           <p:nvPr/>
         </p:nvSpPr>
@@ -6529,7 +7799,7 @@
                 </a:solidFill>
                 <a:latin typeface="Helvetica Neue"/>
               </a:rPr>
-              <a:t>Step 1: Start at Binance:USDT</a:t>
+              <a:t>A*: f(n) = g(n) + h(n)</a:t>
             </a:r>
           </a:p>
         </p:txBody>
@@ -6542,8 +7812,8 @@
         </p:nvSpPr>
         <p:spPr>
           <a:xfrm>
-            <a:off x="457200" y="749808"/>
-            <a:ext cx="8229600" cy="411480"/>
+            <a:off x="548640" y="1188720"/>
+            <a:ext cx="8229600" cy="548640"/>
           </a:xfrm>
           <a:prstGeom prst="rect">
             <a:avLst/>
@@ -6558,44 +7828,176 @@
           <a:p>
             <a:pPr algn="l"/>
             <a:r>
-              <a:rPr sz="1400" b="0" i="1">
-                <a:solidFill>
-                  <a:srgbClr val="595959"/>
-                </a:solidFill>
-                <a:latin typeface="Helvetica Neue"/>
-              </a:rPr>
-              <a:t>A* begins at our starting node. Orange edges show all neighbors being pushed to the priority queue with their f(n) values.</a:t>
-            </a:r>
-          </a:p>
-        </p:txBody>
-      </p:sp>
-      <p:pic>
-        <p:nvPicPr>
-          <p:cNvPr id="5" name="Picture 4" descr="frame_00_step01.png"/>
-          <p:cNvPicPr>
-            <a:picLocks noChangeAspect="1"/>
-          </p:cNvPicPr>
-          <p:nvPr/>
-        </p:nvPicPr>
-        <p:blipFill>
-          <a:blip r:embed="rId2"/>
-          <a:stretch>
-            <a:fillRect/>
-          </a:stretch>
-        </p:blipFill>
-        <p:spPr>
-          <a:xfrm>
-            <a:off x="2831047" y="1280160"/>
-            <a:ext cx="3481906" cy="3566160"/>
-          </a:xfrm>
-          <a:prstGeom prst="rect">
-            <a:avLst/>
-          </a:prstGeom>
-        </p:spPr>
-      </p:pic>
-      <p:sp>
-        <p:nvSpPr>
-          <p:cNvPr id="6" name="TextBox 5"/>
+              <a:rPr sz="1500" b="0" i="0">
+                <a:solidFill>
+                  <a:srgbClr val="000000"/>
+                </a:solidFill>
+                <a:latin typeface="Helvetica Neue"/>
+              </a:rPr>
+              <a:t>Add a heuristic that looks ahead at execution quality</a:t>
+            </a:r>
+          </a:p>
+        </p:txBody>
+      </p:sp>
+      <p:sp>
+        <p:nvSpPr>
+          <p:cNvPr id="5" name="TextBox 4"/>
+          <p:cNvSpPr txBox="1"/>
+          <p:nvPr/>
+        </p:nvSpPr>
+        <p:spPr>
+          <a:xfrm>
+            <a:off x="2286000" y="1828800"/>
+            <a:ext cx="4572000" cy="548640"/>
+          </a:xfrm>
+          <a:prstGeom prst="rect">
+            <a:avLst/>
+          </a:prstGeom>
+          <a:noFill/>
+        </p:spPr>
+        <p:txBody>
+          <a:bodyPr wrap="square">
+            <a:spAutoFit/>
+          </a:bodyPr>
+          <a:lstStyle/>
+          <a:p>
+            <a:pPr algn="ctr"/>
+            <a:r>
+              <a:rPr sz="2800" b="1" i="0">
+                <a:solidFill>
+                  <a:srgbClr val="173482"/>
+                </a:solidFill>
+                <a:latin typeface="Helvetica Neue"/>
+              </a:rPr>
+              <a:t>f(n) = g(n) + h(n)</a:t>
+            </a:r>
+          </a:p>
+        </p:txBody>
+      </p:sp>
+      <p:sp>
+        <p:nvSpPr>
+          <p:cNvPr id="6" name="Rounded Rectangle 5"/>
+          <p:cNvSpPr/>
+          <p:nvPr/>
+        </p:nvSpPr>
+        <p:spPr>
+          <a:xfrm>
+            <a:off x="457200" y="2651760"/>
+            <a:ext cx="8229600" cy="2011680"/>
+          </a:xfrm>
+          <a:prstGeom prst="roundRect">
+            <a:avLst/>
+          </a:prstGeom>
+          <a:solidFill>
+            <a:srgbClr val="EEEEEE"/>
+          </a:solidFill>
+          <a:ln>
+            <a:noFill/>
+          </a:ln>
+          <a:effectLst/>
+        </p:spPr>
+        <p:style>
+          <a:lnRef idx="1">
+            <a:schemeClr val="accent1"/>
+          </a:lnRef>
+          <a:fillRef idx="3">
+            <a:schemeClr val="accent1"/>
+          </a:fillRef>
+          <a:effectRef idx="2">
+            <a:schemeClr val="accent1"/>
+          </a:effectRef>
+          <a:fontRef idx="minor">
+            <a:schemeClr val="lt1"/>
+          </a:fontRef>
+        </p:style>
+        <p:txBody>
+          <a:bodyPr rtlCol="0" anchor="ctr"/>
+          <a:lstStyle/>
+          <a:p>
+            <a:pPr algn="ctr"/>
+          </a:p>
+        </p:txBody>
+      </p:sp>
+      <p:sp>
+        <p:nvSpPr>
+          <p:cNvPr id="7" name="TextBox 6"/>
+          <p:cNvSpPr txBox="1"/>
+          <p:nvPr/>
+        </p:nvSpPr>
+        <p:spPr>
+          <a:xfrm>
+            <a:off x="731520" y="2743200"/>
+            <a:ext cx="7680960" cy="1828800"/>
+          </a:xfrm>
+          <a:prstGeom prst="rect">
+            <a:avLst/>
+          </a:prstGeom>
+          <a:noFill/>
+        </p:spPr>
+        <p:txBody>
+          <a:bodyPr wrap="square">
+            <a:spAutoFit/>
+          </a:bodyPr>
+          <a:lstStyle/>
+          <a:p>
+            <a:pPr algn="l"/>
+            <a:r>
+              <a:rPr sz="1300" b="0" i="0">
+                <a:solidFill>
+                  <a:srgbClr val="000000"/>
+                </a:solidFill>
+                <a:latin typeface="Helvetica Neue"/>
+              </a:rPr>
+              <a:t>h(n) = slippage(L2 order book) + σ · √(Δt)</a:t>
+            </a:r>
+          </a:p>
+          <a:p>
+            <a:pPr algn="l"/>
+          </a:p>
+          <a:p>
+            <a:pPr algn="l"/>
+            <a:r>
+              <a:rPr sz="1300" b="0" i="0">
+                <a:solidFill>
+                  <a:srgbClr val="000000"/>
+                </a:solidFill>
+                <a:latin typeface="Helvetica Neue"/>
+              </a:rPr>
+              <a:t>  Slippage:   Walk the ask side for our trade size. Thin book = high cost.</a:t>
+            </a:r>
+          </a:p>
+          <a:p>
+            <a:pPr algn="l"/>
+            <a:r>
+              <a:rPr sz="1300" b="0" i="0">
+                <a:solidFill>
+                  <a:srgbClr val="000000"/>
+                </a:solidFill>
+                <a:latin typeface="Helvetica Neue"/>
+              </a:rPr>
+              <a:t>  Time risk:  Stablecoin vol (~1.5 bps/min) × transfer duration.</a:t>
+            </a:r>
+          </a:p>
+          <a:p>
+            <a:pPr algn="l"/>
+          </a:p>
+          <a:p>
+            <a:pPr algn="l"/>
+            <a:r>
+              <a:rPr sz="1300" b="0" i="0">
+                <a:solidFill>
+                  <a:srgbClr val="000000"/>
+                </a:solidFill>
+                <a:latin typeface="Helvetica Neue"/>
+              </a:rPr>
+              <a:t>  Deep book + fast transfer → low h → A* explores that path first.</a:t>
+            </a:r>
+          </a:p>
+        </p:txBody>
+      </p:sp>
+      <p:sp>
+        <p:nvSpPr>
+          <p:cNvPr id="8" name="TextBox 7"/>
           <p:cNvSpPr txBox="1"/>
           <p:nvPr/>
         </p:nvSpPr>
@@ -6706,8 +8108,8 @@
         </p:nvSpPr>
         <p:spPr>
           <a:xfrm>
-            <a:off x="457200" y="256032"/>
-            <a:ext cx="8229600" cy="640080"/>
+            <a:off x="274320" y="164592"/>
+            <a:ext cx="5486400" cy="457200"/>
           </a:xfrm>
           <a:prstGeom prst="rect">
             <a:avLst/>
@@ -6722,13 +8124,13 @@
           <a:p>
             <a:pPr algn="l"/>
             <a:r>
-              <a:rPr sz="2800" b="1" i="0">
+              <a:rPr sz="1800" b="1" i="0">
                 <a:solidFill>
                   <a:srgbClr val="173482"/>
                 </a:solidFill>
                 <a:latin typeface="Helvetica Neue"/>
               </a:rPr>
-              <a:t>Mid-Search: Expanding Through the Graph</a:t>
+              <a:t>A* Step 1: Start Node</a:t>
             </a:r>
           </a:p>
         </p:txBody>
@@ -6741,8 +8143,8 @@
         </p:nvSpPr>
         <p:spPr>
           <a:xfrm>
-            <a:off x="457200" y="749808"/>
-            <a:ext cx="8229600" cy="411480"/>
+            <a:off x="274320" y="502920"/>
+            <a:ext cx="8229600" cy="320040"/>
           </a:xfrm>
           <a:prstGeom prst="rect">
             <a:avLst/>
@@ -6757,20 +8159,20 @@
           <a:p>
             <a:pPr algn="l"/>
             <a:r>
-              <a:rPr sz="1400" b="0" i="1">
+              <a:rPr sz="1100" b="0" i="1">
                 <a:solidFill>
                   <a:srgbClr val="595959"/>
                 </a:solidFill>
                 <a:latin typeface="Helvetica Neue"/>
               </a:rPr>
-              <a:t>A* has explored the cheap, low-slippage paths first (Binance→Bybit). High time-risk transfers to OKX/Gate.io are deprioritized by h(n).</a:t>
+              <a:t>Begin at Binance:USDT. Orange = edges just pushed to priority queue.</a:t>
             </a:r>
           </a:p>
         </p:txBody>
       </p:sp>
       <p:pic>
         <p:nvPicPr>
-          <p:cNvPr id="5" name="Picture 4" descr="frame_05_step25.png"/>
+          <p:cNvPr id="5" name="Picture 4" descr="frame_00_step01.png"/>
           <p:cNvPicPr>
             <a:picLocks noChangeAspect="1"/>
           </p:cNvPicPr>
@@ -6784,8 +8186,8 @@
         </p:blipFill>
         <p:spPr>
           <a:xfrm>
-            <a:off x="2831047" y="1280160"/>
-            <a:ext cx="3481906" cy="3566160"/>
+            <a:off x="2563208" y="868680"/>
+            <a:ext cx="4017584" cy="4114800"/>
           </a:xfrm>
           <a:prstGeom prst="rect">
             <a:avLst/>

</xml_diff>

<commit_message>
fix: Note stablecoins can peg to non-USD fiat, paths need not close a cycle
- Slide 3: added EURC/EURT examples, cross-currency arbitrage note
- Slide 4: generalized peg mechanisms to any fiat, not just USD
- Slide 6/13/summary: clarified A* finds a profitable path, which may
  or may not close back into a cycle at the start node
</commit_message>
<xml_diff>
--- a/astar_arbitrage_deck.pptx
+++ b/astar_arbitrage_deck.pptx
@@ -3947,7 +3947,7 @@
                 </a:solidFill>
                 <a:latin typeface="Helvetica Neue"/>
               </a:rPr>
-              <a:t>A* Final: Cycle Found</a:t>
+              <a:t>A* Final: Profitable Path Found</a:t>
             </a:r>
           </a:p>
         </p:txBody>
@@ -3982,7 +3982,19 @@
                 </a:solidFill>
                 <a:latin typeface="Helvetica Neue"/>
               </a:rPr>
-              <a:t>Red = profitable arbitrage cycle. Total cost shown in info panel.</a:t>
+              <a:t>Red = lowest-cost route found. Doesn’t have to close a cycle —</a:t>
+            </a:r>
+          </a:p>
+          <a:p>
+            <a:pPr algn="l"/>
+            <a:r>
+              <a:rPr sz="1100" b="0" i="1">
+                <a:solidFill>
+                  <a:srgbClr val="595959"/>
+                </a:solidFill>
+                <a:latin typeface="Helvetica Neue"/>
+              </a:rPr>
+              <a:t>a one-way path can be profitable too (e.g. rebalancing, one-off transfers).</a:t>
             </a:r>
           </a:p>
         </p:txBody>
@@ -4482,7 +4494,7 @@
                 </a:solidFill>
                 <a:latin typeface="Helvetica Neue"/>
               </a:rPr>
-              <a:t>•  Stablecoins = crypto pegged to $1 — tiny cross-exchange price gaps exist</a:t>
+              <a:t>•  Stablecoins = crypto pegged to fiat (USD, EUR, etc.) — tiny cross-exchange gaps exist</a:t>
             </a:r>
           </a:p>
           <a:p>
@@ -4498,7 +4510,23 @@
                 </a:solidFill>
                 <a:latin typeface="Helvetica Neue"/>
               </a:rPr>
-              <a:t>•  Model as a graph → arbitrage = finding a profitable cycle</a:t>
+              <a:t>•  Model as a graph → arbitrage = finding a profitable path</a:t>
+            </a:r>
+          </a:p>
+          <a:p>
+            <a:pPr>
+              <a:spcAft>
+                <a:spcPts val="800"/>
+              </a:spcAft>
+            </a:pPr>
+            <a:r>
+              <a:rPr sz="1600">
+                <a:solidFill>
+                  <a:srgbClr val="000000"/>
+                </a:solidFill>
+                <a:latin typeface="Helvetica Neue"/>
+              </a:rPr>
+              <a:t>•  The path can close a cycle back to start, or just end at a cheaper destination — both count</a:t>
             </a:r>
           </a:p>
           <a:p>
@@ -5290,7 +5318,7 @@
         <p:spPr>
           <a:xfrm>
             <a:off x="548640" y="1188720"/>
-            <a:ext cx="4389120" cy="1828800"/>
+            <a:ext cx="4389120" cy="2194560"/>
           </a:xfrm>
           <a:prstGeom prst="rect">
             <a:avLst/>
@@ -5309,13 +5337,13 @@
               </a:spcAft>
             </a:pPr>
             <a:r>
-              <a:rPr sz="1500">
+              <a:rPr sz="1400">
                 <a:solidFill>
                   <a:srgbClr val="000000"/>
                 </a:solidFill>
                 <a:latin typeface="Helvetica Neue"/>
               </a:rPr>
-              <a:t>•  Crypto tokens pegged to $1.00 USD</a:t>
+              <a:t>•  Crypto tokens pegged to a fiat currency</a:t>
             </a:r>
           </a:p>
           <a:p>
@@ -5325,13 +5353,23 @@
               </a:spcAft>
             </a:pPr>
             <a:r>
-              <a:rPr sz="1500">
+              <a:rPr sz="1400">
                 <a:solidFill>
                   <a:srgbClr val="000000"/>
                 </a:solidFill>
                 <a:latin typeface="Helvetica Neue"/>
               </a:rPr>
-              <a:t>•  Backed by real reserves (cash, treasuries)</a:t>
+              <a:t>•  Not just USD — EUR, GBP, CAD, JPY</a:t>
+            </a:r>
+            <a:br/>
+            <a:r>
+              <a:rPr sz="1400">
+                <a:solidFill>
+                  <a:srgbClr val="000000"/>
+                </a:solidFill>
+                <a:latin typeface="Helvetica Neue"/>
+              </a:rPr>
+              <a:t>stablecoins exist too (e.g. EURC, EURT)</a:t>
             </a:r>
           </a:p>
           <a:p>
@@ -5341,7 +5379,23 @@
               </a:spcAft>
             </a:pPr>
             <a:r>
-              <a:rPr sz="1500">
+              <a:rPr sz="1400">
+                <a:solidFill>
+                  <a:srgbClr val="000000"/>
+                </a:solidFill>
+                <a:latin typeface="Helvetica Neue"/>
+              </a:rPr>
+              <a:t>•  Backed by real reserves (cash, treasuries)</a:t>
+            </a:r>
+          </a:p>
+          <a:p>
+            <a:pPr>
+              <a:spcAft>
+                <a:spcPts val="800"/>
+              </a:spcAft>
+            </a:pPr>
+            <a:r>
+              <a:rPr sz="1400">
                 <a:solidFill>
                   <a:srgbClr val="000000"/>
                 </a:solidFill>
@@ -5361,7 +5415,7 @@
         <p:spPr>
           <a:xfrm>
             <a:off x="5029200" y="1188720"/>
-            <a:ext cx="3840480" cy="640080"/>
+            <a:ext cx="3840480" cy="566928"/>
           </a:xfrm>
           <a:prstGeom prst="roundRect">
             <a:avLst/>
@@ -5404,7 +5458,7 @@
         </p:nvSpPr>
         <p:spPr>
           <a:xfrm>
-            <a:off x="5212080" y="1280160"/>
+            <a:off x="5212080" y="1243584"/>
             <a:ext cx="2560320" cy="457200"/>
           </a:xfrm>
           <a:prstGeom prst="rect">
@@ -5420,7 +5474,7 @@
           <a:p>
             <a:pPr algn="l"/>
             <a:r>
-              <a:rPr sz="1300" b="1" i="0">
+              <a:rPr sz="1200" b="1" i="0">
                 <a:solidFill>
                   <a:srgbClr val="000000"/>
                 </a:solidFill>
@@ -5439,7 +5493,7 @@
         </p:nvSpPr>
         <p:spPr>
           <a:xfrm>
-            <a:off x="7772400" y="1280160"/>
+            <a:off x="7772400" y="1243584"/>
             <a:ext cx="914400" cy="457200"/>
           </a:xfrm>
           <a:prstGeom prst="rect">
@@ -5455,7 +5509,7 @@
           <a:p>
             <a:pPr algn="l"/>
             <a:r>
-              <a:rPr sz="1400" b="1" i="0">
+              <a:rPr sz="1300" b="1" i="0">
                 <a:solidFill>
                   <a:srgbClr val="173482"/>
                 </a:solidFill>
@@ -5474,8 +5528,8 @@
         </p:nvSpPr>
         <p:spPr>
           <a:xfrm>
-            <a:off x="5029200" y="2057400"/>
-            <a:ext cx="3840480" cy="640080"/>
+            <a:off x="5029200" y="1901952"/>
+            <a:ext cx="3840480" cy="566928"/>
           </a:xfrm>
           <a:prstGeom prst="roundRect">
             <a:avLst/>
@@ -5518,7 +5572,7 @@
         </p:nvSpPr>
         <p:spPr>
           <a:xfrm>
-            <a:off x="5212080" y="2148840"/>
+            <a:off x="5212080" y="1956816"/>
             <a:ext cx="2560320" cy="457200"/>
           </a:xfrm>
           <a:prstGeom prst="rect">
@@ -5534,7 +5588,7 @@
           <a:p>
             <a:pPr algn="l"/>
             <a:r>
-              <a:rPr sz="1300" b="1" i="0">
+              <a:rPr sz="1200" b="1" i="0">
                 <a:solidFill>
                   <a:srgbClr val="000000"/>
                 </a:solidFill>
@@ -5553,7 +5607,7 @@
         </p:nvSpPr>
         <p:spPr>
           <a:xfrm>
-            <a:off x="7772400" y="2148840"/>
+            <a:off x="7772400" y="1956816"/>
             <a:ext cx="914400" cy="457200"/>
           </a:xfrm>
           <a:prstGeom prst="rect">
@@ -5569,7 +5623,7 @@
           <a:p>
             <a:pPr algn="l"/>
             <a:r>
-              <a:rPr sz="1400" b="1" i="0">
+              <a:rPr sz="1300" b="1" i="0">
                 <a:solidFill>
                   <a:srgbClr val="173482"/>
                 </a:solidFill>
@@ -5588,8 +5642,8 @@
         </p:nvSpPr>
         <p:spPr>
           <a:xfrm>
-            <a:off x="5029200" y="2926080"/>
-            <a:ext cx="3840480" cy="640080"/>
+            <a:off x="5029200" y="2615184"/>
+            <a:ext cx="3840480" cy="566928"/>
           </a:xfrm>
           <a:prstGeom prst="roundRect">
             <a:avLst/>
@@ -5632,7 +5686,7 @@
         </p:nvSpPr>
         <p:spPr>
           <a:xfrm>
-            <a:off x="5212080" y="3017520"/>
+            <a:off x="5212080" y="2670048"/>
             <a:ext cx="2560320" cy="457200"/>
           </a:xfrm>
           <a:prstGeom prst="rect">
@@ -5648,7 +5702,7 @@
           <a:p>
             <a:pPr algn="l"/>
             <a:r>
-              <a:rPr sz="1300" b="1" i="0">
+              <a:rPr sz="1200" b="1" i="0">
                 <a:solidFill>
                   <a:srgbClr val="000000"/>
                 </a:solidFill>
@@ -5667,7 +5721,7 @@
         </p:nvSpPr>
         <p:spPr>
           <a:xfrm>
-            <a:off x="7772400" y="3017520"/>
+            <a:off x="7772400" y="2670048"/>
             <a:ext cx="914400" cy="457200"/>
           </a:xfrm>
           <a:prstGeom prst="rect">
@@ -5683,7 +5737,7 @@
           <a:p>
             <a:pPr algn="l"/>
             <a:r>
-              <a:rPr sz="1400" b="1" i="0">
+              <a:rPr sz="1300" b="1" i="0">
                 <a:solidFill>
                   <a:srgbClr val="173482"/>
                 </a:solidFill>
@@ -5702,8 +5756,8 @@
         </p:nvSpPr>
         <p:spPr>
           <a:xfrm>
-            <a:off x="5029200" y="3794759"/>
-            <a:ext cx="3840480" cy="640080"/>
+            <a:off x="5029200" y="3328416"/>
+            <a:ext cx="3840480" cy="566928"/>
           </a:xfrm>
           <a:prstGeom prst="roundRect">
             <a:avLst/>
@@ -5746,7 +5800,7 @@
         </p:nvSpPr>
         <p:spPr>
           <a:xfrm>
-            <a:off x="5212080" y="3886199"/>
+            <a:off x="5212080" y="3383280"/>
             <a:ext cx="2560320" cy="457200"/>
           </a:xfrm>
           <a:prstGeom prst="rect">
@@ -5762,13 +5816,13 @@
           <a:p>
             <a:pPr algn="l"/>
             <a:r>
-              <a:rPr sz="1300" b="1" i="0">
+              <a:rPr sz="1200" b="1" i="0">
                 <a:solidFill>
                   <a:srgbClr val="000000"/>
                 </a:solidFill>
                 <a:latin typeface="Helvetica Neue"/>
               </a:rPr>
-              <a:t>FDUSD (Binance)</a:t>
+              <a:t>EURC  (Circle, EUR)</a:t>
             </a:r>
           </a:p>
         </p:txBody>
@@ -5781,7 +5835,7 @@
         </p:nvSpPr>
         <p:spPr>
           <a:xfrm>
-            <a:off x="7772400" y="3886199"/>
+            <a:off x="7772400" y="3383280"/>
             <a:ext cx="914400" cy="457200"/>
           </a:xfrm>
           <a:prstGeom prst="rect">
@@ -5797,27 +5851,71 @@
           <a:p>
             <a:pPr algn="l"/>
             <a:r>
-              <a:rPr sz="1400" b="1" i="0">
+              <a:rPr sz="1300" b="1" i="0">
                 <a:solidFill>
                   <a:srgbClr val="173482"/>
                 </a:solidFill>
                 <a:latin typeface="Helvetica Neue"/>
               </a:rPr>
-              <a:t>$0.9988</a:t>
-            </a:r>
-          </a:p>
-        </p:txBody>
-      </p:sp>
-      <p:sp>
-        <p:nvSpPr>
-          <p:cNvPr id="17" name="TextBox 16"/>
+              <a:t>€1.0002</a:t>
+            </a:r>
+          </a:p>
+        </p:txBody>
+      </p:sp>
+      <p:sp>
+        <p:nvSpPr>
+          <p:cNvPr id="17" name="Rounded Rectangle 16"/>
+          <p:cNvSpPr/>
+          <p:nvPr/>
+        </p:nvSpPr>
+        <p:spPr>
+          <a:xfrm>
+            <a:off x="5029200" y="4041648"/>
+            <a:ext cx="3840480" cy="566928"/>
+          </a:xfrm>
+          <a:prstGeom prst="roundRect">
+            <a:avLst/>
+          </a:prstGeom>
+          <a:solidFill>
+            <a:srgbClr val="B6E3EE"/>
+          </a:solidFill>
+          <a:ln>
+            <a:noFill/>
+          </a:ln>
+          <a:effectLst/>
+        </p:spPr>
+        <p:style>
+          <a:lnRef idx="1">
+            <a:schemeClr val="accent1"/>
+          </a:lnRef>
+          <a:fillRef idx="3">
+            <a:schemeClr val="accent1"/>
+          </a:fillRef>
+          <a:effectRef idx="2">
+            <a:schemeClr val="accent1"/>
+          </a:effectRef>
+          <a:fontRef idx="minor">
+            <a:schemeClr val="lt1"/>
+          </a:fontRef>
+        </p:style>
+        <p:txBody>
+          <a:bodyPr rtlCol="0" anchor="ctr"/>
+          <a:lstStyle/>
+          <a:p>
+            <a:pPr algn="ctr"/>
+          </a:p>
+        </p:txBody>
+      </p:sp>
+      <p:sp>
+        <p:nvSpPr>
+          <p:cNvPr id="18" name="TextBox 17"/>
           <p:cNvSpPr txBox="1"/>
           <p:nvPr/>
         </p:nvSpPr>
         <p:spPr>
           <a:xfrm>
-            <a:off x="457200" y="4297680"/>
-            <a:ext cx="8229600" cy="457200"/>
+            <a:off x="5212080" y="4096512"/>
+            <a:ext cx="2560320" cy="457200"/>
           </a:xfrm>
           <a:prstGeom prst="rect">
             <a:avLst/>
@@ -5830,6 +5928,76 @@
           </a:bodyPr>
           <a:lstStyle/>
           <a:p>
+            <a:pPr algn="l"/>
+            <a:r>
+              <a:rPr sz="1200" b="1" i="0">
+                <a:solidFill>
+                  <a:srgbClr val="000000"/>
+                </a:solidFill>
+                <a:latin typeface="Helvetica Neue"/>
+              </a:rPr>
+              <a:t>EURT  (Tether, EUR)</a:t>
+            </a:r>
+          </a:p>
+        </p:txBody>
+      </p:sp>
+      <p:sp>
+        <p:nvSpPr>
+          <p:cNvPr id="19" name="TextBox 18"/>
+          <p:cNvSpPr txBox="1"/>
+          <p:nvPr/>
+        </p:nvSpPr>
+        <p:spPr>
+          <a:xfrm>
+            <a:off x="7772400" y="4096512"/>
+            <a:ext cx="914400" cy="457200"/>
+          </a:xfrm>
+          <a:prstGeom prst="rect">
+            <a:avLst/>
+          </a:prstGeom>
+          <a:noFill/>
+        </p:spPr>
+        <p:txBody>
+          <a:bodyPr wrap="square">
+            <a:spAutoFit/>
+          </a:bodyPr>
+          <a:lstStyle/>
+          <a:p>
+            <a:pPr algn="l"/>
+            <a:r>
+              <a:rPr sz="1300" b="1" i="0">
+                <a:solidFill>
+                  <a:srgbClr val="173482"/>
+                </a:solidFill>
+                <a:latin typeface="Helvetica Neue"/>
+              </a:rPr>
+              <a:t>€0.9995</a:t>
+            </a:r>
+          </a:p>
+        </p:txBody>
+      </p:sp>
+      <p:sp>
+        <p:nvSpPr>
+          <p:cNvPr id="20" name="TextBox 19"/>
+          <p:cNvSpPr txBox="1"/>
+          <p:nvPr/>
+        </p:nvSpPr>
+        <p:spPr>
+          <a:xfrm>
+            <a:off x="457200" y="4297680"/>
+            <a:ext cx="8229600" cy="457200"/>
+          </a:xfrm>
+          <a:prstGeom prst="rect">
+            <a:avLst/>
+          </a:prstGeom>
+          <a:noFill/>
+        </p:spPr>
+        <p:txBody>
+          <a:bodyPr wrap="square">
+            <a:spAutoFit/>
+          </a:bodyPr>
+          <a:lstStyle/>
+          <a:p>
             <a:pPr algn="ctr"/>
             <a:r>
               <a:rPr sz="1300" b="0" i="1">
@@ -5838,14 +6006,14 @@
                 </a:solidFill>
                 <a:latin typeface="Helvetica Neue"/>
               </a:rPr>
-              <a:t>These tiny deviations from $1.00 across exchanges = our arbitrage signal</a:t>
-            </a:r>
-          </a:p>
-        </p:txBody>
-      </p:sp>
-      <p:sp>
-        <p:nvSpPr>
-          <p:cNvPr id="18" name="TextBox 17"/>
+              <a:t>Cross-currency arbitrage is possible too: USD-pegged vs. EUR-pegged coins</a:t>
+            </a:r>
+          </a:p>
+        </p:txBody>
+      </p:sp>
+      <p:sp>
+        <p:nvSpPr>
+          <p:cNvPr id="21" name="TextBox 20"/>
           <p:cNvSpPr txBox="1"/>
           <p:nvPr/>
         </p:nvSpPr>
@@ -5978,7 +6146,7 @@
                 </a:solidFill>
                 <a:latin typeface="Helvetica Neue"/>
               </a:rPr>
-              <a:t>How Do They Stay at $1.00?</a:t>
+              <a:t>How Do They Stay Pegged?</a:t>
             </a:r>
           </a:p>
         </p:txBody>
@@ -6013,7 +6181,7 @@
                 </a:solidFill>
                 <a:latin typeface="Helvetica Neue"/>
               </a:rPr>
-              <a:t>Three pegging mechanisms</a:t>
+              <a:t>Three mechanisms — works for USD, EUR, GBP, CAD, etc.</a:t>
             </a:r>
           </a:p>
         </p:txBody>
@@ -6104,7 +6272,7 @@
                 </a:solidFill>
                 <a:latin typeface="Helvetica Neue"/>
               </a:rPr>
-              <a:t>(USDT, USDC)</a:t>
+              <a:t>(USDT, EURC)</a:t>
             </a:r>
           </a:p>
           <a:p>
@@ -6119,7 +6287,7 @@
                 </a:solidFill>
                 <a:latin typeface="Helvetica Neue"/>
               </a:rPr>
-              <a:t>1:1 reserve of USD in</a:t>
+              <a:t>1:1 reserve of fiat cash</a:t>
             </a:r>
           </a:p>
           <a:p>
@@ -6131,7 +6299,7 @@
                 </a:solidFill>
                 <a:latin typeface="Helvetica Neue"/>
               </a:rPr>
-              <a:t>bank accounts + T-bills.</a:t>
+              <a:t>in bank accounts + bonds.</a:t>
             </a:r>
           </a:p>
           <a:p>
@@ -6143,7 +6311,7 @@
                 </a:solidFill>
                 <a:latin typeface="Helvetica Neue"/>
               </a:rPr>
-              <a:t>Redeem anytime for $1.</a:t>
+              <a:t>Redeem anytime at par.</a:t>
             </a:r>
           </a:p>
         </p:txBody>
@@ -7197,7 +7365,7 @@
                 </a:solidFill>
                 <a:latin typeface="Helvetica Neue"/>
               </a:rPr>
-              <a:t>•  Goal: find lowest-cost</a:t>
+              <a:t>•  Goal: find lowest-cost path</a:t>
             </a:r>
             <a:br/>
             <a:r>
@@ -7207,7 +7375,27 @@
                 </a:solidFill>
                 <a:latin typeface="Helvetica Neue"/>
               </a:rPr>
-              <a:t>  cycle back to start</a:t>
+              <a:t>  — a closed cycle back to</a:t>
+            </a:r>
+            <a:br/>
+            <a:r>
+              <a:rPr sz="1200">
+                <a:solidFill>
+                  <a:srgbClr val="000000"/>
+                </a:solidFill>
+                <a:latin typeface="Helvetica Neue"/>
+              </a:rPr>
+              <a:t>  start, OR just the cheapest</a:t>
+            </a:r>
+            <a:br/>
+            <a:r>
+              <a:rPr sz="1200">
+                <a:solidFill>
+                  <a:srgbClr val="000000"/>
+                </a:solidFill>
+                <a:latin typeface="Helvetica Neue"/>
+              </a:rPr>
+              <a:t>  route between two nodes</a:t>
             </a:r>
           </a:p>
         </p:txBody>

</xml_diff>

<commit_message>
fix: shrink oversized graph image on slide 6, add real-world-costs slide
- Slide 6 image now fit-to-box (max 5.7x4.1in) instead of overflowing the slide
- New slide 7: Why Shortest-Path Isn't Enough - Fees, Slippage, Latency,
  Operational risk (ported from the original GSS research deck)
- Renumbered all subsequent slides (16 slides total)
</commit_message>
<xml_diff>
--- a/astar_arbitrage_deck.pptx
+++ b/astar_arbitrage_deck.pptx
@@ -20,6 +20,7 @@
     <p:sldId id="268" r:id="rId19"/>
     <p:sldId id="269" r:id="rId20"/>
     <p:sldId id="270" r:id="rId21"/>
+    <p:sldId id="271" r:id="rId22"/>
   </p:sldIdLst>
   <p:sldSz cx="9144000" cy="5143500" type="screen4x3"/>
   <p:notesSz cx="6858000" cy="9144000"/>
@@ -3350,7 +3351,7 @@
                 </a:solidFill>
                 <a:latin typeface="Helvetica Neue"/>
               </a:rPr>
-              <a:t>A* Step 3: Expanding Neighbors</a:t>
+              <a:t>A* Step 1: Start Node</a:t>
             </a:r>
           </a:p>
         </p:txBody>
@@ -3385,14 +3386,14 @@
                 </a:solidFill>
                 <a:latin typeface="Helvetica Neue"/>
               </a:rPr>
-              <a:t>Cheap, low-slippage paths explored first. Fee labels (bps) on each edge.</a:t>
+              <a:t>Begin at Binance:USDT. Orange = edges just pushed to priority queue.</a:t>
             </a:r>
           </a:p>
         </p:txBody>
       </p:sp>
       <p:pic>
         <p:nvPicPr>
-          <p:cNvPr id="5" name="Picture 4" descr="frame_02_step10.png"/>
+          <p:cNvPr id="5" name="Picture 4" descr="frame_00_step01.png"/>
           <p:cNvPicPr>
             <a:picLocks noChangeAspect="1"/>
           </p:cNvPicPr>
@@ -3549,7 +3550,7 @@
                 </a:solidFill>
                 <a:latin typeface="Helvetica Neue"/>
               </a:rPr>
-              <a:t>A* Mid-Search</a:t>
+              <a:t>A* Step 3: Expanding Neighbors</a:t>
             </a:r>
           </a:p>
         </p:txBody>
@@ -3584,14 +3585,14 @@
                 </a:solidFill>
                 <a:latin typeface="Helvetica Neue"/>
               </a:rPr>
-              <a:t>Bybit and Kraken reached. High time-risk paths to OKX deprioritized.</a:t>
+              <a:t>Cheap, low-slippage paths explored first. Fee labels (bps) on each edge.</a:t>
             </a:r>
           </a:p>
         </p:txBody>
       </p:sp>
       <p:pic>
         <p:nvPicPr>
-          <p:cNvPr id="5" name="Picture 4" descr="frame_05_step25.png"/>
+          <p:cNvPr id="5" name="Picture 4" descr="frame_02_step10.png"/>
           <p:cNvPicPr>
             <a:picLocks noChangeAspect="1"/>
           </p:cNvPicPr>
@@ -3748,7 +3749,7 @@
                 </a:solidFill>
                 <a:latin typeface="Helvetica Neue"/>
               </a:rPr>
-              <a:t>A* Nearing Completion</a:t>
+              <a:t>A* Mid-Search</a:t>
             </a:r>
           </a:p>
         </p:txBody>
@@ -3783,14 +3784,14 @@
                 </a:solidFill>
                 <a:latin typeface="Helvetica Neue"/>
               </a:rPr>
-              <a:t>Most nodes expanded. Searching for profitable return path to start.</a:t>
+              <a:t>Bybit and Kraken reached. High time-risk paths to OKX deprioritized.</a:t>
             </a:r>
           </a:p>
         </p:txBody>
       </p:sp>
       <p:pic>
         <p:nvPicPr>
-          <p:cNvPr id="5" name="Picture 4" descr="frame_08_step40.png"/>
+          <p:cNvPr id="5" name="Picture 4" descr="frame_05_step25.png"/>
           <p:cNvPicPr>
             <a:picLocks noChangeAspect="1"/>
           </p:cNvPicPr>
@@ -3947,7 +3948,7 @@
                 </a:solidFill>
                 <a:latin typeface="Helvetica Neue"/>
               </a:rPr>
-              <a:t>A* Final: Profitable Path Found</a:t>
+              <a:t>A* Nearing Completion</a:t>
             </a:r>
           </a:p>
         </p:txBody>
@@ -3982,26 +3983,14 @@
                 </a:solidFill>
                 <a:latin typeface="Helvetica Neue"/>
               </a:rPr>
-              <a:t>Red = lowest-cost route found. Doesn’t have to close a cycle —</a:t>
-            </a:r>
-          </a:p>
-          <a:p>
-            <a:pPr algn="l"/>
-            <a:r>
-              <a:rPr sz="1100" b="0" i="1">
-                <a:solidFill>
-                  <a:srgbClr val="595959"/>
-                </a:solidFill>
-                <a:latin typeface="Helvetica Neue"/>
-              </a:rPr>
-              <a:t>a one-way path can be profitable too (e.g. rebalancing, one-off transfers).</a:t>
+              <a:t>Most nodes expanded. Searching for profitable return path to start.</a:t>
             </a:r>
           </a:p>
         </p:txBody>
       </p:sp>
       <p:pic>
         <p:nvPicPr>
-          <p:cNvPr id="5" name="Picture 4" descr="frame_09_step44.png"/>
+          <p:cNvPr id="5" name="Picture 4" descr="frame_08_step40.png"/>
           <p:cNvPicPr>
             <a:picLocks noChangeAspect="1"/>
           </p:cNvPicPr>
@@ -4136,8 +4125,8 @@
         </p:nvSpPr>
         <p:spPr>
           <a:xfrm>
-            <a:off x="457200" y="256032"/>
-            <a:ext cx="8229600" cy="640080"/>
+            <a:off x="274320" y="164592"/>
+            <a:ext cx="5486400" cy="457200"/>
           </a:xfrm>
           <a:prstGeom prst="rect">
             <a:avLst/>
@@ -4152,13 +4141,13 @@
           <a:p>
             <a:pPr algn="l"/>
             <a:r>
-              <a:rPr sz="2800" b="1" i="0">
+              <a:rPr sz="1800" b="1" i="0">
                 <a:solidFill>
                   <a:srgbClr val="173482"/>
                 </a:solidFill>
                 <a:latin typeface="Helvetica Neue"/>
               </a:rPr>
-              <a:t>The L2 Order Book → Slippage Heuristic</a:t>
+              <a:t>A* Final: Profitable Path Found</a:t>
             </a:r>
           </a:p>
         </p:txBody>
@@ -4171,8 +4160,8 @@
         </p:nvSpPr>
         <p:spPr>
           <a:xfrm>
-            <a:off x="457200" y="1097280"/>
-            <a:ext cx="3657600" cy="3200400"/>
+            <a:off x="274320" y="502920"/>
+            <a:ext cx="8229600" cy="320040"/>
           </a:xfrm>
           <a:prstGeom prst="rect">
             <a:avLst/>
@@ -4185,120 +4174,34 @@
           </a:bodyPr>
           <a:lstStyle/>
           <a:p>
-            <a:pPr>
-              <a:spcAft>
-                <a:spcPts val="800"/>
-              </a:spcAft>
-            </a:pPr>
-            <a:r>
-              <a:rPr sz="1200">
-                <a:solidFill>
-                  <a:srgbClr val="000000"/>
-                </a:solidFill>
-                <a:latin typeface="Helvetica Neue"/>
-              </a:rPr>
-              <a:t>•  20 price levels of depth</a:t>
-            </a:r>
-          </a:p>
-          <a:p>
-            <a:pPr>
-              <a:spcAft>
-                <a:spcPts val="800"/>
-              </a:spcAft>
-            </a:pPr>
-            <a:r>
-              <a:rPr sz="1200">
-                <a:solidFill>
-                  <a:srgbClr val="000000"/>
-                </a:solidFill>
-                <a:latin typeface="Helvetica Neue"/>
-              </a:rPr>
-              <a:t>•  Walk asks for our trade size</a:t>
-            </a:r>
-          </a:p>
-          <a:p>
-            <a:pPr>
-              <a:spcAft>
-                <a:spcPts val="800"/>
-              </a:spcAft>
-            </a:pPr>
-            <a:r>
-              <a:rPr sz="1200">
-                <a:solidFill>
-                  <a:srgbClr val="000000"/>
-                </a:solidFill>
-                <a:latin typeface="Helvetica Neue"/>
-              </a:rPr>
-              <a:t>•  Binance: ~0 bps slippage</a:t>
-            </a:r>
-            <a:br/>
-            <a:r>
-              <a:rPr sz="1200">
-                <a:solidFill>
-                  <a:srgbClr val="000000"/>
-                </a:solidFill>
-                <a:latin typeface="Helvetica Neue"/>
-              </a:rPr>
-              <a:t>  (millions of units at top)</a:t>
-            </a:r>
-          </a:p>
-          <a:p>
-            <a:pPr>
-              <a:spcAft>
-                <a:spcPts val="800"/>
-              </a:spcAft>
-            </a:pPr>
-            <a:r>
-              <a:rPr sz="1200">
-                <a:solidFill>
-                  <a:srgbClr val="000000"/>
-                </a:solidFill>
-                <a:latin typeface="Helvetica Neue"/>
-              </a:rPr>
-              <a:t>•  Gate.io: ~0.5 bps slippage</a:t>
-            </a:r>
-            <a:br/>
-            <a:r>
-              <a:rPr sz="1200">
-                <a:solidFill>
-                  <a:srgbClr val="000000"/>
-                </a:solidFill>
-                <a:latin typeface="Helvetica Neue"/>
-              </a:rPr>
-              <a:t>  (only 6K at top level)</a:t>
-            </a:r>
-          </a:p>
-          <a:p>
-            <a:pPr>
-              <a:spcAft>
-                <a:spcPts val="800"/>
-              </a:spcAft>
-            </a:pPr>
-            <a:r>
-              <a:rPr sz="1200">
-                <a:solidFill>
-                  <a:srgbClr val="000000"/>
-                </a:solidFill>
-                <a:latin typeface="Helvetica Neue"/>
-              </a:rPr>
-              <a:t>•  Thin book = high h(n)</a:t>
-            </a:r>
-            <a:br/>
-            <a:r>
-              <a:rPr sz="1200">
-                <a:solidFill>
-                  <a:srgbClr val="000000"/>
-                </a:solidFill>
-                <a:latin typeface="Helvetica Neue"/>
-              </a:rPr>
-              <a:t>  = A* avoids it</a:t>
+            <a:pPr algn="l"/>
+            <a:r>
+              <a:rPr sz="1100" b="0" i="1">
+                <a:solidFill>
+                  <a:srgbClr val="595959"/>
+                </a:solidFill>
+                <a:latin typeface="Helvetica Neue"/>
+              </a:rPr>
+              <a:t>Red = lowest-cost route found. Doesn’t have to close a cycle —</a:t>
+            </a:r>
+          </a:p>
+          <a:p>
+            <a:pPr algn="l"/>
+            <a:r>
+              <a:rPr sz="1100" b="0" i="1">
+                <a:solidFill>
+                  <a:srgbClr val="595959"/>
+                </a:solidFill>
+                <a:latin typeface="Helvetica Neue"/>
+              </a:rPr>
+              <a:t>a one-way path can be profitable too (e.g. rebalancing, one-off transfers).</a:t>
             </a:r>
           </a:p>
         </p:txBody>
       </p:sp>
       <p:pic>
         <p:nvPicPr>
-          <p:cNvPr id="5" name="Picture 4" descr="astar_arbitrage_demo.png"/>
+          <p:cNvPr id="5" name="Picture 4" descr="frame_09_step44.png"/>
           <p:cNvPicPr>
             <a:picLocks noChangeAspect="1"/>
           </p:cNvPicPr>
@@ -4312,8 +4215,8 @@
         </p:blipFill>
         <p:spPr>
           <a:xfrm>
-            <a:off x="3840480" y="1005840"/>
-            <a:ext cx="5120640" cy="4569768"/>
+            <a:off x="2563208" y="868680"/>
+            <a:ext cx="4017584" cy="4114800"/>
           </a:xfrm>
           <a:prstGeom prst="rect">
             <a:avLst/>
@@ -4455,7 +4358,7 @@
                 </a:solidFill>
                 <a:latin typeface="Helvetica Neue"/>
               </a:rPr>
-              <a:t>Summary</a:t>
+              <a:t>The L2 Order Book → Slippage Heuristic</a:t>
             </a:r>
           </a:p>
         </p:txBody>
@@ -4468,8 +4371,8 @@
         </p:nvSpPr>
         <p:spPr>
           <a:xfrm>
-            <a:off x="548640" y="1188720"/>
-            <a:ext cx="8229600" cy="2743200"/>
+            <a:off x="457200" y="1097280"/>
+            <a:ext cx="3657600" cy="3200400"/>
           </a:xfrm>
           <a:prstGeom prst="rect">
             <a:avLst/>
@@ -4488,13 +4391,13 @@
               </a:spcAft>
             </a:pPr>
             <a:r>
-              <a:rPr sz="1600">
+              <a:rPr sz="1200">
                 <a:solidFill>
                   <a:srgbClr val="000000"/>
                 </a:solidFill>
                 <a:latin typeface="Helvetica Neue"/>
               </a:rPr>
-              <a:t>•  Stablecoins = crypto pegged to fiat (USD, EUR, etc.) — tiny cross-exchange gaps exist</a:t>
+              <a:t>•  20 price levels of depth</a:t>
             </a:r>
           </a:p>
           <a:p>
@@ -4504,13 +4407,13 @@
               </a:spcAft>
             </a:pPr>
             <a:r>
-              <a:rPr sz="1600">
+              <a:rPr sz="1200">
                 <a:solidFill>
                   <a:srgbClr val="000000"/>
                 </a:solidFill>
                 <a:latin typeface="Helvetica Neue"/>
               </a:rPr>
-              <a:t>•  Model as a graph → arbitrage = finding a profitable path</a:t>
+              <a:t>•  Walk asks for our trade size</a:t>
             </a:r>
           </a:p>
           <a:p>
@@ -4520,13 +4423,23 @@
               </a:spcAft>
             </a:pPr>
             <a:r>
-              <a:rPr sz="1600">
+              <a:rPr sz="1200">
                 <a:solidFill>
                   <a:srgbClr val="000000"/>
                 </a:solidFill>
                 <a:latin typeface="Helvetica Neue"/>
               </a:rPr>
-              <a:t>•  The path can close a cycle back to start, or just end at a cheaper destination — both count</a:t>
+              <a:t>•  Binance: ~0 bps slippage</a:t>
+            </a:r>
+            <a:br/>
+            <a:r>
+              <a:rPr sz="1200">
+                <a:solidFill>
+                  <a:srgbClr val="000000"/>
+                </a:solidFill>
+                <a:latin typeface="Helvetica Neue"/>
+              </a:rPr>
+              <a:t>  (millions of units at top)</a:t>
             </a:r>
           </a:p>
           <a:p>
@@ -4536,13 +4449,23 @@
               </a:spcAft>
             </a:pPr>
             <a:r>
-              <a:rPr sz="1600">
+              <a:rPr sz="1200">
                 <a:solidFill>
                   <a:srgbClr val="000000"/>
                 </a:solidFill>
                 <a:latin typeface="Helvetica Neue"/>
               </a:rPr>
-              <a:t>•  A* + slippage heuristic guides search toward deep, fast routes</a:t>
+              <a:t>•  Gate.io: ~0.5 bps slippage</a:t>
+            </a:r>
+            <a:br/>
+            <a:r>
+              <a:rPr sz="1200">
+                <a:solidFill>
+                  <a:srgbClr val="000000"/>
+                </a:solidFill>
+                <a:latin typeface="Helvetica Neue"/>
+              </a:rPr>
+              <a:t>  (only 6K at top level)</a:t>
             </a:r>
           </a:p>
           <a:p>
@@ -4552,27 +4475,61 @@
               </a:spcAft>
             </a:pPr>
             <a:r>
-              <a:rPr sz="1600">
+              <a:rPr sz="1200">
                 <a:solidFill>
                   <a:srgbClr val="000000"/>
                 </a:solidFill>
                 <a:latin typeface="Helvetica Neue"/>
               </a:rPr>
-              <a:t>•  Same optimality as Dijkstra, but focused exploration</a:t>
-            </a:r>
-          </a:p>
-        </p:txBody>
-      </p:sp>
-      <p:sp>
-        <p:nvSpPr>
-          <p:cNvPr id="5" name="TextBox 4"/>
+              <a:t>•  Thin book = high h(n)</a:t>
+            </a:r>
+            <a:br/>
+            <a:r>
+              <a:rPr sz="1200">
+                <a:solidFill>
+                  <a:srgbClr val="000000"/>
+                </a:solidFill>
+                <a:latin typeface="Helvetica Neue"/>
+              </a:rPr>
+              <a:t>  = A* avoids it</a:t>
+            </a:r>
+          </a:p>
+        </p:txBody>
+      </p:sp>
+      <p:pic>
+        <p:nvPicPr>
+          <p:cNvPr id="5" name="Picture 4" descr="astar_arbitrage_demo.png"/>
+          <p:cNvPicPr>
+            <a:picLocks noChangeAspect="1"/>
+          </p:cNvPicPr>
+          <p:nvPr/>
+        </p:nvPicPr>
+        <p:blipFill>
+          <a:blip r:embed="rId2"/>
+          <a:stretch>
+            <a:fillRect/>
+          </a:stretch>
+        </p:blipFill>
+        <p:spPr>
+          <a:xfrm>
+            <a:off x="3840480" y="1005840"/>
+            <a:ext cx="5120640" cy="4569768"/>
+          </a:xfrm>
+          <a:prstGeom prst="rect">
+            <a:avLst/>
+          </a:prstGeom>
+        </p:spPr>
+      </p:pic>
+      <p:sp>
+        <p:nvSpPr>
+          <p:cNvPr id="6" name="TextBox 5"/>
           <p:cNvSpPr txBox="1"/>
           <p:nvPr/>
         </p:nvSpPr>
         <p:spPr>
           <a:xfrm>
-            <a:off x="548640" y="3657600"/>
-            <a:ext cx="8229600" cy="731520"/>
+            <a:off x="8503920" y="4823460"/>
+            <a:ext cx="457200" cy="274320"/>
           </a:xfrm>
           <a:prstGeom prst="rect">
             <a:avLst/>
@@ -4585,41 +4542,99 @@
           </a:bodyPr>
           <a:lstStyle/>
           <a:p>
-            <a:pPr algn="l"/>
-            <a:r>
-              <a:rPr sz="1200" b="0" i="1">
+            <a:pPr algn="r"/>
+            <a:r>
+              <a:rPr sz="1000" b="0" i="0">
                 <a:solidFill>
                   <a:srgbClr val="595959"/>
                 </a:solidFill>
                 <a:latin typeface="Helvetica Neue"/>
               </a:rPr>
-              <a:t>Code: scripts/animate_astar_search.py</a:t>
-            </a:r>
-          </a:p>
-          <a:p>
-            <a:pPr algn="l"/>
-            <a:r>
-              <a:rPr sz="1200" b="0" i="1">
-                <a:solidFill>
-                  <a:srgbClr val="595959"/>
-                </a:solidFill>
-                <a:latin typeface="Helvetica Neue"/>
-              </a:rPr>
-              <a:t>UI: streamlit run scripts/ui.py</a:t>
-            </a:r>
-          </a:p>
-        </p:txBody>
-      </p:sp>
-      <p:sp>
-        <p:nvSpPr>
-          <p:cNvPr id="6" name="TextBox 5"/>
+              <a:t>15</a:t>
+            </a:r>
+          </a:p>
+        </p:txBody>
+      </p:sp>
+    </p:spTree>
+  </p:cSld>
+  <p:clrMapOvr>
+    <a:masterClrMapping/>
+  </p:clrMapOvr>
+</p:sld>
+</file>
+
+<file path=ppt/slides/slide16.xml><?xml version="1.0" encoding="utf-8"?>
+<p:sld xmlns:a="http://schemas.openxmlformats.org/drawingml/2006/main" xmlns:p="http://schemas.openxmlformats.org/presentationml/2006/main" xmlns:r="http://schemas.openxmlformats.org/officeDocument/2006/relationships">
+  <p:cSld>
+    <p:bg>
+      <p:bgPr>
+        <a:solidFill>
+          <a:srgbClr val="FFFFFF"/>
+        </a:solidFill>
+        <a:effectLst/>
+      </p:bgPr>
+    </p:bg>
+    <p:spTree>
+      <p:nvGrpSpPr>
+        <p:cNvPr id="1" name=""/>
+        <p:cNvGrpSpPr/>
+        <p:nvPr/>
+      </p:nvGrpSpPr>
+      <p:grpSpPr/>
+      <p:sp>
+        <p:nvSpPr>
+          <p:cNvPr id="2" name="Rectangle 1"/>
+          <p:cNvSpPr/>
+          <p:nvPr/>
+        </p:nvSpPr>
+        <p:spPr>
+          <a:xfrm>
+            <a:off x="0" y="0"/>
+            <a:ext cx="9144000" cy="109728"/>
+          </a:xfrm>
+          <a:prstGeom prst="rect">
+            <a:avLst/>
+          </a:prstGeom>
+          <a:solidFill>
+            <a:srgbClr val="173482"/>
+          </a:solidFill>
+          <a:ln>
+            <a:noFill/>
+          </a:ln>
+          <a:effectLst/>
+        </p:spPr>
+        <p:style>
+          <a:lnRef idx="1">
+            <a:schemeClr val="accent1"/>
+          </a:lnRef>
+          <a:fillRef idx="3">
+            <a:schemeClr val="accent1"/>
+          </a:fillRef>
+          <a:effectRef idx="2">
+            <a:schemeClr val="accent1"/>
+          </a:effectRef>
+          <a:fontRef idx="minor">
+            <a:schemeClr val="lt1"/>
+          </a:fontRef>
+        </p:style>
+        <p:txBody>
+          <a:bodyPr rtlCol="0" anchor="ctr"/>
+          <a:lstStyle/>
+          <a:p>
+            <a:pPr algn="ctr"/>
+          </a:p>
+        </p:txBody>
+      </p:sp>
+      <p:sp>
+        <p:nvSpPr>
+          <p:cNvPr id="3" name="TextBox 2"/>
           <p:cNvSpPr txBox="1"/>
           <p:nvPr/>
         </p:nvSpPr>
         <p:spPr>
           <a:xfrm>
-            <a:off x="8503920" y="4823460"/>
-            <a:ext cx="457200" cy="274320"/>
+            <a:off x="457200" y="256032"/>
+            <a:ext cx="8229600" cy="640080"/>
           </a:xfrm>
           <a:prstGeom prst="rect">
             <a:avLst/>
@@ -4632,6 +4647,207 @@
           </a:bodyPr>
           <a:lstStyle/>
           <a:p>
+            <a:pPr algn="l"/>
+            <a:r>
+              <a:rPr sz="2800" b="1" i="0">
+                <a:solidFill>
+                  <a:srgbClr val="173482"/>
+                </a:solidFill>
+                <a:latin typeface="Helvetica Neue"/>
+              </a:rPr>
+              <a:t>Summary</a:t>
+            </a:r>
+          </a:p>
+        </p:txBody>
+      </p:sp>
+      <p:sp>
+        <p:nvSpPr>
+          <p:cNvPr id="4" name="TextBox 3"/>
+          <p:cNvSpPr txBox="1"/>
+          <p:nvPr/>
+        </p:nvSpPr>
+        <p:spPr>
+          <a:xfrm>
+            <a:off x="548640" y="1188720"/>
+            <a:ext cx="8229600" cy="2743200"/>
+          </a:xfrm>
+          <a:prstGeom prst="rect">
+            <a:avLst/>
+          </a:prstGeom>
+          <a:noFill/>
+        </p:spPr>
+        <p:txBody>
+          <a:bodyPr wrap="square">
+            <a:spAutoFit/>
+          </a:bodyPr>
+          <a:lstStyle/>
+          <a:p>
+            <a:pPr>
+              <a:spcAft>
+                <a:spcPts val="800"/>
+              </a:spcAft>
+            </a:pPr>
+            <a:r>
+              <a:rPr sz="1500">
+                <a:solidFill>
+                  <a:srgbClr val="000000"/>
+                </a:solidFill>
+                <a:latin typeface="Helvetica Neue"/>
+              </a:rPr>
+              <a:t>•  Stablecoins = crypto pegged to fiat (USD, EUR, etc.) — tiny cross-exchange gaps exist</a:t>
+            </a:r>
+          </a:p>
+          <a:p>
+            <a:pPr>
+              <a:spcAft>
+                <a:spcPts val="800"/>
+              </a:spcAft>
+            </a:pPr>
+            <a:r>
+              <a:rPr sz="1500">
+                <a:solidFill>
+                  <a:srgbClr val="000000"/>
+                </a:solidFill>
+                <a:latin typeface="Helvetica Neue"/>
+              </a:rPr>
+              <a:t>•  Model as a graph → arbitrage = finding a profitable path</a:t>
+            </a:r>
+          </a:p>
+          <a:p>
+            <a:pPr>
+              <a:spcAft>
+                <a:spcPts val="800"/>
+              </a:spcAft>
+            </a:pPr>
+            <a:r>
+              <a:rPr sz="1500">
+                <a:solidFill>
+                  <a:srgbClr val="000000"/>
+                </a:solidFill>
+                <a:latin typeface="Helvetica Neue"/>
+              </a:rPr>
+              <a:t>•  The path can close a cycle back to start, or just end at a cheaper destination — both count</a:t>
+            </a:r>
+          </a:p>
+          <a:p>
+            <a:pPr>
+              <a:spcAft>
+                <a:spcPts val="800"/>
+              </a:spcAft>
+            </a:pPr>
+            <a:r>
+              <a:rPr sz="1500">
+                <a:solidFill>
+                  <a:srgbClr val="000000"/>
+                </a:solidFill>
+                <a:latin typeface="Helvetica Neue"/>
+              </a:rPr>
+              <a:t>•  Real-world costs — fees, slippage, latency, operational risk — shape which paths are worth it</a:t>
+            </a:r>
+          </a:p>
+          <a:p>
+            <a:pPr>
+              <a:spcAft>
+                <a:spcPts val="800"/>
+              </a:spcAft>
+            </a:pPr>
+            <a:r>
+              <a:rPr sz="1500">
+                <a:solidFill>
+                  <a:srgbClr val="000000"/>
+                </a:solidFill>
+                <a:latin typeface="Helvetica Neue"/>
+              </a:rPr>
+              <a:t>•  A* + slippage heuristic guides search toward deep, fast routes</a:t>
+            </a:r>
+          </a:p>
+          <a:p>
+            <a:pPr>
+              <a:spcAft>
+                <a:spcPts val="800"/>
+              </a:spcAft>
+            </a:pPr>
+            <a:r>
+              <a:rPr sz="1500">
+                <a:solidFill>
+                  <a:srgbClr val="000000"/>
+                </a:solidFill>
+                <a:latin typeface="Helvetica Neue"/>
+              </a:rPr>
+              <a:t>•  Same optimality as Dijkstra, but focused exploration</a:t>
+            </a:r>
+          </a:p>
+        </p:txBody>
+      </p:sp>
+      <p:sp>
+        <p:nvSpPr>
+          <p:cNvPr id="5" name="TextBox 4"/>
+          <p:cNvSpPr txBox="1"/>
+          <p:nvPr/>
+        </p:nvSpPr>
+        <p:spPr>
+          <a:xfrm>
+            <a:off x="548640" y="3657600"/>
+            <a:ext cx="8229600" cy="731520"/>
+          </a:xfrm>
+          <a:prstGeom prst="rect">
+            <a:avLst/>
+          </a:prstGeom>
+          <a:noFill/>
+        </p:spPr>
+        <p:txBody>
+          <a:bodyPr wrap="square">
+            <a:spAutoFit/>
+          </a:bodyPr>
+          <a:lstStyle/>
+          <a:p>
+            <a:pPr algn="l"/>
+            <a:r>
+              <a:rPr sz="1200" b="0" i="1">
+                <a:solidFill>
+                  <a:srgbClr val="595959"/>
+                </a:solidFill>
+                <a:latin typeface="Helvetica Neue"/>
+              </a:rPr>
+              <a:t>Code: scripts/animate_astar_search.py</a:t>
+            </a:r>
+          </a:p>
+          <a:p>
+            <a:pPr algn="l"/>
+            <a:r>
+              <a:rPr sz="1200" b="0" i="1">
+                <a:solidFill>
+                  <a:srgbClr val="595959"/>
+                </a:solidFill>
+                <a:latin typeface="Helvetica Neue"/>
+              </a:rPr>
+              <a:t>UI: streamlit run scripts/ui.py</a:t>
+            </a:r>
+          </a:p>
+        </p:txBody>
+      </p:sp>
+      <p:sp>
+        <p:nvSpPr>
+          <p:cNvPr id="6" name="TextBox 5"/>
+          <p:cNvSpPr txBox="1"/>
+          <p:nvPr/>
+        </p:nvSpPr>
+        <p:spPr>
+          <a:xfrm>
+            <a:off x="8503920" y="4823460"/>
+            <a:ext cx="457200" cy="274320"/>
+          </a:xfrm>
+          <a:prstGeom prst="rect">
+            <a:avLst/>
+          </a:prstGeom>
+          <a:noFill/>
+        </p:spPr>
+        <p:txBody>
+          <a:bodyPr wrap="square">
+            <a:spAutoFit/>
+          </a:bodyPr>
+          <a:lstStyle/>
+          <a:p>
             <a:pPr algn="r"/>
             <a:r>
               <a:rPr sz="1000" b="0" i="0">
@@ -4640,7 +4856,7 @@
                 </a:solidFill>
                 <a:latin typeface="Helvetica Neue"/>
               </a:rPr>
-              <a:t>15</a:t>
+              <a:t>16</a:t>
             </a:r>
           </a:p>
         </p:txBody>
@@ -7416,8 +7632,8 @@
         </p:blipFill>
         <p:spPr>
           <a:xfrm>
-            <a:off x="3474720" y="1005840"/>
-            <a:ext cx="5486400" cy="5619157"/>
+            <a:off x="3657600" y="1097280"/>
+            <a:ext cx="3660464" cy="3749039"/>
           </a:xfrm>
           <a:prstGeom prst="rect">
             <a:avLst/>
@@ -7559,7 +7775,7 @@
                 </a:solidFill>
                 <a:latin typeface="Helvetica Neue"/>
               </a:rPr>
-              <a:t>Dijkstra: f(n) = g(n)</a:t>
+              <a:t>Why Shortest-Path Isn’t Enough</a:t>
             </a:r>
           </a:p>
         </p:txBody>
@@ -7572,8 +7788,8 @@
         </p:nvSpPr>
         <p:spPr>
           <a:xfrm>
-            <a:off x="548640" y="1188720"/>
-            <a:ext cx="8229600" cy="548640"/>
+            <a:off x="457200" y="749808"/>
+            <a:ext cx="8229600" cy="411480"/>
           </a:xfrm>
           <a:prstGeom prst="rect">
             <a:avLst/>
@@ -7588,62 +7804,27 @@
           <a:p>
             <a:pPr algn="l"/>
             <a:r>
-              <a:rPr sz="1500" b="0" i="0">
-                <a:solidFill>
-                  <a:srgbClr val="000000"/>
-                </a:solidFill>
-                <a:latin typeface="Helvetica Neue"/>
-              </a:rPr>
-              <a:t>Expand the node with the lowest accumulated cost so far</a:t>
-            </a:r>
-          </a:p>
-        </p:txBody>
-      </p:sp>
-      <p:sp>
-        <p:nvSpPr>
-          <p:cNvPr id="5" name="TextBox 4"/>
-          <p:cNvSpPr txBox="1"/>
-          <p:nvPr/>
-        </p:nvSpPr>
-        <p:spPr>
-          <a:xfrm>
-            <a:off x="2743200" y="1828800"/>
-            <a:ext cx="3657600" cy="548640"/>
-          </a:xfrm>
-          <a:prstGeom prst="rect">
-            <a:avLst/>
-          </a:prstGeom>
-          <a:noFill/>
-        </p:spPr>
-        <p:txBody>
-          <a:bodyPr wrap="square">
-            <a:spAutoFit/>
-          </a:bodyPr>
-          <a:lstStyle/>
-          <a:p>
-            <a:pPr algn="ctr"/>
-            <a:r>
-              <a:rPr sz="2800" b="1" i="0">
-                <a:solidFill>
-                  <a:srgbClr val="173482"/>
-                </a:solidFill>
-                <a:latin typeface="Helvetica Neue"/>
-              </a:rPr>
-              <a:t>f(n) = g(n)</a:t>
-            </a:r>
-          </a:p>
-        </p:txBody>
-      </p:sp>
-      <p:sp>
-        <p:nvSpPr>
-          <p:cNvPr id="6" name="Rounded Rectangle 5"/>
+              <a:rPr sz="1400" b="0" i="1">
+                <a:solidFill>
+                  <a:srgbClr val="595959"/>
+                </a:solidFill>
+                <a:latin typeface="Helvetica Neue"/>
+              </a:rPr>
+              <a:t>4 real-world costs a naive graph search ignores</a:t>
+            </a:r>
+          </a:p>
+        </p:txBody>
+      </p:sp>
+      <p:sp>
+        <p:nvSpPr>
+          <p:cNvPr id="5" name="Rounded Rectangle 4"/>
           <p:cNvSpPr/>
           <p:nvPr/>
         </p:nvSpPr>
         <p:spPr>
           <a:xfrm>
-            <a:off x="457200" y="2651760"/>
-            <a:ext cx="3931920" cy="1828800"/>
+            <a:off x="411480" y="1280160"/>
+            <a:ext cx="2651760" cy="2560320"/>
           </a:xfrm>
           <a:prstGeom prst="roundRect">
             <a:avLst/>
@@ -7680,14 +7861,14 @@
       </p:sp>
       <p:sp>
         <p:nvSpPr>
-          <p:cNvPr id="7" name="TextBox 6"/>
+          <p:cNvPr id="6" name="TextBox 5"/>
           <p:cNvSpPr txBox="1"/>
           <p:nvPr/>
         </p:nvSpPr>
         <p:spPr>
           <a:xfrm>
-            <a:off x="640080" y="2743200"/>
-            <a:ext cx="3566160" cy="1645920"/>
+            <a:off x="548640" y="1371600"/>
+            <a:ext cx="2377440" cy="2377440"/>
           </a:xfrm>
           <a:prstGeom prst="rect">
             <a:avLst/>
@@ -7702,57 +7883,84 @@
           <a:p>
             <a:pPr algn="l"/>
             <a:r>
-              <a:rPr sz="1400" b="0" i="0">
+              <a:rPr sz="1200" b="0" i="0">
                 <a:solidFill>
                   <a:srgbClr val="000000"/>
                 </a:solidFill>
                 <a:latin typeface="Helvetica Neue"/>
               </a:rPr>
-              <a:t>✓  Guaranteed optimal</a:t>
-            </a:r>
-          </a:p>
-          <a:p>
-            <a:pPr algn="l"/>
-            <a:r>
-              <a:rPr sz="1400" b="0" i="0">
+              <a:t>1. Fees</a:t>
+            </a:r>
+          </a:p>
+          <a:p>
+            <a:pPr algn="l"/>
+          </a:p>
+          <a:p>
+            <a:pPr algn="l"/>
+            <a:r>
+              <a:rPr sz="1200" b="0" i="0">
                 <a:solidFill>
                   <a:srgbClr val="000000"/>
                 </a:solidFill>
                 <a:latin typeface="Helvetica Neue"/>
               </a:rPr>
-              <a:t>✓  Simple to implement</a:t>
-            </a:r>
-          </a:p>
-          <a:p>
-            <a:pPr algn="l"/>
-            <a:r>
-              <a:rPr sz="1400" b="0" i="0">
+              <a:t>Flat transfer fees apply</a:t>
+            </a:r>
+          </a:p>
+          <a:p>
+            <a:pPr algn="l"/>
+            <a:r>
+              <a:rPr sz="1200" b="0" i="0">
                 <a:solidFill>
                   <a:srgbClr val="000000"/>
                 </a:solidFill>
                 <a:latin typeface="Helvetica Neue"/>
               </a:rPr>
-              <a:t>✓  No domain knowledge needed</a:t>
-            </a:r>
-          </a:p>
-        </p:txBody>
-      </p:sp>
-      <p:sp>
-        <p:nvSpPr>
-          <p:cNvPr id="8" name="Rounded Rectangle 7"/>
+              <a:t>per trade — the order needs</a:t>
+            </a:r>
+          </a:p>
+          <a:p>
+            <a:pPr algn="l"/>
+            <a:r>
+              <a:rPr sz="1200" b="0" i="0">
+                <a:solidFill>
+                  <a:srgbClr val="000000"/>
+                </a:solidFill>
+                <a:latin typeface="Helvetica Neue"/>
+              </a:rPr>
+              <a:t>to be large enough to</a:t>
+            </a:r>
+          </a:p>
+          <a:p>
+            <a:pPr algn="l"/>
+            <a:r>
+              <a:rPr sz="1200" b="0" i="0">
+                <a:solidFill>
+                  <a:srgbClr val="000000"/>
+                </a:solidFill>
+                <a:latin typeface="Helvetica Neue"/>
+              </a:rPr>
+              <a:t>offset them.</a:t>
+            </a:r>
+          </a:p>
+        </p:txBody>
+      </p:sp>
+      <p:sp>
+        <p:nvSpPr>
+          <p:cNvPr id="7" name="Rounded Rectangle 6"/>
           <p:cNvSpPr/>
           <p:nvPr/>
         </p:nvSpPr>
         <p:spPr>
           <a:xfrm>
-            <a:off x="4754880" y="2651760"/>
-            <a:ext cx="3931920" cy="1828800"/>
+            <a:off x="3246120" y="1280160"/>
+            <a:ext cx="2651760" cy="2560320"/>
           </a:xfrm>
           <a:prstGeom prst="roundRect">
             <a:avLst/>
           </a:prstGeom>
           <a:solidFill>
-            <a:srgbClr val="FFEBEE"/>
+            <a:srgbClr val="B6E3EE"/>
           </a:solidFill>
           <a:ln>
             <a:noFill/>
@@ -7783,14 +7991,14 @@
       </p:sp>
       <p:sp>
         <p:nvSpPr>
-          <p:cNvPr id="9" name="TextBox 8"/>
+          <p:cNvPr id="8" name="TextBox 7"/>
           <p:cNvSpPr txBox="1"/>
           <p:nvPr/>
         </p:nvSpPr>
         <p:spPr>
           <a:xfrm>
-            <a:off x="4937760" y="2743200"/>
-            <a:ext cx="3566160" cy="1645920"/>
+            <a:off x="3383280" y="1371600"/>
+            <a:ext cx="2377440" cy="2377440"/>
           </a:xfrm>
           <a:prstGeom prst="rect">
             <a:avLst/>
@@ -7805,56 +8013,292 @@
           <a:p>
             <a:pPr algn="l"/>
             <a:r>
-              <a:rPr sz="1400" b="0" i="0">
+              <a:rPr sz="1200" b="0" i="0">
                 <a:solidFill>
                   <a:srgbClr val="000000"/>
                 </a:solidFill>
                 <a:latin typeface="Helvetica Neue"/>
               </a:rPr>
-              <a:t>✗  Explores blindly</a:t>
-            </a:r>
-          </a:p>
-          <a:p>
-            <a:pPr algn="l"/>
-            <a:r>
-              <a:rPr sz="1400" b="0" i="0">
+              <a:t>2. Slippage</a:t>
+            </a:r>
+          </a:p>
+          <a:p>
+            <a:pPr algn="l"/>
+          </a:p>
+          <a:p>
+            <a:pPr algn="l"/>
+            <a:r>
+              <a:rPr sz="1200" b="0" i="0">
                 <a:solidFill>
                   <a:srgbClr val="000000"/>
                 </a:solidFill>
                 <a:latin typeface="Helvetica Neue"/>
               </a:rPr>
-              <a:t>✗  Ignores slippage risk</a:t>
-            </a:r>
-          </a:p>
-          <a:p>
-            <a:pPr algn="l"/>
-            <a:r>
-              <a:rPr sz="1400" b="0" i="0">
+              <a:t>Asset prices move during</a:t>
+            </a:r>
+          </a:p>
+          <a:p>
+            <a:pPr algn="l"/>
+            <a:r>
+              <a:rPr sz="1200" b="0" i="0">
                 <a:solidFill>
                   <a:srgbClr val="000000"/>
                 </a:solidFill>
                 <a:latin typeface="Helvetica Neue"/>
               </a:rPr>
-              <a:t>✗  Ignores transfer time</a:t>
-            </a:r>
-          </a:p>
-          <a:p>
-            <a:pPr algn="l"/>
-            <a:r>
-              <a:rPr sz="1400" b="0" i="0">
+              <a:t>execution — impacts profit</a:t>
+            </a:r>
+          </a:p>
+          <a:p>
+            <a:pPr algn="l"/>
+            <a:r>
+              <a:rPr sz="1200" b="0" i="0">
                 <a:solidFill>
                   <a:srgbClr val="000000"/>
                 </a:solidFill>
                 <a:latin typeface="Helvetica Neue"/>
               </a:rPr>
-              <a:t>✗  Wastes time on thin books</a:t>
-            </a:r>
+              <a:t>more for larger order</a:t>
+            </a:r>
+          </a:p>
+          <a:p>
+            <a:pPr algn="l"/>
+            <a:r>
+              <a:rPr sz="1200" b="0" i="0">
+                <a:solidFill>
+                  <a:srgbClr val="000000"/>
+                </a:solidFill>
+                <a:latin typeface="Helvetica Neue"/>
+              </a:rPr>
+              <a:t>sizes.</a:t>
+            </a:r>
+          </a:p>
+        </p:txBody>
+      </p:sp>
+      <p:sp>
+        <p:nvSpPr>
+          <p:cNvPr id="9" name="Rounded Rectangle 8"/>
+          <p:cNvSpPr/>
+          <p:nvPr/>
+        </p:nvSpPr>
+        <p:spPr>
+          <a:xfrm>
+            <a:off x="6080760" y="1280160"/>
+            <a:ext cx="2651760" cy="2560320"/>
+          </a:xfrm>
+          <a:prstGeom prst="roundRect">
+            <a:avLst/>
+          </a:prstGeom>
+          <a:solidFill>
+            <a:srgbClr val="EEEEEE"/>
+          </a:solidFill>
+          <a:ln>
+            <a:noFill/>
+          </a:ln>
+          <a:effectLst/>
+        </p:spPr>
+        <p:style>
+          <a:lnRef idx="1">
+            <a:schemeClr val="accent1"/>
+          </a:lnRef>
+          <a:fillRef idx="3">
+            <a:schemeClr val="accent1"/>
+          </a:fillRef>
+          <a:effectRef idx="2">
+            <a:schemeClr val="accent1"/>
+          </a:effectRef>
+          <a:fontRef idx="minor">
+            <a:schemeClr val="lt1"/>
+          </a:fontRef>
+        </p:style>
+        <p:txBody>
+          <a:bodyPr rtlCol="0" anchor="ctr"/>
+          <a:lstStyle/>
+          <a:p>
+            <a:pPr algn="ctr"/>
           </a:p>
         </p:txBody>
       </p:sp>
       <p:sp>
         <p:nvSpPr>
           <p:cNvPr id="10" name="TextBox 9"/>
+          <p:cNvSpPr txBox="1"/>
+          <p:nvPr/>
+        </p:nvSpPr>
+        <p:spPr>
+          <a:xfrm>
+            <a:off x="6217920" y="1371600"/>
+            <a:ext cx="2377440" cy="2377440"/>
+          </a:xfrm>
+          <a:prstGeom prst="rect">
+            <a:avLst/>
+          </a:prstGeom>
+          <a:noFill/>
+        </p:spPr>
+        <p:txBody>
+          <a:bodyPr wrap="square">
+            <a:spAutoFit/>
+          </a:bodyPr>
+          <a:lstStyle/>
+          <a:p>
+            <a:pPr algn="l"/>
+            <a:r>
+              <a:rPr sz="1200" b="0" i="0">
+                <a:solidFill>
+                  <a:srgbClr val="000000"/>
+                </a:solidFill>
+                <a:latin typeface="Helvetica Neue"/>
+              </a:rPr>
+              <a:t>3. Latency</a:t>
+            </a:r>
+          </a:p>
+          <a:p>
+            <a:pPr algn="l"/>
+          </a:p>
+          <a:p>
+            <a:pPr algn="l"/>
+            <a:r>
+              <a:rPr sz="1200" b="0" i="0">
+                <a:solidFill>
+                  <a:srgbClr val="000000"/>
+                </a:solidFill>
+                <a:latin typeface="Helvetica Neue"/>
+              </a:rPr>
+              <a:t>Some blockchains take</a:t>
+            </a:r>
+          </a:p>
+          <a:p>
+            <a:pPr algn="l"/>
+            <a:r>
+              <a:rPr sz="1200" b="0" i="0">
+                <a:solidFill>
+                  <a:srgbClr val="000000"/>
+                </a:solidFill>
+                <a:latin typeface="Helvetica Neue"/>
+              </a:rPr>
+              <a:t>longer to confirm — others</a:t>
+            </a:r>
+          </a:p>
+          <a:p>
+            <a:pPr algn="l"/>
+            <a:r>
+              <a:rPr sz="1200" b="0" i="0">
+                <a:solidFill>
+                  <a:srgbClr val="000000"/>
+                </a:solidFill>
+                <a:latin typeface="Helvetica Neue"/>
+              </a:rPr>
+              <a:t>slow down under</a:t>
+            </a:r>
+          </a:p>
+          <a:p>
+            <a:pPr algn="l"/>
+            <a:r>
+              <a:rPr sz="1200" b="0" i="0">
+                <a:solidFill>
+                  <a:srgbClr val="000000"/>
+                </a:solidFill>
+                <a:latin typeface="Helvetica Neue"/>
+              </a:rPr>
+              <a:t>high volume.</a:t>
+            </a:r>
+          </a:p>
+        </p:txBody>
+      </p:sp>
+      <p:sp>
+        <p:nvSpPr>
+          <p:cNvPr id="11" name="Rounded Rectangle 10"/>
+          <p:cNvSpPr/>
+          <p:nvPr/>
+        </p:nvSpPr>
+        <p:spPr>
+          <a:xfrm>
+            <a:off x="1828800" y="4023360"/>
+            <a:ext cx="2651760" cy="868680"/>
+          </a:xfrm>
+          <a:prstGeom prst="roundRect">
+            <a:avLst/>
+          </a:prstGeom>
+          <a:solidFill>
+            <a:srgbClr val="173482"/>
+          </a:solidFill>
+          <a:ln>
+            <a:noFill/>
+          </a:ln>
+          <a:effectLst/>
+        </p:spPr>
+        <p:style>
+          <a:lnRef idx="1">
+            <a:schemeClr val="accent1"/>
+          </a:lnRef>
+          <a:fillRef idx="3">
+            <a:schemeClr val="accent1"/>
+          </a:fillRef>
+          <a:effectRef idx="2">
+            <a:schemeClr val="accent1"/>
+          </a:effectRef>
+          <a:fontRef idx="minor">
+            <a:schemeClr val="lt1"/>
+          </a:fontRef>
+        </p:style>
+        <p:txBody>
+          <a:bodyPr rtlCol="0" anchor="ctr"/>
+          <a:lstStyle/>
+          <a:p>
+            <a:pPr algn="ctr"/>
+          </a:p>
+        </p:txBody>
+      </p:sp>
+      <p:sp>
+        <p:nvSpPr>
+          <p:cNvPr id="12" name="TextBox 11"/>
+          <p:cNvSpPr txBox="1"/>
+          <p:nvPr/>
+        </p:nvSpPr>
+        <p:spPr>
+          <a:xfrm>
+            <a:off x="1965960" y="4114800"/>
+            <a:ext cx="2377440" cy="685800"/>
+          </a:xfrm>
+          <a:prstGeom prst="rect">
+            <a:avLst/>
+          </a:prstGeom>
+          <a:noFill/>
+        </p:spPr>
+        <p:txBody>
+          <a:bodyPr wrap="square">
+            <a:spAutoFit/>
+          </a:bodyPr>
+          <a:lstStyle/>
+          <a:p>
+            <a:pPr algn="l"/>
+            <a:r>
+              <a:rPr sz="1200" b="0" i="0">
+                <a:solidFill>
+                  <a:srgbClr val="FFFFFF"/>
+                </a:solidFill>
+                <a:latin typeface="Helvetica Neue"/>
+              </a:rPr>
+              <a:t>4. Operational risk — withdrawals may be paused,</a:t>
+            </a:r>
+          </a:p>
+          <a:p>
+            <a:pPr algn="l"/>
+            <a:r>
+              <a:rPr sz="1200" b="0" i="0">
+                <a:solidFill>
+                  <a:srgbClr val="FFFFFF"/>
+                </a:solidFill>
+                <a:latin typeface="Helvetica Neue"/>
+              </a:rPr>
+              <a:t>regions geofenced, or VPNs blocked</a:t>
+            </a:r>
+          </a:p>
+        </p:txBody>
+      </p:sp>
+      <p:sp>
+        <p:nvSpPr>
+          <p:cNvPr id="13" name="TextBox 12"/>
           <p:cNvSpPr txBox="1"/>
           <p:nvPr/>
         </p:nvSpPr>
@@ -7987,7 +8431,7 @@
                 </a:solidFill>
                 <a:latin typeface="Helvetica Neue"/>
               </a:rPr>
-              <a:t>A*: f(n) = g(n) + h(n)</a:t>
+              <a:t>Dijkstra: f(n) = g(n)</a:t>
             </a:r>
           </a:p>
         </p:txBody>
@@ -8022,7 +8466,7 @@
                 </a:solidFill>
                 <a:latin typeface="Helvetica Neue"/>
               </a:rPr>
-              <a:t>Add a heuristic that looks ahead at execution quality</a:t>
+              <a:t>Expand the node with the lowest accumulated cost so far</a:t>
             </a:r>
           </a:p>
         </p:txBody>
@@ -8035,8 +8479,8 @@
         </p:nvSpPr>
         <p:spPr>
           <a:xfrm>
-            <a:off x="2286000" y="1828800"/>
-            <a:ext cx="4572000" cy="548640"/>
+            <a:off x="2743200" y="1828800"/>
+            <a:ext cx="3657600" cy="548640"/>
           </a:xfrm>
           <a:prstGeom prst="rect">
             <a:avLst/>
@@ -8057,7 +8501,7 @@
                 </a:solidFill>
                 <a:latin typeface="Helvetica Neue"/>
               </a:rPr>
-              <a:t>f(n) = g(n) + h(n)</a:t>
+              <a:t>f(n) = g(n)</a:t>
             </a:r>
           </a:p>
         </p:txBody>
@@ -8071,13 +8515,13 @@
         <p:spPr>
           <a:xfrm>
             <a:off x="457200" y="2651760"/>
-            <a:ext cx="8229600" cy="2011680"/>
+            <a:ext cx="3931920" cy="1828800"/>
           </a:xfrm>
           <a:prstGeom prst="roundRect">
             <a:avLst/>
           </a:prstGeom>
           <a:solidFill>
-            <a:srgbClr val="EEEEEE"/>
+            <a:srgbClr val="EAF8F2"/>
           </a:solidFill>
           <a:ln>
             <a:noFill/>
@@ -8114,8 +8558,8 @@
         </p:nvSpPr>
         <p:spPr>
           <a:xfrm>
-            <a:off x="731520" y="2743200"/>
-            <a:ext cx="7680960" cy="1828800"/>
+            <a:off x="640080" y="2743200"/>
+            <a:ext cx="3566160" cy="1645920"/>
           </a:xfrm>
           <a:prstGeom prst="rect">
             <a:avLst/>
@@ -8130,62 +8574,159 @@
           <a:p>
             <a:pPr algn="l"/>
             <a:r>
-              <a:rPr sz="1300" b="0" i="0">
+              <a:rPr sz="1400" b="0" i="0">
                 <a:solidFill>
                   <a:srgbClr val="000000"/>
                 </a:solidFill>
                 <a:latin typeface="Helvetica Neue"/>
               </a:rPr>
-              <a:t>h(n) = slippage(L2 order book) + σ · √(Δt)</a:t>
-            </a:r>
-          </a:p>
-          <a:p>
-            <a:pPr algn="l"/>
-          </a:p>
-          <a:p>
-            <a:pPr algn="l"/>
-            <a:r>
-              <a:rPr sz="1300" b="0" i="0">
+              <a:t>✓  Guaranteed optimal</a:t>
+            </a:r>
+          </a:p>
+          <a:p>
+            <a:pPr algn="l"/>
+            <a:r>
+              <a:rPr sz="1400" b="0" i="0">
                 <a:solidFill>
                   <a:srgbClr val="000000"/>
                 </a:solidFill>
                 <a:latin typeface="Helvetica Neue"/>
               </a:rPr>
-              <a:t>  Slippage:   Walk the ask side for our trade size. Thin book = high cost.</a:t>
-            </a:r>
-          </a:p>
-          <a:p>
-            <a:pPr algn="l"/>
-            <a:r>
-              <a:rPr sz="1300" b="0" i="0">
+              <a:t>✓  Simple to implement</a:t>
+            </a:r>
+          </a:p>
+          <a:p>
+            <a:pPr algn="l"/>
+            <a:r>
+              <a:rPr sz="1400" b="0" i="0">
                 <a:solidFill>
                   <a:srgbClr val="000000"/>
                 </a:solidFill>
                 <a:latin typeface="Helvetica Neue"/>
               </a:rPr>
-              <a:t>  Time risk:  Stablecoin vol (~1.5 bps/min) × transfer duration.</a:t>
-            </a:r>
-          </a:p>
-          <a:p>
-            <a:pPr algn="l"/>
-          </a:p>
-          <a:p>
-            <a:pPr algn="l"/>
-            <a:r>
-              <a:rPr sz="1300" b="0" i="0">
+              <a:t>✓  No domain knowledge needed</a:t>
+            </a:r>
+          </a:p>
+        </p:txBody>
+      </p:sp>
+      <p:sp>
+        <p:nvSpPr>
+          <p:cNvPr id="8" name="Rounded Rectangle 7"/>
+          <p:cNvSpPr/>
+          <p:nvPr/>
+        </p:nvSpPr>
+        <p:spPr>
+          <a:xfrm>
+            <a:off x="4754880" y="2651760"/>
+            <a:ext cx="3931920" cy="1828800"/>
+          </a:xfrm>
+          <a:prstGeom prst="roundRect">
+            <a:avLst/>
+          </a:prstGeom>
+          <a:solidFill>
+            <a:srgbClr val="FFEBEE"/>
+          </a:solidFill>
+          <a:ln>
+            <a:noFill/>
+          </a:ln>
+          <a:effectLst/>
+        </p:spPr>
+        <p:style>
+          <a:lnRef idx="1">
+            <a:schemeClr val="accent1"/>
+          </a:lnRef>
+          <a:fillRef idx="3">
+            <a:schemeClr val="accent1"/>
+          </a:fillRef>
+          <a:effectRef idx="2">
+            <a:schemeClr val="accent1"/>
+          </a:effectRef>
+          <a:fontRef idx="minor">
+            <a:schemeClr val="lt1"/>
+          </a:fontRef>
+        </p:style>
+        <p:txBody>
+          <a:bodyPr rtlCol="0" anchor="ctr"/>
+          <a:lstStyle/>
+          <a:p>
+            <a:pPr algn="ctr"/>
+          </a:p>
+        </p:txBody>
+      </p:sp>
+      <p:sp>
+        <p:nvSpPr>
+          <p:cNvPr id="9" name="TextBox 8"/>
+          <p:cNvSpPr txBox="1"/>
+          <p:nvPr/>
+        </p:nvSpPr>
+        <p:spPr>
+          <a:xfrm>
+            <a:off x="4937760" y="2743200"/>
+            <a:ext cx="3566160" cy="1645920"/>
+          </a:xfrm>
+          <a:prstGeom prst="rect">
+            <a:avLst/>
+          </a:prstGeom>
+          <a:noFill/>
+        </p:spPr>
+        <p:txBody>
+          <a:bodyPr wrap="square">
+            <a:spAutoFit/>
+          </a:bodyPr>
+          <a:lstStyle/>
+          <a:p>
+            <a:pPr algn="l"/>
+            <a:r>
+              <a:rPr sz="1400" b="0" i="0">
                 <a:solidFill>
                   <a:srgbClr val="000000"/>
                 </a:solidFill>
                 <a:latin typeface="Helvetica Neue"/>
               </a:rPr>
-              <a:t>  Deep book + fast transfer → low h → A* explores that path first.</a:t>
-            </a:r>
-          </a:p>
-        </p:txBody>
-      </p:sp>
-      <p:sp>
-        <p:nvSpPr>
-          <p:cNvPr id="8" name="TextBox 7"/>
+              <a:t>✗  Explores blindly</a:t>
+            </a:r>
+          </a:p>
+          <a:p>
+            <a:pPr algn="l"/>
+            <a:r>
+              <a:rPr sz="1400" b="0" i="0">
+                <a:solidFill>
+                  <a:srgbClr val="000000"/>
+                </a:solidFill>
+                <a:latin typeface="Helvetica Neue"/>
+              </a:rPr>
+              <a:t>✗  Ignores slippage risk</a:t>
+            </a:r>
+          </a:p>
+          <a:p>
+            <a:pPr algn="l"/>
+            <a:r>
+              <a:rPr sz="1400" b="0" i="0">
+                <a:solidFill>
+                  <a:srgbClr val="000000"/>
+                </a:solidFill>
+                <a:latin typeface="Helvetica Neue"/>
+              </a:rPr>
+              <a:t>✗  Ignores transfer time</a:t>
+            </a:r>
+          </a:p>
+          <a:p>
+            <a:pPr algn="l"/>
+            <a:r>
+              <a:rPr sz="1400" b="0" i="0">
+                <a:solidFill>
+                  <a:srgbClr val="000000"/>
+                </a:solidFill>
+                <a:latin typeface="Helvetica Neue"/>
+              </a:rPr>
+              <a:t>✗  Wastes time on thin books</a:t>
+            </a:r>
+          </a:p>
+        </p:txBody>
+      </p:sp>
+      <p:sp>
+        <p:nvSpPr>
+          <p:cNvPr id="10" name="TextBox 9"/>
           <p:cNvSpPr txBox="1"/>
           <p:nvPr/>
         </p:nvSpPr>
@@ -8296,8 +8837,8 @@
         </p:nvSpPr>
         <p:spPr>
           <a:xfrm>
-            <a:off x="274320" y="164592"/>
-            <a:ext cx="5486400" cy="457200"/>
+            <a:off x="457200" y="256032"/>
+            <a:ext cx="8229600" cy="640080"/>
           </a:xfrm>
           <a:prstGeom prst="rect">
             <a:avLst/>
@@ -8312,13 +8853,13 @@
           <a:p>
             <a:pPr algn="l"/>
             <a:r>
-              <a:rPr sz="1800" b="1" i="0">
+              <a:rPr sz="2800" b="1" i="0">
                 <a:solidFill>
                   <a:srgbClr val="173482"/>
                 </a:solidFill>
                 <a:latin typeface="Helvetica Neue"/>
               </a:rPr>
-              <a:t>A* Step 1: Start Node</a:t>
+              <a:t>A*: f(n) = g(n) + h(n)</a:t>
             </a:r>
           </a:p>
         </p:txBody>
@@ -8331,8 +8872,8 @@
         </p:nvSpPr>
         <p:spPr>
           <a:xfrm>
-            <a:off x="274320" y="502920"/>
-            <a:ext cx="8229600" cy="320040"/>
+            <a:off x="548640" y="1188720"/>
+            <a:ext cx="8229600" cy="548640"/>
           </a:xfrm>
           <a:prstGeom prst="rect">
             <a:avLst/>
@@ -8347,44 +8888,176 @@
           <a:p>
             <a:pPr algn="l"/>
             <a:r>
-              <a:rPr sz="1100" b="0" i="1">
-                <a:solidFill>
-                  <a:srgbClr val="595959"/>
-                </a:solidFill>
-                <a:latin typeface="Helvetica Neue"/>
-              </a:rPr>
-              <a:t>Begin at Binance:USDT. Orange = edges just pushed to priority queue.</a:t>
-            </a:r>
-          </a:p>
-        </p:txBody>
-      </p:sp>
-      <p:pic>
-        <p:nvPicPr>
-          <p:cNvPr id="5" name="Picture 4" descr="frame_00_step01.png"/>
-          <p:cNvPicPr>
-            <a:picLocks noChangeAspect="1"/>
-          </p:cNvPicPr>
-          <p:nvPr/>
-        </p:nvPicPr>
-        <p:blipFill>
-          <a:blip r:embed="rId2"/>
-          <a:stretch>
-            <a:fillRect/>
-          </a:stretch>
-        </p:blipFill>
-        <p:spPr>
-          <a:xfrm>
-            <a:off x="2563208" y="868680"/>
-            <a:ext cx="4017584" cy="4114800"/>
-          </a:xfrm>
-          <a:prstGeom prst="rect">
-            <a:avLst/>
-          </a:prstGeom>
-        </p:spPr>
-      </p:pic>
-      <p:sp>
-        <p:nvSpPr>
-          <p:cNvPr id="6" name="TextBox 5"/>
+              <a:rPr sz="1500" b="0" i="0">
+                <a:solidFill>
+                  <a:srgbClr val="000000"/>
+                </a:solidFill>
+                <a:latin typeface="Helvetica Neue"/>
+              </a:rPr>
+              <a:t>Add a heuristic that looks ahead at execution quality</a:t>
+            </a:r>
+          </a:p>
+        </p:txBody>
+      </p:sp>
+      <p:sp>
+        <p:nvSpPr>
+          <p:cNvPr id="5" name="TextBox 4"/>
+          <p:cNvSpPr txBox="1"/>
+          <p:nvPr/>
+        </p:nvSpPr>
+        <p:spPr>
+          <a:xfrm>
+            <a:off x="2286000" y="1828800"/>
+            <a:ext cx="4572000" cy="548640"/>
+          </a:xfrm>
+          <a:prstGeom prst="rect">
+            <a:avLst/>
+          </a:prstGeom>
+          <a:noFill/>
+        </p:spPr>
+        <p:txBody>
+          <a:bodyPr wrap="square">
+            <a:spAutoFit/>
+          </a:bodyPr>
+          <a:lstStyle/>
+          <a:p>
+            <a:pPr algn="ctr"/>
+            <a:r>
+              <a:rPr sz="2800" b="1" i="0">
+                <a:solidFill>
+                  <a:srgbClr val="173482"/>
+                </a:solidFill>
+                <a:latin typeface="Helvetica Neue"/>
+              </a:rPr>
+              <a:t>f(n) = g(n) + h(n)</a:t>
+            </a:r>
+          </a:p>
+        </p:txBody>
+      </p:sp>
+      <p:sp>
+        <p:nvSpPr>
+          <p:cNvPr id="6" name="Rounded Rectangle 5"/>
+          <p:cNvSpPr/>
+          <p:nvPr/>
+        </p:nvSpPr>
+        <p:spPr>
+          <a:xfrm>
+            <a:off x="457200" y="2651760"/>
+            <a:ext cx="8229600" cy="2011680"/>
+          </a:xfrm>
+          <a:prstGeom prst="roundRect">
+            <a:avLst/>
+          </a:prstGeom>
+          <a:solidFill>
+            <a:srgbClr val="EEEEEE"/>
+          </a:solidFill>
+          <a:ln>
+            <a:noFill/>
+          </a:ln>
+          <a:effectLst/>
+        </p:spPr>
+        <p:style>
+          <a:lnRef idx="1">
+            <a:schemeClr val="accent1"/>
+          </a:lnRef>
+          <a:fillRef idx="3">
+            <a:schemeClr val="accent1"/>
+          </a:fillRef>
+          <a:effectRef idx="2">
+            <a:schemeClr val="accent1"/>
+          </a:effectRef>
+          <a:fontRef idx="minor">
+            <a:schemeClr val="lt1"/>
+          </a:fontRef>
+        </p:style>
+        <p:txBody>
+          <a:bodyPr rtlCol="0" anchor="ctr"/>
+          <a:lstStyle/>
+          <a:p>
+            <a:pPr algn="ctr"/>
+          </a:p>
+        </p:txBody>
+      </p:sp>
+      <p:sp>
+        <p:nvSpPr>
+          <p:cNvPr id="7" name="TextBox 6"/>
+          <p:cNvSpPr txBox="1"/>
+          <p:nvPr/>
+        </p:nvSpPr>
+        <p:spPr>
+          <a:xfrm>
+            <a:off x="731520" y="2743200"/>
+            <a:ext cx="7680960" cy="1828800"/>
+          </a:xfrm>
+          <a:prstGeom prst="rect">
+            <a:avLst/>
+          </a:prstGeom>
+          <a:noFill/>
+        </p:spPr>
+        <p:txBody>
+          <a:bodyPr wrap="square">
+            <a:spAutoFit/>
+          </a:bodyPr>
+          <a:lstStyle/>
+          <a:p>
+            <a:pPr algn="l"/>
+            <a:r>
+              <a:rPr sz="1300" b="0" i="0">
+                <a:solidFill>
+                  <a:srgbClr val="000000"/>
+                </a:solidFill>
+                <a:latin typeface="Helvetica Neue"/>
+              </a:rPr>
+              <a:t>h(n) = slippage(L2 order book) + σ · √(Δt)</a:t>
+            </a:r>
+          </a:p>
+          <a:p>
+            <a:pPr algn="l"/>
+          </a:p>
+          <a:p>
+            <a:pPr algn="l"/>
+            <a:r>
+              <a:rPr sz="1300" b="0" i="0">
+                <a:solidFill>
+                  <a:srgbClr val="000000"/>
+                </a:solidFill>
+                <a:latin typeface="Helvetica Neue"/>
+              </a:rPr>
+              <a:t>  Slippage:   Walk the ask side for our trade size. Thin book = high cost.</a:t>
+            </a:r>
+          </a:p>
+          <a:p>
+            <a:pPr algn="l"/>
+            <a:r>
+              <a:rPr sz="1300" b="0" i="0">
+                <a:solidFill>
+                  <a:srgbClr val="000000"/>
+                </a:solidFill>
+                <a:latin typeface="Helvetica Neue"/>
+              </a:rPr>
+              <a:t>  Time risk:  Stablecoin vol (~1.5 bps/min) × transfer duration.</a:t>
+            </a:r>
+          </a:p>
+          <a:p>
+            <a:pPr algn="l"/>
+          </a:p>
+          <a:p>
+            <a:pPr algn="l"/>
+            <a:r>
+              <a:rPr sz="1300" b="0" i="0">
+                <a:solidFill>
+                  <a:srgbClr val="000000"/>
+                </a:solidFill>
+                <a:latin typeface="Helvetica Neue"/>
+              </a:rPr>
+              <a:t>  Deep book + fast transfer → low h → A* explores that path first.</a:t>
+            </a:r>
+          </a:p>
+        </p:txBody>
+      </p:sp>
+      <p:sp>
+        <p:nvSpPr>
+          <p:cNvPr id="8" name="TextBox 7"/>
           <p:cNvSpPr txBox="1"/>
           <p:nvPr/>
         </p:nvSpPr>

</xml_diff>

<commit_message>
fix: replace overflowing L2 order-book image with bid/ask table
- Slide 15 no longer embeds the oversized 4-panel figure (was overflowing
  the slide bounds)
- Added a compact bid/ask table comparing Binance (deep book) vs.
  Gate.io (thin book) to demonstrate slippage directly
- Notes that this is what guides h(n), and that Liquidity and
  Latency (chain + venue) heuristic variants were also tested
</commit_message>
<xml_diff>
--- a/astar_arbitrage_deck.pptx
+++ b/astar_arbitrage_deck.pptx
@@ -4371,8 +4371,8 @@
         </p:nvSpPr>
         <p:spPr>
           <a:xfrm>
-            <a:off x="457200" y="1097280"/>
-            <a:ext cx="3657600" cy="3200400"/>
+            <a:off x="411480" y="1097280"/>
+            <a:ext cx="3703320" cy="2468880"/>
           </a:xfrm>
           <a:prstGeom prst="rect">
             <a:avLst/>
@@ -4391,13 +4391,13 @@
               </a:spcAft>
             </a:pPr>
             <a:r>
-              <a:rPr sz="1200">
+              <a:rPr sz="1300">
                 <a:solidFill>
                   <a:srgbClr val="000000"/>
                 </a:solidFill>
                 <a:latin typeface="Helvetica Neue"/>
               </a:rPr>
-              <a:t>•  20 price levels of depth</a:t>
+              <a:t>•  20 price levels of depth per book</a:t>
             </a:r>
           </a:p>
           <a:p>
@@ -4407,13 +4407,23 @@
               </a:spcAft>
             </a:pPr>
             <a:r>
-              <a:rPr sz="1200">
+              <a:rPr sz="1300">
                 <a:solidFill>
                   <a:srgbClr val="000000"/>
                 </a:solidFill>
                 <a:latin typeface="Helvetica Neue"/>
               </a:rPr>
-              <a:t>•  Walk asks for our trade size</a:t>
+              <a:t>•  Walk the asks for our trade size</a:t>
+            </a:r>
+            <a:br/>
+            <a:r>
+              <a:rPr sz="1300">
+                <a:solidFill>
+                  <a:srgbClr val="000000"/>
+                </a:solidFill>
+                <a:latin typeface="Helvetica Neue"/>
+              </a:rPr>
+              <a:t>  → this is what guides h(n)</a:t>
             </a:r>
           </a:p>
           <a:p>
@@ -4423,23 +4433,23 @@
               </a:spcAft>
             </a:pPr>
             <a:r>
-              <a:rPr sz="1200">
+              <a:rPr sz="1300">
                 <a:solidFill>
                   <a:srgbClr val="000000"/>
                 </a:solidFill>
                 <a:latin typeface="Helvetica Neue"/>
               </a:rPr>
-              <a:t>•  Binance: ~0 bps slippage</a:t>
+              <a:t>•  Deep book (Binance) → low slippage</a:t>
             </a:r>
             <a:br/>
             <a:r>
-              <a:rPr sz="1200">
+              <a:rPr sz="1300">
                 <a:solidFill>
                   <a:srgbClr val="000000"/>
                 </a:solidFill>
                 <a:latin typeface="Helvetica Neue"/>
               </a:rPr>
-              <a:t>  (millions of units at top)</a:t>
+              <a:t>  → A* prefers it</a:t>
             </a:r>
           </a:p>
           <a:p>
@@ -4449,80 +4459,692 @@
               </a:spcAft>
             </a:pPr>
             <a:r>
-              <a:rPr sz="1200">
+              <a:rPr sz="1300">
                 <a:solidFill>
                   <a:srgbClr val="000000"/>
                 </a:solidFill>
                 <a:latin typeface="Helvetica Neue"/>
               </a:rPr>
-              <a:t>•  Gate.io: ~0.5 bps slippage</a:t>
+              <a:t>•  Thin book (Gate.io) → high slippage</a:t>
             </a:r>
             <a:br/>
             <a:r>
-              <a:rPr sz="1200">
+              <a:rPr sz="1300">
                 <a:solidFill>
                   <a:srgbClr val="000000"/>
                 </a:solidFill>
                 <a:latin typeface="Helvetica Neue"/>
               </a:rPr>
-              <a:t>  (only 6K at top level)</a:t>
-            </a:r>
-          </a:p>
-          <a:p>
-            <a:pPr>
-              <a:spcAft>
-                <a:spcPts val="800"/>
-              </a:spcAft>
-            </a:pPr>
-            <a:r>
-              <a:rPr sz="1200">
+              <a:t>  → A* avoids it</a:t>
+            </a:r>
+          </a:p>
+        </p:txBody>
+      </p:sp>
+      <p:sp>
+        <p:nvSpPr>
+          <p:cNvPr id="5" name="Rounded Rectangle 4"/>
+          <p:cNvSpPr/>
+          <p:nvPr/>
+        </p:nvSpPr>
+        <p:spPr>
+          <a:xfrm>
+            <a:off x="411480" y="3611880"/>
+            <a:ext cx="3703320" cy="1051560"/>
+          </a:xfrm>
+          <a:prstGeom prst="roundRect">
+            <a:avLst/>
+          </a:prstGeom>
+          <a:solidFill>
+            <a:srgbClr val="EEEEEE"/>
+          </a:solidFill>
+          <a:ln>
+            <a:noFill/>
+          </a:ln>
+          <a:effectLst/>
+        </p:spPr>
+        <p:style>
+          <a:lnRef idx="1">
+            <a:schemeClr val="accent1"/>
+          </a:lnRef>
+          <a:fillRef idx="3">
+            <a:schemeClr val="accent1"/>
+          </a:fillRef>
+          <a:effectRef idx="2">
+            <a:schemeClr val="accent1"/>
+          </a:effectRef>
+          <a:fontRef idx="minor">
+            <a:schemeClr val="lt1"/>
+          </a:fontRef>
+        </p:style>
+        <p:txBody>
+          <a:bodyPr rtlCol="0" anchor="ctr"/>
+          <a:lstStyle/>
+          <a:p>
+            <a:pPr algn="ctr"/>
+          </a:p>
+        </p:txBody>
+      </p:sp>
+      <p:sp>
+        <p:nvSpPr>
+          <p:cNvPr id="6" name="TextBox 5"/>
+          <p:cNvSpPr txBox="1"/>
+          <p:nvPr/>
+        </p:nvSpPr>
+        <p:spPr>
+          <a:xfrm>
+            <a:off x="548640" y="3675887"/>
+            <a:ext cx="3429000" cy="914400"/>
+          </a:xfrm>
+          <a:prstGeom prst="rect">
+            <a:avLst/>
+          </a:prstGeom>
+          <a:noFill/>
+        </p:spPr>
+        <p:txBody>
+          <a:bodyPr wrap="square">
+            <a:spAutoFit/>
+          </a:bodyPr>
+          <a:lstStyle/>
+          <a:p>
+            <a:pPr algn="l"/>
+            <a:r>
+              <a:rPr sz="1200" b="0" i="0">
                 <a:solidFill>
                   <a:srgbClr val="000000"/>
                 </a:solidFill>
                 <a:latin typeface="Helvetica Neue"/>
               </a:rPr>
-              <a:t>•  Thin book = high h(n)</a:t>
-            </a:r>
-            <a:br/>
-            <a:r>
-              <a:rPr sz="1200">
+              <a:t>Also tested h(n) variants penalizing:</a:t>
+            </a:r>
+          </a:p>
+          <a:p>
+            <a:pPr algn="l"/>
+            <a:r>
+              <a:rPr sz="1200" b="0" i="0">
                 <a:solidFill>
                   <a:srgbClr val="000000"/>
                 </a:solidFill>
                 <a:latin typeface="Helvetica Neue"/>
               </a:rPr>
-              <a:t>  = A* avoids it</a:t>
-            </a:r>
-          </a:p>
-        </p:txBody>
-      </p:sp>
-      <p:pic>
-        <p:nvPicPr>
-          <p:cNvPr id="5" name="Picture 4" descr="astar_arbitrage_demo.png"/>
-          <p:cNvPicPr>
-            <a:picLocks noChangeAspect="1"/>
-          </p:cNvPicPr>
-          <p:nvPr/>
-        </p:nvPicPr>
-        <p:blipFill>
-          <a:blip r:embed="rId2"/>
-          <a:stretch>
-            <a:fillRect/>
-          </a:stretch>
-        </p:blipFill>
-        <p:spPr>
-          <a:xfrm>
-            <a:off x="3840480" y="1005840"/>
-            <a:ext cx="5120640" cy="4569768"/>
-          </a:xfrm>
-          <a:prstGeom prst="rect">
-            <a:avLst/>
-          </a:prstGeom>
-        </p:spPr>
-      </p:pic>
-      <p:sp>
-        <p:nvSpPr>
-          <p:cNvPr id="6" name="TextBox 5"/>
+              <a:t>• Liquidity (order book depth)</a:t>
+            </a:r>
+          </a:p>
+          <a:p>
+            <a:pPr algn="l"/>
+            <a:r>
+              <a:rPr sz="1200" b="0" i="0">
+                <a:solidFill>
+                  <a:srgbClr val="000000"/>
+                </a:solidFill>
+                <a:latin typeface="Helvetica Neue"/>
+              </a:rPr>
+              <a:t>• Latency (chain + venue confirm time)</a:t>
+            </a:r>
+          </a:p>
+        </p:txBody>
+      </p:sp>
+      <p:graphicFrame>
+        <p:nvGraphicFramePr>
+          <p:cNvPr id="7" name="Table 6"/>
+          <p:cNvGraphicFramePr>
+            <a:graphicFrameLocks noGrp="1"/>
+          </p:cNvGraphicFramePr>
+          <p:nvPr/>
+        </p:nvGraphicFramePr>
+        <p:xfrm>
+          <a:off x="4434840" y="1143000"/>
+          <a:ext cx="4297680" cy="2468880"/>
+        </p:xfrm>
+        <a:graphic>
+          <a:graphicData uri="http://schemas.openxmlformats.org/drawingml/2006/table">
+            <a:tbl>
+              <a:tblPr firstRow="1" bandRow="1">
+                <a:tableStyleId>{5C22544A-7EE6-4342-B048-85BDC9FD1C3A}</a:tableStyleId>
+              </a:tblPr>
+              <a:tblGrid>
+                <a:gridCol w="1554480"/>
+                <a:gridCol w="1371600"/>
+                <a:gridCol w="1371600"/>
+              </a:tblGrid>
+              <a:tr h="352697">
+                <a:tc>
+                  <a:txBody>
+                    <a:bodyPr/>
+                    <a:lstStyle/>
+                    <a:p>
+                      <a:pPr>
+                        <a:defRPr sz="1300" b="1">
+                          <a:solidFill>
+                            <a:srgbClr val="FFFFFF"/>
+                          </a:solidFill>
+                        </a:defRPr>
+                      </a:pPr>
+                      <a:r>
+                        <a:t>USDC/USDT</a:t>
+                      </a:r>
+                    </a:p>
+                  </a:txBody>
+                  <a:tcPr anchor="ctr">
+                    <a:solidFill>
+                      <a:srgbClr val="173482"/>
+                    </a:solidFill>
+                  </a:tcPr>
+                </a:tc>
+                <a:tc>
+                  <a:txBody>
+                    <a:bodyPr/>
+                    <a:lstStyle/>
+                    <a:p>
+                      <a:pPr>
+                        <a:defRPr sz="1300" b="1">
+                          <a:solidFill>
+                            <a:srgbClr val="FFFFFF"/>
+                          </a:solidFill>
+                        </a:defRPr>
+                      </a:pPr>
+                      <a:r>
+                        <a:t>Bid</a:t>
+                      </a:r>
+                    </a:p>
+                  </a:txBody>
+                  <a:tcPr anchor="ctr">
+                    <a:solidFill>
+                      <a:srgbClr val="173482"/>
+                    </a:solidFill>
+                  </a:tcPr>
+                </a:tc>
+                <a:tc>
+                  <a:txBody>
+                    <a:bodyPr/>
+                    <a:lstStyle/>
+                    <a:p>
+                      <a:pPr>
+                        <a:defRPr sz="1300" b="1">
+                          <a:solidFill>
+                            <a:srgbClr val="FFFFFF"/>
+                          </a:solidFill>
+                        </a:defRPr>
+                      </a:pPr>
+                      <a:r>
+                        <a:t>Ask</a:t>
+                      </a:r>
+                    </a:p>
+                  </a:txBody>
+                  <a:tcPr anchor="ctr">
+                    <a:solidFill>
+                      <a:srgbClr val="173482"/>
+                    </a:solidFill>
+                  </a:tcPr>
+                </a:tc>
+              </a:tr>
+              <a:tr h="352697">
+                <a:tc>
+                  <a:txBody>
+                    <a:bodyPr/>
+                    <a:lstStyle/>
+                    <a:p>
+                      <a:pPr>
+                        <a:defRPr sz="1200" b="0">
+                          <a:solidFill>
+                            <a:srgbClr val="000000"/>
+                          </a:solidFill>
+                        </a:defRPr>
+                      </a:pPr>
+                      <a:r>
+                        <a:t>Binance (deep)</a:t>
+                      </a:r>
+                    </a:p>
+                  </a:txBody>
+                  <a:tcPr anchor="ctr">
+                    <a:solidFill>
+                      <a:srgbClr val="EAF8F2"/>
+                    </a:solidFill>
+                  </a:tcPr>
+                </a:tc>
+                <a:tc>
+                  <a:txBody>
+                    <a:bodyPr/>
+                    <a:lstStyle/>
+                    <a:p>
+                      <a:pPr>
+                        <a:defRPr sz="1200" b="0">
+                          <a:solidFill>
+                            <a:srgbClr val="000000"/>
+                          </a:solidFill>
+                        </a:defRPr>
+                      </a:pPr>
+                      <a:r>
+                        <a:t>1.00011</a:t>
+                      </a:r>
+                    </a:p>
+                  </a:txBody>
+                  <a:tcPr anchor="ctr">
+                    <a:solidFill>
+                      <a:srgbClr val="EAF8F2"/>
+                    </a:solidFill>
+                  </a:tcPr>
+                </a:tc>
+                <a:tc>
+                  <a:txBody>
+                    <a:bodyPr/>
+                    <a:lstStyle/>
+                    <a:p>
+                      <a:pPr>
+                        <a:defRPr sz="1200" b="0">
+                          <a:solidFill>
+                            <a:srgbClr val="000000"/>
+                          </a:solidFill>
+                        </a:defRPr>
+                      </a:pPr>
+                      <a:r>
+                        <a:t>1.00014</a:t>
+                      </a:r>
+                    </a:p>
+                  </a:txBody>
+                  <a:tcPr anchor="ctr">
+                    <a:solidFill>
+                      <a:srgbClr val="EAF8F2"/>
+                    </a:solidFill>
+                  </a:tcPr>
+                </a:tc>
+              </a:tr>
+              <a:tr h="352697">
+                <a:tc>
+                  <a:txBody>
+                    <a:bodyPr/>
+                    <a:lstStyle/>
+                    <a:p>
+                      <a:pPr>
+                        <a:defRPr sz="1200" b="0">
+                          <a:solidFill>
+                            <a:srgbClr val="000000"/>
+                          </a:solidFill>
+                        </a:defRPr>
+                      </a:pPr>
+                    </a:p>
+                  </a:txBody>
+                  <a:tcPr anchor="ctr">
+                    <a:solidFill>
+                      <a:srgbClr val="EAF8F2"/>
+                    </a:solidFill>
+                  </a:tcPr>
+                </a:tc>
+                <a:tc>
+                  <a:txBody>
+                    <a:bodyPr/>
+                    <a:lstStyle/>
+                    <a:p>
+                      <a:pPr>
+                        <a:defRPr sz="1200" b="0">
+                          <a:solidFill>
+                            <a:srgbClr val="000000"/>
+                          </a:solidFill>
+                        </a:defRPr>
+                      </a:pPr>
+                      <a:r>
+                        <a:t>1.00010</a:t>
+                      </a:r>
+                    </a:p>
+                  </a:txBody>
+                  <a:tcPr anchor="ctr">
+                    <a:solidFill>
+                      <a:srgbClr val="EAF8F2"/>
+                    </a:solidFill>
+                  </a:tcPr>
+                </a:tc>
+                <a:tc>
+                  <a:txBody>
+                    <a:bodyPr/>
+                    <a:lstStyle/>
+                    <a:p>
+                      <a:pPr>
+                        <a:defRPr sz="1200" b="0">
+                          <a:solidFill>
+                            <a:srgbClr val="000000"/>
+                          </a:solidFill>
+                        </a:defRPr>
+                      </a:pPr>
+                      <a:r>
+                        <a:t>1.00015</a:t>
+                      </a:r>
+                    </a:p>
+                  </a:txBody>
+                  <a:tcPr anchor="ctr">
+                    <a:solidFill>
+                      <a:srgbClr val="EAF8F2"/>
+                    </a:solidFill>
+                  </a:tcPr>
+                </a:tc>
+              </a:tr>
+              <a:tr h="352697">
+                <a:tc>
+                  <a:txBody>
+                    <a:bodyPr/>
+                    <a:lstStyle/>
+                    <a:p>
+                      <a:pPr>
+                        <a:defRPr sz="1200" b="0">
+                          <a:solidFill>
+                            <a:srgbClr val="000000"/>
+                          </a:solidFill>
+                        </a:defRPr>
+                      </a:pPr>
+                    </a:p>
+                  </a:txBody>
+                  <a:tcPr anchor="ctr">
+                    <a:solidFill>
+                      <a:srgbClr val="EAF8F2"/>
+                    </a:solidFill>
+                  </a:tcPr>
+                </a:tc>
+                <a:tc>
+                  <a:txBody>
+                    <a:bodyPr/>
+                    <a:lstStyle/>
+                    <a:p>
+                      <a:pPr>
+                        <a:defRPr sz="1200" b="0">
+                          <a:solidFill>
+                            <a:srgbClr val="000000"/>
+                          </a:solidFill>
+                        </a:defRPr>
+                      </a:pPr>
+                      <a:r>
+                        <a:t>1.00009</a:t>
+                      </a:r>
+                    </a:p>
+                  </a:txBody>
+                  <a:tcPr anchor="ctr">
+                    <a:solidFill>
+                      <a:srgbClr val="EAF8F2"/>
+                    </a:solidFill>
+                  </a:tcPr>
+                </a:tc>
+                <a:tc>
+                  <a:txBody>
+                    <a:bodyPr/>
+                    <a:lstStyle/>
+                    <a:p>
+                      <a:pPr>
+                        <a:defRPr sz="1200" b="0">
+                          <a:solidFill>
+                            <a:srgbClr val="000000"/>
+                          </a:solidFill>
+                        </a:defRPr>
+                      </a:pPr>
+                      <a:r>
+                        <a:t>1.00016</a:t>
+                      </a:r>
+                    </a:p>
+                  </a:txBody>
+                  <a:tcPr anchor="ctr">
+                    <a:solidFill>
+                      <a:srgbClr val="EAF8F2"/>
+                    </a:solidFill>
+                  </a:tcPr>
+                </a:tc>
+              </a:tr>
+              <a:tr h="352697">
+                <a:tc>
+                  <a:txBody>
+                    <a:bodyPr/>
+                    <a:lstStyle/>
+                    <a:p>
+                      <a:pPr>
+                        <a:defRPr sz="1200" b="0">
+                          <a:solidFill>
+                            <a:srgbClr val="000000"/>
+                          </a:solidFill>
+                        </a:defRPr>
+                      </a:pPr>
+                      <a:r>
+                        <a:t>Gate.io (thin)</a:t>
+                      </a:r>
+                    </a:p>
+                  </a:txBody>
+                  <a:tcPr anchor="ctr">
+                    <a:solidFill>
+                      <a:srgbClr val="FFEBEE"/>
+                    </a:solidFill>
+                  </a:tcPr>
+                </a:tc>
+                <a:tc>
+                  <a:txBody>
+                    <a:bodyPr/>
+                    <a:lstStyle/>
+                    <a:p>
+                      <a:pPr>
+                        <a:defRPr sz="1200" b="0">
+                          <a:solidFill>
+                            <a:srgbClr val="000000"/>
+                          </a:solidFill>
+                        </a:defRPr>
+                      </a:pPr>
+                      <a:r>
+                        <a:t>1.0006</a:t>
+                      </a:r>
+                    </a:p>
+                  </a:txBody>
+                  <a:tcPr anchor="ctr">
+                    <a:solidFill>
+                      <a:srgbClr val="FFEBEE"/>
+                    </a:solidFill>
+                  </a:tcPr>
+                </a:tc>
+                <a:tc>
+                  <a:txBody>
+                    <a:bodyPr/>
+                    <a:lstStyle/>
+                    <a:p>
+                      <a:pPr>
+                        <a:defRPr sz="1200" b="0">
+                          <a:solidFill>
+                            <a:srgbClr val="000000"/>
+                          </a:solidFill>
+                        </a:defRPr>
+                      </a:pPr>
+                      <a:r>
+                        <a:t>1.0009</a:t>
+                      </a:r>
+                    </a:p>
+                  </a:txBody>
+                  <a:tcPr anchor="ctr">
+                    <a:solidFill>
+                      <a:srgbClr val="FFEBEE"/>
+                    </a:solidFill>
+                  </a:tcPr>
+                </a:tc>
+              </a:tr>
+              <a:tr h="352697">
+                <a:tc>
+                  <a:txBody>
+                    <a:bodyPr/>
+                    <a:lstStyle/>
+                    <a:p>
+                      <a:pPr>
+                        <a:defRPr sz="1200" b="0">
+                          <a:solidFill>
+                            <a:srgbClr val="000000"/>
+                          </a:solidFill>
+                        </a:defRPr>
+                      </a:pPr>
+                    </a:p>
+                  </a:txBody>
+                  <a:tcPr anchor="ctr">
+                    <a:solidFill>
+                      <a:srgbClr val="FFEBEE"/>
+                    </a:solidFill>
+                  </a:tcPr>
+                </a:tc>
+                <a:tc>
+                  <a:txBody>
+                    <a:bodyPr/>
+                    <a:lstStyle/>
+                    <a:p>
+                      <a:pPr>
+                        <a:defRPr sz="1200" b="0">
+                          <a:solidFill>
+                            <a:srgbClr val="000000"/>
+                          </a:solidFill>
+                        </a:defRPr>
+                      </a:pPr>
+                      <a:r>
+                        <a:t>1.0005</a:t>
+                      </a:r>
+                    </a:p>
+                  </a:txBody>
+                  <a:tcPr anchor="ctr">
+                    <a:solidFill>
+                      <a:srgbClr val="FFEBEE"/>
+                    </a:solidFill>
+                  </a:tcPr>
+                </a:tc>
+                <a:tc>
+                  <a:txBody>
+                    <a:bodyPr/>
+                    <a:lstStyle/>
+                    <a:p>
+                      <a:pPr>
+                        <a:defRPr sz="1200" b="0">
+                          <a:solidFill>
+                            <a:srgbClr val="000000"/>
+                          </a:solidFill>
+                        </a:defRPr>
+                      </a:pPr>
+                      <a:r>
+                        <a:t>1.0010</a:t>
+                      </a:r>
+                    </a:p>
+                  </a:txBody>
+                  <a:tcPr anchor="ctr">
+                    <a:solidFill>
+                      <a:srgbClr val="FFEBEE"/>
+                    </a:solidFill>
+                  </a:tcPr>
+                </a:tc>
+              </a:tr>
+              <a:tr h="352698">
+                <a:tc>
+                  <a:txBody>
+                    <a:bodyPr/>
+                    <a:lstStyle/>
+                    <a:p>
+                      <a:pPr>
+                        <a:defRPr sz="1200" b="0">
+                          <a:solidFill>
+                            <a:srgbClr val="000000"/>
+                          </a:solidFill>
+                        </a:defRPr>
+                      </a:pPr>
+                    </a:p>
+                  </a:txBody>
+                  <a:tcPr anchor="ctr">
+                    <a:solidFill>
+                      <a:srgbClr val="FFEBEE"/>
+                    </a:solidFill>
+                  </a:tcPr>
+                </a:tc>
+                <a:tc>
+                  <a:txBody>
+                    <a:bodyPr/>
+                    <a:lstStyle/>
+                    <a:p>
+                      <a:pPr>
+                        <a:defRPr sz="1200" b="0">
+                          <a:solidFill>
+                            <a:srgbClr val="000000"/>
+                          </a:solidFill>
+                        </a:defRPr>
+                      </a:pPr>
+                      <a:r>
+                        <a:t>1.0004</a:t>
+                      </a:r>
+                    </a:p>
+                  </a:txBody>
+                  <a:tcPr anchor="ctr">
+                    <a:solidFill>
+                      <a:srgbClr val="FFEBEE"/>
+                    </a:solidFill>
+                  </a:tcPr>
+                </a:tc>
+                <a:tc>
+                  <a:txBody>
+                    <a:bodyPr/>
+                    <a:lstStyle/>
+                    <a:p>
+                      <a:pPr>
+                        <a:defRPr sz="1200" b="0">
+                          <a:solidFill>
+                            <a:srgbClr val="000000"/>
+                          </a:solidFill>
+                        </a:defRPr>
+                      </a:pPr>
+                      <a:r>
+                        <a:t>1.0011</a:t>
+                      </a:r>
+                    </a:p>
+                  </a:txBody>
+                  <a:tcPr anchor="ctr">
+                    <a:solidFill>
+                      <a:srgbClr val="FFEBEE"/>
+                    </a:solidFill>
+                  </a:tcPr>
+                </a:tc>
+              </a:tr>
+            </a:tbl>
+          </a:graphicData>
+        </a:graphic>
+      </p:graphicFrame>
+      <p:sp>
+        <p:nvSpPr>
+          <p:cNvPr id="8" name="TextBox 7"/>
+          <p:cNvSpPr txBox="1"/>
+          <p:nvPr/>
+        </p:nvSpPr>
+        <p:spPr>
+          <a:xfrm>
+            <a:off x="4434840" y="3703320"/>
+            <a:ext cx="4297680" cy="914400"/>
+          </a:xfrm>
+          <a:prstGeom prst="rect">
+            <a:avLst/>
+          </a:prstGeom>
+          <a:noFill/>
+        </p:spPr>
+        <p:txBody>
+          <a:bodyPr wrap="square">
+            <a:spAutoFit/>
+          </a:bodyPr>
+          <a:lstStyle/>
+          <a:p>
+            <a:pPr algn="l"/>
+            <a:r>
+              <a:rPr sz="1200" b="0" i="1">
+                <a:solidFill>
+                  <a:srgbClr val="595959"/>
+                </a:solidFill>
+                <a:latin typeface="Helvetica Neue"/>
+              </a:rPr>
+              <a:t>$50K buy on Binance ≈ 0 bps slippage (millions of units at top)</a:t>
+            </a:r>
+          </a:p>
+          <a:p>
+            <a:pPr algn="l"/>
+            <a:r>
+              <a:rPr sz="1200" b="0" i="1">
+                <a:solidFill>
+                  <a:srgbClr val="595959"/>
+                </a:solidFill>
+                <a:latin typeface="Helvetica Neue"/>
+              </a:rPr>
+              <a:t>$50K buy on Gate.io ≈ 0.5 bps slippage (only ~5K units at top)</a:t>
+            </a:r>
+          </a:p>
+        </p:txBody>
+      </p:sp>
+      <p:sp>
+        <p:nvSpPr>
+          <p:cNvPr id="9" name="TextBox 8"/>
           <p:cNvSpPr txBox="1"/>
           <p:nvPr/>
         </p:nvSpPr>

</xml_diff>

<commit_message>
Update improved A* arbitrage deck
</commit_message>
<xml_diff>
--- a/astar_arbitrage_deck.pptx
+++ b/astar_arbitrage_deck.pptx
@@ -5,24 +5,24 @@
     <p:sldMasterId id="2147483648" r:id="rId1"/>
   </p:sldMasterIdLst>
   <p:sldIdLst>
-    <p:sldId id="256" r:id="rId7"/>
-    <p:sldId id="257" r:id="rId8"/>
-    <p:sldId id="258" r:id="rId9"/>
-    <p:sldId id="259" r:id="rId10"/>
-    <p:sldId id="260" r:id="rId11"/>
-    <p:sldId id="261" r:id="rId12"/>
-    <p:sldId id="262" r:id="rId13"/>
-    <p:sldId id="263" r:id="rId14"/>
-    <p:sldId id="264" r:id="rId15"/>
-    <p:sldId id="265" r:id="rId16"/>
-    <p:sldId id="266" r:id="rId17"/>
-    <p:sldId id="267" r:id="rId18"/>
-    <p:sldId id="268" r:id="rId19"/>
-    <p:sldId id="269" r:id="rId20"/>
-    <p:sldId id="270" r:id="rId21"/>
-    <p:sldId id="271" r:id="rId22"/>
+    <p:sldId id="256" r:id="rId2"/>
+    <p:sldId id="257" r:id="rId3"/>
+    <p:sldId id="258" r:id="rId4"/>
+    <p:sldId id="259" r:id="rId5"/>
+    <p:sldId id="260" r:id="rId6"/>
+    <p:sldId id="261" r:id="rId7"/>
+    <p:sldId id="262" r:id="rId8"/>
+    <p:sldId id="263" r:id="rId9"/>
+    <p:sldId id="264" r:id="rId10"/>
+    <p:sldId id="265" r:id="rId11"/>
+    <p:sldId id="266" r:id="rId12"/>
+    <p:sldId id="267" r:id="rId13"/>
+    <p:sldId id="268" r:id="rId14"/>
+    <p:sldId id="269" r:id="rId15"/>
+    <p:sldId id="270" r:id="rId16"/>
+    <p:sldId id="271" r:id="rId17"/>
   </p:sldIdLst>
-  <p:sldSz cx="9144000" cy="5143500" type="screen4x3"/>
+  <p:sldSz cx="9144000" cy="5143500" type="screen16x9"/>
   <p:notesSz cx="6858000" cy="9144000"/>
   <p:defaultTextStyle>
     <a:defPPr>
@@ -119,6 +119,22 @@
       </a:defRPr>
     </a:lvl9pPr>
   </p:defaultTextStyle>
+  <p:extLst>
+    <p:ext uri="{EFAFB233-063F-42B5-8137-9DF3F51BA10A}">
+      <p15:sldGuideLst xmlns:p15="http://schemas.microsoft.com/office/powerpoint/2012/main">
+        <p15:guide id="1" orient="horz" pos="2160">
+          <p15:clr>
+            <a:srgbClr val="A4A3A4"/>
+          </p15:clr>
+        </p15:guide>
+        <p15:guide id="2" pos="2880">
+          <p15:clr>
+            <a:srgbClr val="A4A3A4"/>
+          </p15:clr>
+        </p15:guide>
+      </p15:sldGuideLst>
+    </p:ext>
+  </p:extLst>
 </p:presentation>
 </file>
 
@@ -160,10 +176,9 @@
           <a:lstStyle/>
           <a:p>
             <a:r>
-              <a:rPr lang="en-US" smtClean="0"/>
+              <a:rPr lang="en-US"/>
               <a:t>Click to edit Master title style</a:t>
             </a:r>
-            <a:endParaRPr lang="en-US"/>
           </a:p>
         </p:txBody>
       </p:sp>
@@ -279,10 +294,9 @@
           </a:lstStyle>
           <a:p>
             <a:r>
-              <a:rPr lang="en-US" smtClean="0"/>
+              <a:rPr lang="en-US"/>
               <a:t>Click to edit Master subtitle style</a:t>
             </a:r>
-            <a:endParaRPr lang="en-US"/>
           </a:p>
         </p:txBody>
       </p:sp>
@@ -303,7 +317,7 @@
           <a:p>
             <a:fld id="{5BCAD085-E8A6-8845-BD4E-CB4CCA059FC4}" type="datetimeFigureOut">
               <a:rPr lang="en-US" smtClean="0"/>
-              <a:t>1/27/13</a:t>
+              <a:t>7/29/2026</a:t>
             </a:fld>
             <a:endParaRPr lang="en-US"/>
           </a:p>
@@ -397,10 +411,9 @@
           <a:lstStyle/>
           <a:p>
             <a:r>
-              <a:rPr lang="en-US" smtClean="0"/>
+              <a:rPr lang="en-US"/>
               <a:t>Click to edit Master title style</a:t>
             </a:r>
-            <a:endParaRPr lang="en-US"/>
           </a:p>
         </p:txBody>
       </p:sp>
@@ -421,38 +434,37 @@
           <a:p>
             <a:pPr lvl="0"/>
             <a:r>
-              <a:rPr lang="en-US" smtClean="0"/>
+              <a:rPr lang="en-US"/>
               <a:t>Click to edit Master text styles</a:t>
             </a:r>
           </a:p>
           <a:p>
             <a:pPr lvl="1"/>
             <a:r>
-              <a:rPr lang="en-US" smtClean="0"/>
+              <a:rPr lang="en-US"/>
               <a:t>Second level</a:t>
             </a:r>
           </a:p>
           <a:p>
             <a:pPr lvl="2"/>
             <a:r>
-              <a:rPr lang="en-US" smtClean="0"/>
+              <a:rPr lang="en-US"/>
               <a:t>Third level</a:t>
             </a:r>
           </a:p>
           <a:p>
             <a:pPr lvl="3"/>
             <a:r>
-              <a:rPr lang="en-US" smtClean="0"/>
+              <a:rPr lang="en-US"/>
               <a:t>Fourth level</a:t>
             </a:r>
           </a:p>
           <a:p>
             <a:pPr lvl="4"/>
             <a:r>
-              <a:rPr lang="en-US" smtClean="0"/>
+              <a:rPr lang="en-US"/>
               <a:t>Fifth level</a:t>
             </a:r>
-            <a:endParaRPr lang="en-US"/>
           </a:p>
         </p:txBody>
       </p:sp>
@@ -473,7 +485,7 @@
           <a:p>
             <a:fld id="{5BCAD085-E8A6-8845-BD4E-CB4CCA059FC4}" type="datetimeFigureOut">
               <a:rPr lang="en-US" smtClean="0"/>
-              <a:t>1/27/13</a:t>
+              <a:t>7/29/2026</a:t>
             </a:fld>
             <a:endParaRPr lang="en-US"/>
           </a:p>
@@ -572,10 +584,9 @@
           <a:lstStyle/>
           <a:p>
             <a:r>
-              <a:rPr lang="en-US" smtClean="0"/>
+              <a:rPr lang="en-US"/>
               <a:t>Click to edit Master title style</a:t>
             </a:r>
-            <a:endParaRPr lang="en-US"/>
           </a:p>
         </p:txBody>
       </p:sp>
@@ -601,38 +612,37 @@
           <a:p>
             <a:pPr lvl="0"/>
             <a:r>
-              <a:rPr lang="en-US" smtClean="0"/>
+              <a:rPr lang="en-US"/>
               <a:t>Click to edit Master text styles</a:t>
             </a:r>
           </a:p>
           <a:p>
             <a:pPr lvl="1"/>
             <a:r>
-              <a:rPr lang="en-US" smtClean="0"/>
+              <a:rPr lang="en-US"/>
               <a:t>Second level</a:t>
             </a:r>
           </a:p>
           <a:p>
             <a:pPr lvl="2"/>
             <a:r>
-              <a:rPr lang="en-US" smtClean="0"/>
+              <a:rPr lang="en-US"/>
               <a:t>Third level</a:t>
             </a:r>
           </a:p>
           <a:p>
             <a:pPr lvl="3"/>
             <a:r>
-              <a:rPr lang="en-US" smtClean="0"/>
+              <a:rPr lang="en-US"/>
               <a:t>Fourth level</a:t>
             </a:r>
           </a:p>
           <a:p>
             <a:pPr lvl="4"/>
             <a:r>
-              <a:rPr lang="en-US" smtClean="0"/>
+              <a:rPr lang="en-US"/>
               <a:t>Fifth level</a:t>
             </a:r>
-            <a:endParaRPr lang="en-US"/>
           </a:p>
         </p:txBody>
       </p:sp>
@@ -653,7 +663,7 @@
           <a:p>
             <a:fld id="{5BCAD085-E8A6-8845-BD4E-CB4CCA059FC4}" type="datetimeFigureOut">
               <a:rPr lang="en-US" smtClean="0"/>
-              <a:t>1/27/13</a:t>
+              <a:t>7/29/2026</a:t>
             </a:fld>
             <a:endParaRPr lang="en-US"/>
           </a:p>
@@ -747,10 +757,9 @@
           <a:lstStyle/>
           <a:p>
             <a:r>
-              <a:rPr lang="en-US" smtClean="0"/>
+              <a:rPr lang="en-US"/>
               <a:t>Click to edit Master title style</a:t>
             </a:r>
-            <a:endParaRPr lang="en-US"/>
           </a:p>
         </p:txBody>
       </p:sp>
@@ -771,38 +780,37 @@
           <a:p>
             <a:pPr lvl="0"/>
             <a:r>
-              <a:rPr lang="en-US" smtClean="0"/>
+              <a:rPr lang="en-US"/>
               <a:t>Click to edit Master text styles</a:t>
             </a:r>
           </a:p>
           <a:p>
             <a:pPr lvl="1"/>
             <a:r>
-              <a:rPr lang="en-US" smtClean="0"/>
+              <a:rPr lang="en-US"/>
               <a:t>Second level</a:t>
             </a:r>
           </a:p>
           <a:p>
             <a:pPr lvl="2"/>
             <a:r>
-              <a:rPr lang="en-US" smtClean="0"/>
+              <a:rPr lang="en-US"/>
               <a:t>Third level</a:t>
             </a:r>
           </a:p>
           <a:p>
             <a:pPr lvl="3"/>
             <a:r>
-              <a:rPr lang="en-US" smtClean="0"/>
+              <a:rPr lang="en-US"/>
               <a:t>Fourth level</a:t>
             </a:r>
           </a:p>
           <a:p>
             <a:pPr lvl="4"/>
             <a:r>
-              <a:rPr lang="en-US" smtClean="0"/>
+              <a:rPr lang="en-US"/>
               <a:t>Fifth level</a:t>
             </a:r>
-            <a:endParaRPr lang="en-US"/>
           </a:p>
         </p:txBody>
       </p:sp>
@@ -823,7 +831,7 @@
           <a:p>
             <a:fld id="{5BCAD085-E8A6-8845-BD4E-CB4CCA059FC4}" type="datetimeFigureOut">
               <a:rPr lang="en-US" smtClean="0"/>
-              <a:t>1/27/13</a:t>
+              <a:t>7/29/2026</a:t>
             </a:fld>
             <a:endParaRPr lang="en-US"/>
           </a:p>
@@ -926,10 +934,9 @@
           </a:lstStyle>
           <a:p>
             <a:r>
-              <a:rPr lang="en-US" smtClean="0"/>
+              <a:rPr lang="en-US"/>
               <a:t>Click to edit Master title style</a:t>
             </a:r>
-            <a:endParaRPr lang="en-US"/>
           </a:p>
         </p:txBody>
       </p:sp>
@@ -1046,7 +1053,7 @@
           <a:p>
             <a:pPr lvl="0"/>
             <a:r>
-              <a:rPr lang="en-US" smtClean="0"/>
+              <a:rPr lang="en-US"/>
               <a:t>Click to edit Master text styles</a:t>
             </a:r>
           </a:p>
@@ -1069,7 +1076,7 @@
           <a:p>
             <a:fld id="{5BCAD085-E8A6-8845-BD4E-CB4CCA059FC4}" type="datetimeFigureOut">
               <a:rPr lang="en-US" smtClean="0"/>
-              <a:t>1/27/13</a:t>
+              <a:t>7/29/2026</a:t>
             </a:fld>
             <a:endParaRPr lang="en-US"/>
           </a:p>
@@ -1163,10 +1170,9 @@
           <a:lstStyle/>
           <a:p>
             <a:r>
-              <a:rPr lang="en-US" smtClean="0"/>
+              <a:rPr lang="en-US"/>
               <a:t>Click to edit Master title style</a:t>
             </a:r>
-            <a:endParaRPr lang="en-US"/>
           </a:p>
         </p:txBody>
       </p:sp>
@@ -1220,38 +1226,37 @@
           <a:p>
             <a:pPr lvl="0"/>
             <a:r>
-              <a:rPr lang="en-US" smtClean="0"/>
+              <a:rPr lang="en-US"/>
               <a:t>Click to edit Master text styles</a:t>
             </a:r>
           </a:p>
           <a:p>
             <a:pPr lvl="1"/>
             <a:r>
-              <a:rPr lang="en-US" smtClean="0"/>
+              <a:rPr lang="en-US"/>
               <a:t>Second level</a:t>
             </a:r>
           </a:p>
           <a:p>
             <a:pPr lvl="2"/>
             <a:r>
-              <a:rPr lang="en-US" smtClean="0"/>
+              <a:rPr lang="en-US"/>
               <a:t>Third level</a:t>
             </a:r>
           </a:p>
           <a:p>
             <a:pPr lvl="3"/>
             <a:r>
-              <a:rPr lang="en-US" smtClean="0"/>
+              <a:rPr lang="en-US"/>
               <a:t>Fourth level</a:t>
             </a:r>
           </a:p>
           <a:p>
             <a:pPr lvl="4"/>
             <a:r>
-              <a:rPr lang="en-US" smtClean="0"/>
+              <a:rPr lang="en-US"/>
               <a:t>Fifth level</a:t>
             </a:r>
-            <a:endParaRPr lang="en-US"/>
           </a:p>
         </p:txBody>
       </p:sp>
@@ -1305,38 +1310,37 @@
           <a:p>
             <a:pPr lvl="0"/>
             <a:r>
-              <a:rPr lang="en-US" smtClean="0"/>
+              <a:rPr lang="en-US"/>
               <a:t>Click to edit Master text styles</a:t>
             </a:r>
           </a:p>
           <a:p>
             <a:pPr lvl="1"/>
             <a:r>
-              <a:rPr lang="en-US" smtClean="0"/>
+              <a:rPr lang="en-US"/>
               <a:t>Second level</a:t>
             </a:r>
           </a:p>
           <a:p>
             <a:pPr lvl="2"/>
             <a:r>
-              <a:rPr lang="en-US" smtClean="0"/>
+              <a:rPr lang="en-US"/>
               <a:t>Third level</a:t>
             </a:r>
           </a:p>
           <a:p>
             <a:pPr lvl="3"/>
             <a:r>
-              <a:rPr lang="en-US" smtClean="0"/>
+              <a:rPr lang="en-US"/>
               <a:t>Fourth level</a:t>
             </a:r>
           </a:p>
           <a:p>
             <a:pPr lvl="4"/>
             <a:r>
-              <a:rPr lang="en-US" smtClean="0"/>
+              <a:rPr lang="en-US"/>
               <a:t>Fifth level</a:t>
             </a:r>
-            <a:endParaRPr lang="en-US"/>
           </a:p>
         </p:txBody>
       </p:sp>
@@ -1357,7 +1361,7 @@
           <a:p>
             <a:fld id="{5BCAD085-E8A6-8845-BD4E-CB4CCA059FC4}" type="datetimeFigureOut">
               <a:rPr lang="en-US" smtClean="0"/>
-              <a:t>1/27/13</a:t>
+              <a:t>7/29/2026</a:t>
             </a:fld>
             <a:endParaRPr lang="en-US"/>
           </a:p>
@@ -1455,10 +1459,9 @@
           </a:lstStyle>
           <a:p>
             <a:r>
-              <a:rPr lang="en-US" smtClean="0"/>
+              <a:rPr lang="en-US"/>
               <a:t>Click to edit Master title style</a:t>
             </a:r>
-            <a:endParaRPr lang="en-US"/>
           </a:p>
         </p:txBody>
       </p:sp>
@@ -1521,7 +1524,7 @@
           <a:p>
             <a:pPr lvl="0"/>
             <a:r>
-              <a:rPr lang="en-US" smtClean="0"/>
+              <a:rPr lang="en-US"/>
               <a:t>Click to edit Master text styles</a:t>
             </a:r>
           </a:p>
@@ -1577,38 +1580,37 @@
           <a:p>
             <a:pPr lvl="0"/>
             <a:r>
-              <a:rPr lang="en-US" smtClean="0"/>
+              <a:rPr lang="en-US"/>
               <a:t>Click to edit Master text styles</a:t>
             </a:r>
           </a:p>
           <a:p>
             <a:pPr lvl="1"/>
             <a:r>
-              <a:rPr lang="en-US" smtClean="0"/>
+              <a:rPr lang="en-US"/>
               <a:t>Second level</a:t>
             </a:r>
           </a:p>
           <a:p>
             <a:pPr lvl="2"/>
             <a:r>
-              <a:rPr lang="en-US" smtClean="0"/>
+              <a:rPr lang="en-US"/>
               <a:t>Third level</a:t>
             </a:r>
           </a:p>
           <a:p>
             <a:pPr lvl="3"/>
             <a:r>
-              <a:rPr lang="en-US" smtClean="0"/>
+              <a:rPr lang="en-US"/>
               <a:t>Fourth level</a:t>
             </a:r>
           </a:p>
           <a:p>
             <a:pPr lvl="4"/>
             <a:r>
-              <a:rPr lang="en-US" smtClean="0"/>
+              <a:rPr lang="en-US"/>
               <a:t>Fifth level</a:t>
             </a:r>
-            <a:endParaRPr lang="en-US"/>
           </a:p>
         </p:txBody>
       </p:sp>
@@ -1671,7 +1673,7 @@
           <a:p>
             <a:pPr lvl="0"/>
             <a:r>
-              <a:rPr lang="en-US" smtClean="0"/>
+              <a:rPr lang="en-US"/>
               <a:t>Click to edit Master text styles</a:t>
             </a:r>
           </a:p>
@@ -1727,38 +1729,37 @@
           <a:p>
             <a:pPr lvl="0"/>
             <a:r>
-              <a:rPr lang="en-US" smtClean="0"/>
+              <a:rPr lang="en-US"/>
               <a:t>Click to edit Master text styles</a:t>
             </a:r>
           </a:p>
           <a:p>
             <a:pPr lvl="1"/>
             <a:r>
-              <a:rPr lang="en-US" smtClean="0"/>
+              <a:rPr lang="en-US"/>
               <a:t>Second level</a:t>
             </a:r>
           </a:p>
           <a:p>
             <a:pPr lvl="2"/>
             <a:r>
-              <a:rPr lang="en-US" smtClean="0"/>
+              <a:rPr lang="en-US"/>
               <a:t>Third level</a:t>
             </a:r>
           </a:p>
           <a:p>
             <a:pPr lvl="3"/>
             <a:r>
-              <a:rPr lang="en-US" smtClean="0"/>
+              <a:rPr lang="en-US"/>
               <a:t>Fourth level</a:t>
             </a:r>
           </a:p>
           <a:p>
             <a:pPr lvl="4"/>
             <a:r>
-              <a:rPr lang="en-US" smtClean="0"/>
+              <a:rPr lang="en-US"/>
               <a:t>Fifth level</a:t>
             </a:r>
-            <a:endParaRPr lang="en-US"/>
           </a:p>
         </p:txBody>
       </p:sp>
@@ -1779,7 +1780,7 @@
           <a:p>
             <a:fld id="{5BCAD085-E8A6-8845-BD4E-CB4CCA059FC4}" type="datetimeFigureOut">
               <a:rPr lang="en-US" smtClean="0"/>
-              <a:t>1/27/13</a:t>
+              <a:t>7/29/2026</a:t>
             </a:fld>
             <a:endParaRPr lang="en-US"/>
           </a:p>
@@ -1873,10 +1874,9 @@
           <a:lstStyle/>
           <a:p>
             <a:r>
-              <a:rPr lang="en-US" smtClean="0"/>
+              <a:rPr lang="en-US"/>
               <a:t>Click to edit Master title style</a:t>
             </a:r>
-            <a:endParaRPr lang="en-US"/>
           </a:p>
         </p:txBody>
       </p:sp>
@@ -1897,7 +1897,7 @@
           <a:p>
             <a:fld id="{5BCAD085-E8A6-8845-BD4E-CB4CCA059FC4}" type="datetimeFigureOut">
               <a:rPr lang="en-US" smtClean="0"/>
-              <a:t>1/27/13</a:t>
+              <a:t>7/29/2026</a:t>
             </a:fld>
             <a:endParaRPr lang="en-US"/>
           </a:p>
@@ -1992,7 +1992,7 @@
           <a:p>
             <a:fld id="{5BCAD085-E8A6-8845-BD4E-CB4CCA059FC4}" type="datetimeFigureOut">
               <a:rPr lang="en-US" smtClean="0"/>
-              <a:t>1/27/13</a:t>
+              <a:t>7/29/2026</a:t>
             </a:fld>
             <a:endParaRPr lang="en-US"/>
           </a:p>
@@ -2095,10 +2095,9 @@
           </a:lstStyle>
           <a:p>
             <a:r>
-              <a:rPr lang="en-US" smtClean="0"/>
+              <a:rPr lang="en-US"/>
               <a:t>Click to edit Master title style</a:t>
             </a:r>
-            <a:endParaRPr lang="en-US"/>
           </a:p>
         </p:txBody>
       </p:sp>
@@ -2152,38 +2151,37 @@
           <a:p>
             <a:pPr lvl="0"/>
             <a:r>
-              <a:rPr lang="en-US" smtClean="0"/>
+              <a:rPr lang="en-US"/>
               <a:t>Click to edit Master text styles</a:t>
             </a:r>
           </a:p>
           <a:p>
             <a:pPr lvl="1"/>
             <a:r>
-              <a:rPr lang="en-US" smtClean="0"/>
+              <a:rPr lang="en-US"/>
               <a:t>Second level</a:t>
             </a:r>
           </a:p>
           <a:p>
             <a:pPr lvl="2"/>
             <a:r>
-              <a:rPr lang="en-US" smtClean="0"/>
+              <a:rPr lang="en-US"/>
               <a:t>Third level</a:t>
             </a:r>
           </a:p>
           <a:p>
             <a:pPr lvl="3"/>
             <a:r>
-              <a:rPr lang="en-US" smtClean="0"/>
+              <a:rPr lang="en-US"/>
               <a:t>Fourth level</a:t>
             </a:r>
           </a:p>
           <a:p>
             <a:pPr lvl="4"/>
             <a:r>
-              <a:rPr lang="en-US" smtClean="0"/>
+              <a:rPr lang="en-US"/>
               <a:t>Fifth level</a:t>
             </a:r>
-            <a:endParaRPr lang="en-US"/>
           </a:p>
         </p:txBody>
       </p:sp>
@@ -2246,7 +2244,7 @@
           <a:p>
             <a:pPr lvl="0"/>
             <a:r>
-              <a:rPr lang="en-US" smtClean="0"/>
+              <a:rPr lang="en-US"/>
               <a:t>Click to edit Master text styles</a:t>
             </a:r>
           </a:p>
@@ -2269,7 +2267,7 @@
           <a:p>
             <a:fld id="{5BCAD085-E8A6-8845-BD4E-CB4CCA059FC4}" type="datetimeFigureOut">
               <a:rPr lang="en-US" smtClean="0"/>
-              <a:t>1/27/13</a:t>
+              <a:t>7/29/2026</a:t>
             </a:fld>
             <a:endParaRPr lang="en-US"/>
           </a:p>
@@ -2372,10 +2370,9 @@
           </a:lstStyle>
           <a:p>
             <a:r>
-              <a:rPr lang="en-US" smtClean="0"/>
+              <a:rPr lang="en-US"/>
               <a:t>Click to edit Master title style</a:t>
             </a:r>
-            <a:endParaRPr lang="en-US"/>
           </a:p>
         </p:txBody>
       </p:sp>
@@ -2499,7 +2496,7 @@
           <a:p>
             <a:pPr lvl="0"/>
             <a:r>
-              <a:rPr lang="en-US" smtClean="0"/>
+              <a:rPr lang="en-US"/>
               <a:t>Click to edit Master text styles</a:t>
             </a:r>
           </a:p>
@@ -2522,7 +2519,7 @@
           <a:p>
             <a:fld id="{5BCAD085-E8A6-8845-BD4E-CB4CCA059FC4}" type="datetimeFigureOut">
               <a:rPr lang="en-US" smtClean="0"/>
-              <a:t>1/27/13</a:t>
+              <a:t>7/29/2026</a:t>
             </a:fld>
             <a:endParaRPr lang="en-US"/>
           </a:p>
@@ -2631,10 +2628,9 @@
           <a:lstStyle/>
           <a:p>
             <a:r>
-              <a:rPr lang="en-US" smtClean="0"/>
+              <a:rPr lang="en-US"/>
               <a:t>Click to edit Master title style</a:t>
             </a:r>
-            <a:endParaRPr lang="en-US"/>
           </a:p>
         </p:txBody>
       </p:sp>
@@ -2665,38 +2661,37 @@
           <a:p>
             <a:pPr lvl="0"/>
             <a:r>
-              <a:rPr lang="en-US" smtClean="0"/>
+              <a:rPr lang="en-US"/>
               <a:t>Click to edit Master text styles</a:t>
             </a:r>
           </a:p>
           <a:p>
             <a:pPr lvl="1"/>
             <a:r>
-              <a:rPr lang="en-US" smtClean="0"/>
+              <a:rPr lang="en-US"/>
               <a:t>Second level</a:t>
             </a:r>
           </a:p>
           <a:p>
             <a:pPr lvl="2"/>
             <a:r>
-              <a:rPr lang="en-US" smtClean="0"/>
+              <a:rPr lang="en-US"/>
               <a:t>Third level</a:t>
             </a:r>
           </a:p>
           <a:p>
             <a:pPr lvl="3"/>
             <a:r>
-              <a:rPr lang="en-US" smtClean="0"/>
+              <a:rPr lang="en-US"/>
               <a:t>Fourth level</a:t>
             </a:r>
           </a:p>
           <a:p>
             <a:pPr lvl="4"/>
             <a:r>
-              <a:rPr lang="en-US" smtClean="0"/>
+              <a:rPr lang="en-US"/>
               <a:t>Fifth level</a:t>
             </a:r>
-            <a:endParaRPr lang="en-US"/>
           </a:p>
         </p:txBody>
       </p:sp>
@@ -2735,7 +2730,7 @@
           <a:p>
             <a:fld id="{5BCAD085-E8A6-8845-BD4E-CB4CCA059FC4}" type="datetimeFigureOut">
               <a:rPr lang="en-US" smtClean="0"/>
-              <a:t>1/27/13</a:t>
+              <a:t>7/29/2026</a:t>
             </a:fld>
             <a:endParaRPr lang="en-US"/>
           </a:p>
@@ -3094,7 +3089,7 @@
 </file>
 
 <file path=ppt/slides/slide1.xml><?xml version="1.0" encoding="utf-8"?>
-<p:sld xmlns:a="http://schemas.openxmlformats.org/drawingml/2006/main" xmlns:p="http://schemas.openxmlformats.org/presentationml/2006/main" xmlns:r="http://schemas.openxmlformats.org/officeDocument/2006/relationships">
+<p:sld xmlns:a="http://schemas.openxmlformats.org/drawingml/2006/main" xmlns:r="http://schemas.openxmlformats.org/officeDocument/2006/relationships" xmlns:p="http://schemas.openxmlformats.org/presentationml/2006/main">
   <p:cSld>
     <p:bg>
       <p:bgPr>
@@ -3110,7 +3105,14 @@
         <p:cNvGrpSpPr/>
         <p:nvPr/>
       </p:nvGrpSpPr>
-      <p:grpSpPr/>
+      <p:grpSpPr>
+        <a:xfrm>
+          <a:off x="0" y="0"/>
+          <a:ext cx="0" cy="0"/>
+          <a:chOff x="0" y="0"/>
+          <a:chExt cx="0" cy="0"/>
+        </a:xfrm>
+      </p:grpSpPr>
       <p:sp>
         <p:nvSpPr>
           <p:cNvPr id="2" name="TextBox 1"/>
@@ -3154,7 +3156,7 @@
         </p:nvSpPr>
         <p:spPr>
           <a:xfrm>
-            <a:off x="640080" y="2286000"/>
+            <a:off x="640080" y="2410097"/>
             <a:ext cx="7863840" cy="548640"/>
           </a:xfrm>
           <a:prstGeom prst="rect">
@@ -3170,7 +3172,7 @@
           <a:p>
             <a:pPr algn="l"/>
             <a:r>
-              <a:rPr sz="1600" b="0" i="1">
+              <a:rPr sz="1600" b="0" i="1" dirty="0">
                 <a:solidFill>
                   <a:srgbClr val="B6E3EE"/>
                 </a:solidFill>
@@ -3260,7 +3262,7 @@
 </file>
 
 <file path=ppt/slides/slide10.xml><?xml version="1.0" encoding="utf-8"?>
-<p:sld xmlns:a="http://schemas.openxmlformats.org/drawingml/2006/main" xmlns:p="http://schemas.openxmlformats.org/presentationml/2006/main" xmlns:r="http://schemas.openxmlformats.org/officeDocument/2006/relationships">
+<p:sld xmlns:a="http://schemas.openxmlformats.org/drawingml/2006/main" xmlns:r="http://schemas.openxmlformats.org/officeDocument/2006/relationships" xmlns:p="http://schemas.openxmlformats.org/presentationml/2006/main">
   <p:cSld>
     <p:bg>
       <p:bgPr>
@@ -3276,7 +3278,14 @@
         <p:cNvGrpSpPr/>
         <p:nvPr/>
       </p:nvGrpSpPr>
-      <p:grpSpPr/>
+      <p:grpSpPr>
+        <a:xfrm>
+          <a:off x="0" y="0"/>
+          <a:ext cx="0" cy="0"/>
+          <a:chOff x="0" y="0"/>
+          <a:chExt cx="0" cy="0"/>
+        </a:xfrm>
+      </p:grpSpPr>
       <p:sp>
         <p:nvSpPr>
           <p:cNvPr id="2" name="Rectangle 1"/>
@@ -3318,6 +3327,7 @@
           <a:lstStyle/>
           <a:p>
             <a:pPr algn="ctr"/>
+            <a:endParaRPr/>
           </a:p>
         </p:txBody>
       </p:sp>
@@ -3459,7 +3469,7 @@
 </file>
 
 <file path=ppt/slides/slide11.xml><?xml version="1.0" encoding="utf-8"?>
-<p:sld xmlns:a="http://schemas.openxmlformats.org/drawingml/2006/main" xmlns:p="http://schemas.openxmlformats.org/presentationml/2006/main" xmlns:r="http://schemas.openxmlformats.org/officeDocument/2006/relationships">
+<p:sld xmlns:a="http://schemas.openxmlformats.org/drawingml/2006/main" xmlns:r="http://schemas.openxmlformats.org/officeDocument/2006/relationships" xmlns:p="http://schemas.openxmlformats.org/presentationml/2006/main">
   <p:cSld>
     <p:bg>
       <p:bgPr>
@@ -3475,7 +3485,14 @@
         <p:cNvGrpSpPr/>
         <p:nvPr/>
       </p:nvGrpSpPr>
-      <p:grpSpPr/>
+      <p:grpSpPr>
+        <a:xfrm>
+          <a:off x="0" y="0"/>
+          <a:ext cx="0" cy="0"/>
+          <a:chOff x="0" y="0"/>
+          <a:chExt cx="0" cy="0"/>
+        </a:xfrm>
+      </p:grpSpPr>
       <p:sp>
         <p:nvSpPr>
           <p:cNvPr id="2" name="Rectangle 1"/>
@@ -3517,6 +3534,7 @@
           <a:lstStyle/>
           <a:p>
             <a:pPr algn="ctr"/>
+            <a:endParaRPr/>
           </a:p>
         </p:txBody>
       </p:sp>
@@ -3658,7 +3676,7 @@
 </file>
 
 <file path=ppt/slides/slide12.xml><?xml version="1.0" encoding="utf-8"?>
-<p:sld xmlns:a="http://schemas.openxmlformats.org/drawingml/2006/main" xmlns:p="http://schemas.openxmlformats.org/presentationml/2006/main" xmlns:r="http://schemas.openxmlformats.org/officeDocument/2006/relationships">
+<p:sld xmlns:a="http://schemas.openxmlformats.org/drawingml/2006/main" xmlns:r="http://schemas.openxmlformats.org/officeDocument/2006/relationships" xmlns:p="http://schemas.openxmlformats.org/presentationml/2006/main">
   <p:cSld>
     <p:bg>
       <p:bgPr>
@@ -3674,7 +3692,14 @@
         <p:cNvGrpSpPr/>
         <p:nvPr/>
       </p:nvGrpSpPr>
-      <p:grpSpPr/>
+      <p:grpSpPr>
+        <a:xfrm>
+          <a:off x="0" y="0"/>
+          <a:ext cx="0" cy="0"/>
+          <a:chOff x="0" y="0"/>
+          <a:chExt cx="0" cy="0"/>
+        </a:xfrm>
+      </p:grpSpPr>
       <p:sp>
         <p:nvSpPr>
           <p:cNvPr id="2" name="Rectangle 1"/>
@@ -3716,6 +3741,7 @@
           <a:lstStyle/>
           <a:p>
             <a:pPr algn="ctr"/>
+            <a:endParaRPr/>
           </a:p>
         </p:txBody>
       </p:sp>
@@ -3857,7 +3883,7 @@
 </file>
 
 <file path=ppt/slides/slide13.xml><?xml version="1.0" encoding="utf-8"?>
-<p:sld xmlns:a="http://schemas.openxmlformats.org/drawingml/2006/main" xmlns:p="http://schemas.openxmlformats.org/presentationml/2006/main" xmlns:r="http://schemas.openxmlformats.org/officeDocument/2006/relationships">
+<p:sld xmlns:a="http://schemas.openxmlformats.org/drawingml/2006/main" xmlns:r="http://schemas.openxmlformats.org/officeDocument/2006/relationships" xmlns:p="http://schemas.openxmlformats.org/presentationml/2006/main">
   <p:cSld>
     <p:bg>
       <p:bgPr>
@@ -3873,7 +3899,14 @@
         <p:cNvGrpSpPr/>
         <p:nvPr/>
       </p:nvGrpSpPr>
-      <p:grpSpPr/>
+      <p:grpSpPr>
+        <a:xfrm>
+          <a:off x="0" y="0"/>
+          <a:ext cx="0" cy="0"/>
+          <a:chOff x="0" y="0"/>
+          <a:chExt cx="0" cy="0"/>
+        </a:xfrm>
+      </p:grpSpPr>
       <p:sp>
         <p:nvSpPr>
           <p:cNvPr id="2" name="Rectangle 1"/>
@@ -3915,6 +3948,7 @@
           <a:lstStyle/>
           <a:p>
             <a:pPr algn="ctr"/>
+            <a:endParaRPr/>
           </a:p>
         </p:txBody>
       </p:sp>
@@ -4056,7 +4090,7 @@
 </file>
 
 <file path=ppt/slides/slide14.xml><?xml version="1.0" encoding="utf-8"?>
-<p:sld xmlns:a="http://schemas.openxmlformats.org/drawingml/2006/main" xmlns:p="http://schemas.openxmlformats.org/presentationml/2006/main" xmlns:r="http://schemas.openxmlformats.org/officeDocument/2006/relationships">
+<p:sld xmlns:a="http://schemas.openxmlformats.org/drawingml/2006/main" xmlns:r="http://schemas.openxmlformats.org/officeDocument/2006/relationships" xmlns:p="http://schemas.openxmlformats.org/presentationml/2006/main">
   <p:cSld>
     <p:bg>
       <p:bgPr>
@@ -4072,7 +4106,14 @@
         <p:cNvGrpSpPr/>
         <p:nvPr/>
       </p:nvGrpSpPr>
-      <p:grpSpPr/>
+      <p:grpSpPr>
+        <a:xfrm>
+          <a:off x="0" y="0"/>
+          <a:ext cx="0" cy="0"/>
+          <a:chOff x="0" y="0"/>
+          <a:chExt cx="0" cy="0"/>
+        </a:xfrm>
+      </p:grpSpPr>
       <p:sp>
         <p:nvSpPr>
           <p:cNvPr id="2" name="Rectangle 1"/>
@@ -4114,6 +4155,7 @@
           <a:lstStyle/>
           <a:p>
             <a:pPr algn="ctr"/>
+            <a:endParaRPr/>
           </a:p>
         </p:txBody>
       </p:sp>
@@ -4267,7 +4309,7 @@
 </file>
 
 <file path=ppt/slides/slide15.xml><?xml version="1.0" encoding="utf-8"?>
-<p:sld xmlns:a="http://schemas.openxmlformats.org/drawingml/2006/main" xmlns:p="http://schemas.openxmlformats.org/presentationml/2006/main" xmlns:r="http://schemas.openxmlformats.org/officeDocument/2006/relationships">
+<p:sld xmlns:a="http://schemas.openxmlformats.org/drawingml/2006/main" xmlns:r="http://schemas.openxmlformats.org/officeDocument/2006/relationships" xmlns:p="http://schemas.openxmlformats.org/presentationml/2006/main">
   <p:cSld>
     <p:bg>
       <p:bgPr>
@@ -4283,7 +4325,14 @@
         <p:cNvGrpSpPr/>
         <p:nvPr/>
       </p:nvGrpSpPr>
-      <p:grpSpPr/>
+      <p:grpSpPr>
+        <a:xfrm>
+          <a:off x="0" y="0"/>
+          <a:ext cx="0" cy="0"/>
+          <a:chOff x="0" y="0"/>
+          <a:chExt cx="0" cy="0"/>
+        </a:xfrm>
+      </p:grpSpPr>
       <p:sp>
         <p:nvSpPr>
           <p:cNvPr id="2" name="Rectangle 1"/>
@@ -4325,6 +4374,7 @@
           <a:lstStyle/>
           <a:p>
             <a:pPr algn="ctr"/>
+            <a:endParaRPr/>
           </a:p>
         </p:txBody>
       </p:sp>
@@ -4521,6 +4571,7 @@
           <a:lstStyle/>
           <a:p>
             <a:pPr algn="ctr"/>
+            <a:endParaRPr/>
           </a:p>
         </p:txBody>
       </p:sp>
@@ -4602,9 +4653,27 @@
                 <a:tableStyleId>{5C22544A-7EE6-4342-B048-85BDC9FD1C3A}</a:tableStyleId>
               </a:tblPr>
               <a:tblGrid>
-                <a:gridCol w="1554480"/>
-                <a:gridCol w="1371600"/>
-                <a:gridCol w="1371600"/>
+                <a:gridCol w="1554480">
+                  <a:extLst>
+                    <a:ext uri="{9D8B030D-6E8A-4147-A177-3AD203B41FA5}">
+                      <a16:colId xmlns:a16="http://schemas.microsoft.com/office/drawing/2014/main" val="20000"/>
+                    </a:ext>
+                  </a:extLst>
+                </a:gridCol>
+                <a:gridCol w="1371600">
+                  <a:extLst>
+                    <a:ext uri="{9D8B030D-6E8A-4147-A177-3AD203B41FA5}">
+                      <a16:colId xmlns:a16="http://schemas.microsoft.com/office/drawing/2014/main" val="20001"/>
+                    </a:ext>
+                  </a:extLst>
+                </a:gridCol>
+                <a:gridCol w="1371600">
+                  <a:extLst>
+                    <a:ext uri="{9D8B030D-6E8A-4147-A177-3AD203B41FA5}">
+                      <a16:colId xmlns:a16="http://schemas.microsoft.com/office/drawing/2014/main" val="20002"/>
+                    </a:ext>
+                  </a:extLst>
+                </a:gridCol>
               </a:tblGrid>
               <a:tr h="352697">
                 <a:tc>
@@ -4676,6 +4745,11 @@
                     </a:solidFill>
                   </a:tcPr>
                 </a:tc>
+                <a:extLst>
+                  <a:ext uri="{0D108BD9-81ED-4DB2-BD59-A6C34878D82A}">
+                    <a16:rowId xmlns:a16="http://schemas.microsoft.com/office/drawing/2014/main" val="10000"/>
+                  </a:ext>
+                </a:extLst>
               </a:tr>
               <a:tr h="352697">
                 <a:tc>
@@ -4747,6 +4821,11 @@
                     </a:solidFill>
                   </a:tcPr>
                 </a:tc>
+                <a:extLst>
+                  <a:ext uri="{0D108BD9-81ED-4DB2-BD59-A6C34878D82A}">
+                    <a16:rowId xmlns:a16="http://schemas.microsoft.com/office/drawing/2014/main" val="10001"/>
+                  </a:ext>
+                </a:extLst>
               </a:tr>
               <a:tr h="352697">
                 <a:tc>
@@ -4761,6 +4840,7 @@
                           </a:solidFill>
                         </a:defRPr>
                       </a:pPr>
+                      <a:endParaRPr/>
                     </a:p>
                   </a:txBody>
                   <a:tcPr anchor="ctr">
@@ -4815,6 +4895,11 @@
                     </a:solidFill>
                   </a:tcPr>
                 </a:tc>
+                <a:extLst>
+                  <a:ext uri="{0D108BD9-81ED-4DB2-BD59-A6C34878D82A}">
+                    <a16:rowId xmlns:a16="http://schemas.microsoft.com/office/drawing/2014/main" val="10002"/>
+                  </a:ext>
+                </a:extLst>
               </a:tr>
               <a:tr h="352697">
                 <a:tc>
@@ -4829,6 +4914,7 @@
                           </a:solidFill>
                         </a:defRPr>
                       </a:pPr>
+                      <a:endParaRPr/>
                     </a:p>
                   </a:txBody>
                   <a:tcPr anchor="ctr">
@@ -4883,6 +4969,11 @@
                     </a:solidFill>
                   </a:tcPr>
                 </a:tc>
+                <a:extLst>
+                  <a:ext uri="{0D108BD9-81ED-4DB2-BD59-A6C34878D82A}">
+                    <a16:rowId xmlns:a16="http://schemas.microsoft.com/office/drawing/2014/main" val="10003"/>
+                  </a:ext>
+                </a:extLst>
               </a:tr>
               <a:tr h="352697">
                 <a:tc>
@@ -4954,6 +5045,11 @@
                     </a:solidFill>
                   </a:tcPr>
                 </a:tc>
+                <a:extLst>
+                  <a:ext uri="{0D108BD9-81ED-4DB2-BD59-A6C34878D82A}">
+                    <a16:rowId xmlns:a16="http://schemas.microsoft.com/office/drawing/2014/main" val="10004"/>
+                  </a:ext>
+                </a:extLst>
               </a:tr>
               <a:tr h="352697">
                 <a:tc>
@@ -4968,6 +5064,7 @@
                           </a:solidFill>
                         </a:defRPr>
                       </a:pPr>
+                      <a:endParaRPr/>
                     </a:p>
                   </a:txBody>
                   <a:tcPr anchor="ctr">
@@ -5022,6 +5119,11 @@
                     </a:solidFill>
                   </a:tcPr>
                 </a:tc>
+                <a:extLst>
+                  <a:ext uri="{0D108BD9-81ED-4DB2-BD59-A6C34878D82A}">
+                    <a16:rowId xmlns:a16="http://schemas.microsoft.com/office/drawing/2014/main" val="10005"/>
+                  </a:ext>
+                </a:extLst>
               </a:tr>
               <a:tr h="352698">
                 <a:tc>
@@ -5036,6 +5138,7 @@
                           </a:solidFill>
                         </a:defRPr>
                       </a:pPr>
+                      <a:endParaRPr/>
                     </a:p>
                   </a:txBody>
                   <a:tcPr anchor="ctr">
@@ -5090,6 +5193,11 @@
                     </a:solidFill>
                   </a:tcPr>
                 </a:tc>
+                <a:extLst>
+                  <a:ext uri="{0D108BD9-81ED-4DB2-BD59-A6C34878D82A}">
+                    <a16:rowId xmlns:a16="http://schemas.microsoft.com/office/drawing/2014/main" val="10006"/>
+                  </a:ext>
+                </a:extLst>
               </a:tr>
             </a:tbl>
           </a:graphicData>
@@ -5186,7 +5294,7 @@
 </file>
 
 <file path=ppt/slides/slide16.xml><?xml version="1.0" encoding="utf-8"?>
-<p:sld xmlns:a="http://schemas.openxmlformats.org/drawingml/2006/main" xmlns:p="http://schemas.openxmlformats.org/presentationml/2006/main" xmlns:r="http://schemas.openxmlformats.org/officeDocument/2006/relationships">
+<p:sld xmlns:a="http://schemas.openxmlformats.org/drawingml/2006/main" xmlns:r="http://schemas.openxmlformats.org/officeDocument/2006/relationships" xmlns:p="http://schemas.openxmlformats.org/presentationml/2006/main">
   <p:cSld>
     <p:bg>
       <p:bgPr>
@@ -5202,7 +5310,14 @@
         <p:cNvGrpSpPr/>
         <p:nvPr/>
       </p:nvGrpSpPr>
-      <p:grpSpPr/>
+      <p:grpSpPr>
+        <a:xfrm>
+          <a:off x="0" y="0"/>
+          <a:ext cx="0" cy="0"/>
+          <a:chOff x="0" y="0"/>
+          <a:chExt cx="0" cy="0"/>
+        </a:xfrm>
+      </p:grpSpPr>
       <p:sp>
         <p:nvSpPr>
           <p:cNvPr id="2" name="Rectangle 1"/>
@@ -5244,6 +5359,7 @@
           <a:lstStyle/>
           <a:p>
             <a:pPr algn="ctr"/>
+            <a:endParaRPr/>
           </a:p>
         </p:txBody>
       </p:sp>
@@ -5492,7 +5608,7 @@
 </file>
 
 <file path=ppt/slides/slide2.xml><?xml version="1.0" encoding="utf-8"?>
-<p:sld xmlns:a="http://schemas.openxmlformats.org/drawingml/2006/main" xmlns:p="http://schemas.openxmlformats.org/presentationml/2006/main" xmlns:r="http://schemas.openxmlformats.org/officeDocument/2006/relationships">
+<p:sld xmlns:a="http://schemas.openxmlformats.org/drawingml/2006/main" xmlns:r="http://schemas.openxmlformats.org/officeDocument/2006/relationships" xmlns:p="http://schemas.openxmlformats.org/presentationml/2006/main">
   <p:cSld>
     <p:bg>
       <p:bgPr>
@@ -5508,7 +5624,14 @@
         <p:cNvGrpSpPr/>
         <p:nvPr/>
       </p:nvGrpSpPr>
-      <p:grpSpPr/>
+      <p:grpSpPr>
+        <a:xfrm>
+          <a:off x="0" y="0"/>
+          <a:ext cx="0" cy="0"/>
+          <a:chOff x="0" y="0"/>
+          <a:chExt cx="0" cy="0"/>
+        </a:xfrm>
+      </p:grpSpPr>
       <p:sp>
         <p:nvSpPr>
           <p:cNvPr id="2" name="Rectangle 1"/>
@@ -5550,6 +5673,7 @@
           <a:lstStyle/>
           <a:p>
             <a:pPr algn="ctr"/>
+            <a:endParaRPr/>
           </a:p>
         </p:txBody>
       </p:sp>
@@ -5629,6 +5753,7 @@
           <a:lstStyle/>
           <a:p>
             <a:pPr algn="ctr"/>
+            <a:endParaRPr/>
           </a:p>
         </p:txBody>
       </p:sp>
@@ -5667,6 +5792,12 @@
           </a:p>
           <a:p>
             <a:pPr algn="l"/>
+            <a:endParaRPr sz="1300" b="0" i="0">
+              <a:solidFill>
+                <a:srgbClr val="000000"/>
+              </a:solidFill>
+              <a:latin typeface="Helvetica Neue"/>
+            </a:endParaRPr>
           </a:p>
           <a:p>
             <a:pPr algn="l"/>
@@ -5694,6 +5825,12 @@
           </a:p>
           <a:p>
             <a:pPr algn="l"/>
+            <a:endParaRPr sz="1300" b="0" i="0">
+              <a:solidFill>
+                <a:srgbClr val="000000"/>
+              </a:solidFill>
+              <a:latin typeface="Helvetica Neue"/>
+            </a:endParaRPr>
           </a:p>
           <a:p>
             <a:pPr algn="l"/>
@@ -5750,6 +5887,7 @@
           <a:lstStyle/>
           <a:p>
             <a:pPr algn="ctr"/>
+            <a:endParaRPr/>
           </a:p>
         </p:txBody>
       </p:sp>
@@ -5788,6 +5926,12 @@
           </a:p>
           <a:p>
             <a:pPr algn="l"/>
+            <a:endParaRPr sz="1300" b="0" i="0">
+              <a:solidFill>
+                <a:srgbClr val="000000"/>
+              </a:solidFill>
+              <a:latin typeface="Helvetica Neue"/>
+            </a:endParaRPr>
           </a:p>
           <a:p>
             <a:pPr algn="l"/>
@@ -5880,6 +6024,7 @@
           <a:lstStyle/>
           <a:p>
             <a:pPr algn="ctr"/>
+            <a:endParaRPr/>
           </a:p>
         </p:txBody>
       </p:sp>
@@ -5918,6 +6063,12 @@
           </a:p>
           <a:p>
             <a:pPr algn="l"/>
+            <a:endParaRPr sz="1300" b="0" i="0">
+              <a:solidFill>
+                <a:srgbClr val="FFFFFF"/>
+              </a:solidFill>
+              <a:latin typeface="Helvetica Neue"/>
+            </a:endParaRPr>
           </a:p>
           <a:p>
             <a:pPr algn="l"/>
@@ -5945,6 +6096,12 @@
           </a:p>
           <a:p>
             <a:pPr algn="l"/>
+            <a:endParaRPr sz="1300" b="0" i="0">
+              <a:solidFill>
+                <a:srgbClr val="FFFFFF"/>
+              </a:solidFill>
+              <a:latin typeface="Helvetica Neue"/>
+            </a:endParaRPr>
           </a:p>
           <a:p>
             <a:pPr algn="l"/>
@@ -6051,7 +6208,7 @@
 </file>
 
 <file path=ppt/slides/slide3.xml><?xml version="1.0" encoding="utf-8"?>
-<p:sld xmlns:a="http://schemas.openxmlformats.org/drawingml/2006/main" xmlns:p="http://schemas.openxmlformats.org/presentationml/2006/main" xmlns:r="http://schemas.openxmlformats.org/officeDocument/2006/relationships">
+<p:sld xmlns:a="http://schemas.openxmlformats.org/drawingml/2006/main" xmlns:r="http://schemas.openxmlformats.org/officeDocument/2006/relationships" xmlns:p="http://schemas.openxmlformats.org/presentationml/2006/main">
   <p:cSld>
     <p:bg>
       <p:bgPr>
@@ -6067,7 +6224,14 @@
         <p:cNvGrpSpPr/>
         <p:nvPr/>
       </p:nvGrpSpPr>
-      <p:grpSpPr/>
+      <p:grpSpPr>
+        <a:xfrm>
+          <a:off x="0" y="0"/>
+          <a:ext cx="0" cy="0"/>
+          <a:chOff x="0" y="0"/>
+          <a:chExt cx="0" cy="0"/>
+        </a:xfrm>
+      </p:grpSpPr>
       <p:sp>
         <p:nvSpPr>
           <p:cNvPr id="2" name="Rectangle 1"/>
@@ -6109,6 +6273,7 @@
           <a:lstStyle/>
           <a:p>
             <a:pPr algn="ctr"/>
+            <a:endParaRPr/>
           </a:p>
         </p:txBody>
       </p:sp>
@@ -6285,6 +6450,7 @@
           <a:lstStyle/>
           <a:p>
             <a:pPr algn="ctr"/>
+            <a:endParaRPr/>
           </a:p>
         </p:txBody>
       </p:sp>
@@ -6399,6 +6565,7 @@
           <a:lstStyle/>
           <a:p>
             <a:pPr algn="ctr"/>
+            <a:endParaRPr/>
           </a:p>
         </p:txBody>
       </p:sp>
@@ -6513,6 +6680,7 @@
           <a:lstStyle/>
           <a:p>
             <a:pPr algn="ctr"/>
+            <a:endParaRPr/>
           </a:p>
         </p:txBody>
       </p:sp>
@@ -6627,6 +6795,7 @@
           <a:lstStyle/>
           <a:p>
             <a:pPr algn="ctr"/>
+            <a:endParaRPr/>
           </a:p>
         </p:txBody>
       </p:sp>
@@ -6741,6 +6910,7 @@
           <a:lstStyle/>
           <a:p>
             <a:pPr algn="ctr"/>
+            <a:endParaRPr/>
           </a:p>
         </p:txBody>
       </p:sp>
@@ -6893,7 +7063,7 @@
 </file>
 
 <file path=ppt/slides/slide4.xml><?xml version="1.0" encoding="utf-8"?>
-<p:sld xmlns:a="http://schemas.openxmlformats.org/drawingml/2006/main" xmlns:p="http://schemas.openxmlformats.org/presentationml/2006/main" xmlns:r="http://schemas.openxmlformats.org/officeDocument/2006/relationships">
+<p:sld xmlns:a="http://schemas.openxmlformats.org/drawingml/2006/main" xmlns:r="http://schemas.openxmlformats.org/officeDocument/2006/relationships" xmlns:p="http://schemas.openxmlformats.org/presentationml/2006/main">
   <p:cSld>
     <p:bg>
       <p:bgPr>
@@ -6909,7 +7079,14 @@
         <p:cNvGrpSpPr/>
         <p:nvPr/>
       </p:nvGrpSpPr>
-      <p:grpSpPr/>
+      <p:grpSpPr>
+        <a:xfrm>
+          <a:off x="0" y="0"/>
+          <a:ext cx="0" cy="0"/>
+          <a:chOff x="0" y="0"/>
+          <a:chExt cx="0" cy="0"/>
+        </a:xfrm>
+      </p:grpSpPr>
       <p:sp>
         <p:nvSpPr>
           <p:cNvPr id="2" name="Rectangle 1"/>
@@ -6951,6 +7128,7 @@
           <a:lstStyle/>
           <a:p>
             <a:pPr algn="ctr"/>
+            <a:endParaRPr/>
           </a:p>
         </p:txBody>
       </p:sp>
@@ -7065,6 +7243,7 @@
           <a:lstStyle/>
           <a:p>
             <a:pPr algn="ctr"/>
+            <a:endParaRPr/>
           </a:p>
         </p:txBody>
       </p:sp>
@@ -7115,6 +7294,12 @@
           </a:p>
           <a:p>
             <a:pPr algn="l"/>
+            <a:endParaRPr sz="1200" b="0" i="0">
+              <a:solidFill>
+                <a:srgbClr val="000000"/>
+              </a:solidFill>
+              <a:latin typeface="Helvetica Neue"/>
+            </a:endParaRPr>
           </a:p>
           <a:p>
             <a:pPr algn="l"/>
@@ -7195,6 +7380,7 @@
           <a:lstStyle/>
           <a:p>
             <a:pPr algn="ctr"/>
+            <a:endParaRPr/>
           </a:p>
         </p:txBody>
       </p:sp>
@@ -7245,6 +7431,12 @@
           </a:p>
           <a:p>
             <a:pPr algn="l"/>
+            <a:endParaRPr sz="1200" b="0" i="0">
+              <a:solidFill>
+                <a:srgbClr val="000000"/>
+              </a:solidFill>
+              <a:latin typeface="Helvetica Neue"/>
+            </a:endParaRPr>
           </a:p>
           <a:p>
             <a:pPr algn="l"/>
@@ -7337,6 +7529,7 @@
           <a:lstStyle/>
           <a:p>
             <a:pPr algn="ctr"/>
+            <a:endParaRPr/>
           </a:p>
         </p:txBody>
       </p:sp>
@@ -7387,6 +7580,12 @@
           </a:p>
           <a:p>
             <a:pPr algn="l"/>
+            <a:endParaRPr sz="1200" b="0" i="0">
+              <a:solidFill>
+                <a:srgbClr val="FFFFFF"/>
+              </a:solidFill>
+              <a:latin typeface="Helvetica Neue"/>
+            </a:endParaRPr>
           </a:p>
           <a:p>
             <a:pPr algn="l"/>
@@ -7482,7 +7681,7 @@
 </file>
 
 <file path=ppt/slides/slide5.xml><?xml version="1.0" encoding="utf-8"?>
-<p:sld xmlns:a="http://schemas.openxmlformats.org/drawingml/2006/main" xmlns:p="http://schemas.openxmlformats.org/presentationml/2006/main" xmlns:r="http://schemas.openxmlformats.org/officeDocument/2006/relationships">
+<p:sld xmlns:a="http://schemas.openxmlformats.org/drawingml/2006/main" xmlns:r="http://schemas.openxmlformats.org/officeDocument/2006/relationships" xmlns:p="http://schemas.openxmlformats.org/presentationml/2006/main">
   <p:cSld>
     <p:bg>
       <p:bgPr>
@@ -7498,7 +7697,14 @@
         <p:cNvGrpSpPr/>
         <p:nvPr/>
       </p:nvGrpSpPr>
-      <p:grpSpPr/>
+      <p:grpSpPr>
+        <a:xfrm>
+          <a:off x="0" y="0"/>
+          <a:ext cx="0" cy="0"/>
+          <a:chOff x="0" y="0"/>
+          <a:chExt cx="0" cy="0"/>
+        </a:xfrm>
+      </p:grpSpPr>
       <p:sp>
         <p:nvSpPr>
           <p:cNvPr id="2" name="Rectangle 1"/>
@@ -7540,6 +7746,7 @@
           <a:lstStyle/>
           <a:p>
             <a:pPr algn="ctr"/>
+            <a:endParaRPr/>
           </a:p>
         </p:txBody>
       </p:sp>
@@ -7619,6 +7826,7 @@
           <a:lstStyle/>
           <a:p>
             <a:pPr algn="ctr"/>
+            <a:endParaRPr/>
           </a:p>
         </p:txBody>
       </p:sp>
@@ -7722,6 +7930,7 @@
           <a:lstStyle/>
           <a:p>
             <a:pPr algn="ctr"/>
+            <a:endParaRPr/>
           </a:p>
         </p:txBody>
       </p:sp>
@@ -7860,6 +8069,7 @@
           <a:lstStyle/>
           <a:p>
             <a:pPr algn="ctr"/>
+            <a:endParaRPr/>
           </a:p>
         </p:txBody>
       </p:sp>
@@ -7989,7 +8199,7 @@
 </file>
 
 <file path=ppt/slides/slide6.xml><?xml version="1.0" encoding="utf-8"?>
-<p:sld xmlns:a="http://schemas.openxmlformats.org/drawingml/2006/main" xmlns:p="http://schemas.openxmlformats.org/presentationml/2006/main" xmlns:r="http://schemas.openxmlformats.org/officeDocument/2006/relationships">
+<p:sld xmlns:a="http://schemas.openxmlformats.org/drawingml/2006/main" xmlns:r="http://schemas.openxmlformats.org/officeDocument/2006/relationships" xmlns:p="http://schemas.openxmlformats.org/presentationml/2006/main">
   <p:cSld>
     <p:bg>
       <p:bgPr>
@@ -8005,7 +8215,14 @@
         <p:cNvGrpSpPr/>
         <p:nvPr/>
       </p:nvGrpSpPr>
-      <p:grpSpPr/>
+      <p:grpSpPr>
+        <a:xfrm>
+          <a:off x="0" y="0"/>
+          <a:ext cx="0" cy="0"/>
+          <a:chOff x="0" y="0"/>
+          <a:chExt cx="0" cy="0"/>
+        </a:xfrm>
+      </p:grpSpPr>
       <p:sp>
         <p:nvSpPr>
           <p:cNvPr id="2" name="Rectangle 1"/>
@@ -8047,6 +8264,7 @@
           <a:lstStyle/>
           <a:p>
             <a:pPr algn="ctr"/>
+            <a:endParaRPr/>
           </a:p>
         </p:txBody>
       </p:sp>
@@ -8306,7 +8524,7 @@
 </file>
 
 <file path=ppt/slides/slide7.xml><?xml version="1.0" encoding="utf-8"?>
-<p:sld xmlns:a="http://schemas.openxmlformats.org/drawingml/2006/main" xmlns:p="http://schemas.openxmlformats.org/presentationml/2006/main" xmlns:r="http://schemas.openxmlformats.org/officeDocument/2006/relationships">
+<p:sld xmlns:a="http://schemas.openxmlformats.org/drawingml/2006/main" xmlns:r="http://schemas.openxmlformats.org/officeDocument/2006/relationships" xmlns:p="http://schemas.openxmlformats.org/presentationml/2006/main">
   <p:cSld>
     <p:bg>
       <p:bgPr>
@@ -8322,7 +8540,14 @@
         <p:cNvGrpSpPr/>
         <p:nvPr/>
       </p:nvGrpSpPr>
-      <p:grpSpPr/>
+      <p:grpSpPr>
+        <a:xfrm>
+          <a:off x="0" y="0"/>
+          <a:ext cx="0" cy="0"/>
+          <a:chOff x="0" y="0"/>
+          <a:chExt cx="0" cy="0"/>
+        </a:xfrm>
+      </p:grpSpPr>
       <p:sp>
         <p:nvSpPr>
           <p:cNvPr id="2" name="Rectangle 1"/>
@@ -8364,6 +8589,7 @@
           <a:lstStyle/>
           <a:p>
             <a:pPr algn="ctr"/>
+            <a:endParaRPr/>
           </a:p>
         </p:txBody>
       </p:sp>
@@ -8478,6 +8704,7 @@
           <a:lstStyle/>
           <a:p>
             <a:pPr algn="ctr"/>
+            <a:endParaRPr/>
           </a:p>
         </p:txBody>
       </p:sp>
@@ -8516,6 +8743,12 @@
           </a:p>
           <a:p>
             <a:pPr algn="l"/>
+            <a:endParaRPr sz="1200" b="0" i="0">
+              <a:solidFill>
+                <a:srgbClr val="000000"/>
+              </a:solidFill>
+              <a:latin typeface="Helvetica Neue"/>
+            </a:endParaRPr>
           </a:p>
           <a:p>
             <a:pPr algn="l"/>
@@ -8608,6 +8841,7 @@
           <a:lstStyle/>
           <a:p>
             <a:pPr algn="ctr"/>
+            <a:endParaRPr/>
           </a:p>
         </p:txBody>
       </p:sp>
@@ -8646,6 +8880,12 @@
           </a:p>
           <a:p>
             <a:pPr algn="l"/>
+            <a:endParaRPr sz="1200" b="0" i="0">
+              <a:solidFill>
+                <a:srgbClr val="000000"/>
+              </a:solidFill>
+              <a:latin typeface="Helvetica Neue"/>
+            </a:endParaRPr>
           </a:p>
           <a:p>
             <a:pPr algn="l"/>
@@ -8738,6 +8978,7 @@
           <a:lstStyle/>
           <a:p>
             <a:pPr algn="ctr"/>
+            <a:endParaRPr/>
           </a:p>
         </p:txBody>
       </p:sp>
@@ -8776,6 +9017,12 @@
           </a:p>
           <a:p>
             <a:pPr algn="l"/>
+            <a:endParaRPr sz="1200" b="0" i="0">
+              <a:solidFill>
+                <a:srgbClr val="000000"/>
+              </a:solidFill>
+              <a:latin typeface="Helvetica Neue"/>
+            </a:endParaRPr>
           </a:p>
           <a:p>
             <a:pPr algn="l"/>
@@ -8868,6 +9115,7 @@
           <a:lstStyle/>
           <a:p>
             <a:pPr algn="ctr"/>
+            <a:endParaRPr/>
           </a:p>
         </p:txBody>
       </p:sp>
@@ -8962,7 +9210,7 @@
 </file>
 
 <file path=ppt/slides/slide8.xml><?xml version="1.0" encoding="utf-8"?>
-<p:sld xmlns:a="http://schemas.openxmlformats.org/drawingml/2006/main" xmlns:p="http://schemas.openxmlformats.org/presentationml/2006/main" xmlns:r="http://schemas.openxmlformats.org/officeDocument/2006/relationships">
+<p:sld xmlns:a="http://schemas.openxmlformats.org/drawingml/2006/main" xmlns:r="http://schemas.openxmlformats.org/officeDocument/2006/relationships" xmlns:p="http://schemas.openxmlformats.org/presentationml/2006/main">
   <p:cSld>
     <p:bg>
       <p:bgPr>
@@ -8978,7 +9226,14 @@
         <p:cNvGrpSpPr/>
         <p:nvPr/>
       </p:nvGrpSpPr>
-      <p:grpSpPr/>
+      <p:grpSpPr>
+        <a:xfrm>
+          <a:off x="0" y="0"/>
+          <a:ext cx="0" cy="0"/>
+          <a:chOff x="0" y="0"/>
+          <a:chExt cx="0" cy="0"/>
+        </a:xfrm>
+      </p:grpSpPr>
       <p:sp>
         <p:nvSpPr>
           <p:cNvPr id="2" name="Rectangle 1"/>
@@ -9020,6 +9275,7 @@
           <a:lstStyle/>
           <a:p>
             <a:pPr algn="ctr"/>
+            <a:endParaRPr/>
           </a:p>
         </p:txBody>
       </p:sp>
@@ -9058,76 +9314,330 @@
           </a:p>
         </p:txBody>
       </p:sp>
-      <p:sp>
-        <p:nvSpPr>
-          <p:cNvPr id="4" name="TextBox 3"/>
-          <p:cNvSpPr txBox="1"/>
-          <p:nvPr/>
-        </p:nvSpPr>
-        <p:spPr>
-          <a:xfrm>
-            <a:off x="548640" y="1188720"/>
-            <a:ext cx="8229600" cy="548640"/>
-          </a:xfrm>
-          <a:prstGeom prst="rect">
-            <a:avLst/>
-          </a:prstGeom>
-          <a:noFill/>
-        </p:spPr>
-        <p:txBody>
-          <a:bodyPr wrap="square">
-            <a:spAutoFit/>
-          </a:bodyPr>
-          <a:lstStyle/>
-          <a:p>
-            <a:pPr algn="l"/>
-            <a:r>
-              <a:rPr sz="1500" b="0" i="0">
-                <a:solidFill>
-                  <a:srgbClr val="000000"/>
-                </a:solidFill>
-                <a:latin typeface="Helvetica Neue"/>
-              </a:rPr>
-              <a:t>Expand the node with the lowest accumulated cost so far</a:t>
-            </a:r>
-          </a:p>
-        </p:txBody>
-      </p:sp>
-      <p:sp>
-        <p:nvSpPr>
-          <p:cNvPr id="5" name="TextBox 4"/>
-          <p:cNvSpPr txBox="1"/>
-          <p:nvPr/>
-        </p:nvSpPr>
-        <p:spPr>
-          <a:xfrm>
-            <a:off x="2743200" y="1828800"/>
-            <a:ext cx="3657600" cy="548640"/>
-          </a:xfrm>
-          <a:prstGeom prst="rect">
-            <a:avLst/>
-          </a:prstGeom>
-          <a:noFill/>
-        </p:spPr>
-        <p:txBody>
-          <a:bodyPr wrap="square">
-            <a:spAutoFit/>
-          </a:bodyPr>
-          <a:lstStyle/>
-          <a:p>
-            <a:pPr algn="ctr"/>
-            <a:r>
-              <a:rPr sz="2800" b="1" i="0">
-                <a:solidFill>
-                  <a:srgbClr val="173482"/>
-                </a:solidFill>
-                <a:latin typeface="Helvetica Neue"/>
-              </a:rPr>
-              <a:t>f(n) = g(n)</a:t>
-            </a:r>
-          </a:p>
-        </p:txBody>
-      </p:sp>
+      <mc:AlternateContent xmlns:mc="http://schemas.openxmlformats.org/markup-compatibility/2006">
+        <mc:Choice xmlns:a14="http://schemas.microsoft.com/office/drawing/2010/main" Requires="a14">
+          <p:sp>
+            <p:nvSpPr>
+              <p:cNvPr id="4" name="TextBox 3"/>
+              <p:cNvSpPr txBox="1"/>
+              <p:nvPr/>
+            </p:nvSpPr>
+            <p:spPr>
+              <a:xfrm>
+                <a:off x="548640" y="1188720"/>
+                <a:ext cx="8229600" cy="1031051"/>
+              </a:xfrm>
+              <a:prstGeom prst="rect">
+                <a:avLst/>
+              </a:prstGeom>
+              <a:noFill/>
+            </p:spPr>
+            <p:txBody>
+              <a:bodyPr wrap="square">
+                <a:spAutoFit/>
+              </a:bodyPr>
+              <a:lstStyle/>
+              <a:p>
+                <a:pPr algn="l"/>
+                <a:r>
+                  <a:rPr sz="1500" b="0" i="0" dirty="0">
+                    <a:solidFill>
+                      <a:srgbClr val="000000"/>
+                    </a:solidFill>
+                    <a:latin typeface="Helvetica Neue"/>
+                  </a:rPr>
+                  <a:t>Expand the node with the lowest accumulated cost so far</a:t>
+                </a:r>
+                <a:r>
+                  <a:rPr lang="en-CA" sz="1500" dirty="0">
+                    <a:solidFill>
+                      <a:srgbClr val="000000"/>
+                    </a:solidFill>
+                    <a:latin typeface="Helvetica Neue"/>
+                  </a:rPr>
+                  <a:t>.</a:t>
+                </a:r>
+              </a:p>
+              <a:p>
+                <a:r>
+                  <a:rPr lang="en-CA" sz="1500" dirty="0">
+                    <a:solidFill>
+                      <a:srgbClr val="000000"/>
+                    </a:solidFill>
+                    <a:latin typeface="Helvetica Neue"/>
+                  </a:rPr>
+                  <a:t>For our graph formulation problem, instead of taking the sum of the paths, we take the Prod of the exchange rates of 2 nodes e</a:t>
+                </a:r>
+                <a:br>
+                  <a:rPr lang="en-CA" sz="1500" dirty="0">
+                    <a:solidFill>
+                      <a:srgbClr val="000000"/>
+                    </a:solidFill>
+                    <a:latin typeface="Helvetica Neue"/>
+                  </a:rPr>
+                </a:br>
+                <a:r>
+                  <a:rPr lang="en-CA" sz="1500" dirty="0">
+                    <a:solidFill>
+                      <a:srgbClr val="000000"/>
+                    </a:solidFill>
+                    <a:latin typeface="Helvetica Neue"/>
+                  </a:rPr>
+                  <a:t>- </a:t>
+                </a:r>
+                <a14:m>
+                  <m:oMath xmlns:m="http://schemas.openxmlformats.org/officeDocument/2006/math">
+                    <m:sSub>
+                      <m:sSubPr>
+                        <m:ctrlPr>
+                          <a:rPr lang="en-CA" sz="1600" i="1">
+                            <a:solidFill>
+                              <a:schemeClr val="dk1"/>
+                            </a:solidFill>
+                            <a:latin typeface="Cambria Math" panose="02040503050406030204" pitchFamily="18" charset="0"/>
+                            <a:cs typeface="Times" panose="02020603050405020304" pitchFamily="18" charset="0"/>
+                          </a:rPr>
+                        </m:ctrlPr>
+                      </m:sSubPr>
+                      <m:e>
+                        <m:r>
+                          <a:rPr lang="en-CA" sz="1600" i="1">
+                            <a:solidFill>
+                              <a:schemeClr val="dk1"/>
+                            </a:solidFill>
+                            <a:latin typeface="Cambria Math" panose="02040503050406030204" pitchFamily="18" charset="0"/>
+                            <a:cs typeface="Times" panose="02020603050405020304" pitchFamily="18" charset="0"/>
+                          </a:rPr>
+                          <m:t>𝐶</m:t>
+                        </m:r>
+                      </m:e>
+                      <m:sub>
+                        <m:r>
+                          <a:rPr lang="en-CA" sz="1600" i="1">
+                            <a:solidFill>
+                              <a:schemeClr val="dk1"/>
+                            </a:solidFill>
+                            <a:latin typeface="Cambria Math" panose="02040503050406030204" pitchFamily="18" charset="0"/>
+                            <a:cs typeface="Times" panose="02020603050405020304" pitchFamily="18" charset="0"/>
+                          </a:rPr>
+                          <m:t>𝑘</m:t>
+                        </m:r>
+                      </m:sub>
+                    </m:sSub>
+                    <m:r>
+                      <a:rPr lang="en-CA" sz="1600" i="1">
+                        <a:solidFill>
+                          <a:schemeClr val="dk1"/>
+                        </a:solidFill>
+                        <a:latin typeface="Cambria Math" panose="02040503050406030204" pitchFamily="18" charset="0"/>
+                        <a:cs typeface="Times" panose="02020603050405020304" pitchFamily="18" charset="0"/>
+                      </a:rPr>
+                      <m:t>=</m:t>
+                    </m:r>
+                    <m:sSub>
+                      <m:sSubPr>
+                        <m:ctrlPr>
+                          <a:rPr lang="en-CA" sz="1600" i="1">
+                            <a:solidFill>
+                              <a:schemeClr val="dk1"/>
+                            </a:solidFill>
+                            <a:latin typeface="Cambria Math" panose="02040503050406030204" pitchFamily="18" charset="0"/>
+                            <a:cs typeface="Times" panose="02020603050405020304" pitchFamily="18" charset="0"/>
+                          </a:rPr>
+                        </m:ctrlPr>
+                      </m:sSubPr>
+                      <m:e>
+                        <m:r>
+                          <a:rPr lang="en-CA" sz="1600" i="1">
+                            <a:solidFill>
+                              <a:schemeClr val="dk1"/>
+                            </a:solidFill>
+                            <a:latin typeface="Cambria Math" panose="02040503050406030204" pitchFamily="18" charset="0"/>
+                            <a:cs typeface="Times" panose="02020603050405020304" pitchFamily="18" charset="0"/>
+                          </a:rPr>
+                          <m:t>𝐶</m:t>
+                        </m:r>
+                      </m:e>
+                      <m:sub>
+                        <m:r>
+                          <a:rPr lang="en-CA" sz="1600" i="1">
+                            <a:solidFill>
+                              <a:schemeClr val="dk1"/>
+                            </a:solidFill>
+                            <a:latin typeface="Cambria Math" panose="02040503050406030204" pitchFamily="18" charset="0"/>
+                            <a:cs typeface="Times" panose="02020603050405020304" pitchFamily="18" charset="0"/>
+                          </a:rPr>
+                          <m:t>0</m:t>
+                        </m:r>
+                      </m:sub>
+                    </m:sSub>
+                    <m:r>
+                      <a:rPr lang="en-US" sz="1600" i="1">
+                        <a:solidFill>
+                          <a:schemeClr val="dk1"/>
+                        </a:solidFill>
+                        <a:latin typeface="Cambria Math" panose="02040503050406030204" pitchFamily="18" charset="0"/>
+                        <a:ea typeface="Cambria Math" panose="02040503050406030204" pitchFamily="18" charset="0"/>
+                        <a:cs typeface="Times" panose="02020603050405020304" pitchFamily="18" charset="0"/>
+                      </a:rPr>
+                      <m:t>∙</m:t>
+                    </m:r>
+                    <m:nary>
+                      <m:naryPr>
+                        <m:chr m:val="∏"/>
+                        <m:supHide m:val="on"/>
+                        <m:ctrlPr>
+                          <a:rPr lang="en-CA" sz="1600" i="1">
+                            <a:solidFill>
+                              <a:schemeClr val="dk1"/>
+                            </a:solidFill>
+                            <a:latin typeface="Cambria Math" panose="02040503050406030204" pitchFamily="18" charset="0"/>
+                            <a:ea typeface="Cambria Math" panose="02040503050406030204" pitchFamily="18" charset="0"/>
+                            <a:cs typeface="Times" panose="02020603050405020304" pitchFamily="18" charset="0"/>
+                          </a:rPr>
+                        </m:ctrlPr>
+                      </m:naryPr>
+                      <m:sub>
+                        <m:r>
+                          <m:rPr>
+                            <m:brk m:alnAt="7"/>
+                          </m:rPr>
+                          <a:rPr lang="en-CA" sz="1600" i="1">
+                            <a:solidFill>
+                              <a:schemeClr val="dk1"/>
+                            </a:solidFill>
+                            <a:latin typeface="Cambria Math" panose="02040503050406030204" pitchFamily="18" charset="0"/>
+                            <a:ea typeface="Cambria Math" panose="02040503050406030204" pitchFamily="18" charset="0"/>
+                            <a:cs typeface="Times" panose="02020603050405020304" pitchFamily="18" charset="0"/>
+                          </a:rPr>
+                          <m:t>𝑒</m:t>
+                        </m:r>
+                        <m:r>
+                          <a:rPr lang="en-CA" sz="1600" i="1">
+                            <a:solidFill>
+                              <a:schemeClr val="dk1"/>
+                            </a:solidFill>
+                            <a:latin typeface="Cambria Math" panose="02040503050406030204" pitchFamily="18" charset="0"/>
+                            <a:ea typeface="Cambria Math" panose="02040503050406030204" pitchFamily="18" charset="0"/>
+                            <a:cs typeface="Times" panose="02020603050405020304" pitchFamily="18" charset="0"/>
+                          </a:rPr>
+                          <m:t>𝜖</m:t>
+                        </m:r>
+                        <m:r>
+                          <a:rPr lang="en-CA" sz="1600" i="1">
+                            <a:solidFill>
+                              <a:schemeClr val="dk1"/>
+                            </a:solidFill>
+                            <a:latin typeface="Cambria Math" panose="02040503050406030204" pitchFamily="18" charset="0"/>
+                            <a:ea typeface="Cambria Math" panose="02040503050406030204" pitchFamily="18" charset="0"/>
+                            <a:cs typeface="Times" panose="02020603050405020304" pitchFamily="18" charset="0"/>
+                          </a:rPr>
+                          <m:t>𝑃</m:t>
+                        </m:r>
+                      </m:sub>
+                      <m:sup/>
+                      <m:e>
+                        <m:r>
+                          <a:rPr lang="en-CA" sz="1600" i="1">
+                            <a:solidFill>
+                              <a:schemeClr val="dk1"/>
+                            </a:solidFill>
+                            <a:latin typeface="Cambria Math" panose="02040503050406030204" pitchFamily="18" charset="0"/>
+                            <a:ea typeface="Cambria Math" panose="02040503050406030204" pitchFamily="18" charset="0"/>
+                            <a:cs typeface="Times" panose="02020603050405020304" pitchFamily="18" charset="0"/>
+                          </a:rPr>
+                          <m:t>𝑟</m:t>
+                        </m:r>
+                        <m:d>
+                          <m:dPr>
+                            <m:ctrlPr>
+                              <a:rPr lang="en-CA" sz="1600" i="1">
+                                <a:solidFill>
+                                  <a:schemeClr val="dk1"/>
+                                </a:solidFill>
+                                <a:latin typeface="Cambria Math" panose="02040503050406030204" pitchFamily="18" charset="0"/>
+                                <a:ea typeface="Cambria Math" panose="02040503050406030204" pitchFamily="18" charset="0"/>
+                                <a:cs typeface="Times" panose="02020603050405020304" pitchFamily="18" charset="0"/>
+                              </a:rPr>
+                            </m:ctrlPr>
+                          </m:dPr>
+                          <m:e>
+                            <m:r>
+                              <a:rPr lang="en-CA" sz="1600" i="1">
+                                <a:solidFill>
+                                  <a:schemeClr val="dk1"/>
+                                </a:solidFill>
+                                <a:latin typeface="Cambria Math" panose="02040503050406030204" pitchFamily="18" charset="0"/>
+                                <a:ea typeface="Cambria Math" panose="02040503050406030204" pitchFamily="18" charset="0"/>
+                                <a:cs typeface="Times" panose="02020603050405020304" pitchFamily="18" charset="0"/>
+                              </a:rPr>
+                              <m:t>𝑒</m:t>
+                            </m:r>
+                          </m:e>
+                        </m:d>
+                      </m:e>
+                    </m:nary>
+                  </m:oMath>
+                </a14:m>
+                <a:r>
+                  <a:rPr lang="en-US" sz="1600" dirty="0">
+                    <a:solidFill>
+                      <a:schemeClr val="dk1"/>
+                    </a:solidFill>
+                    <a:latin typeface="Helvetica Neue" panose="020B0604020202020204" charset="0"/>
+                    <a:cs typeface="Times" panose="02020603050405020304" pitchFamily="18" charset="0"/>
+                  </a:rPr>
+                  <a:t>,</a:t>
+                </a:r>
+                <a:endParaRPr sz="1500" b="0" i="0" dirty="0">
+                  <a:solidFill>
+                    <a:srgbClr val="000000"/>
+                  </a:solidFill>
+                  <a:latin typeface="Helvetica Neue"/>
+                </a:endParaRPr>
+              </a:p>
+            </p:txBody>
+          </p:sp>
+        </mc:Choice>
+        <mc:Fallback>
+          <p:sp>
+            <p:nvSpPr>
+              <p:cNvPr id="4" name="TextBox 3"/>
+              <p:cNvSpPr txBox="1">
+                <a:spLocks noRot="1" noChangeAspect="1" noMove="1" noResize="1" noEditPoints="1" noAdjustHandles="1" noChangeArrowheads="1" noChangeShapeType="1" noTextEdit="1"/>
+              </p:cNvSpPr>
+              <p:nvPr/>
+            </p:nvSpPr>
+            <p:spPr>
+              <a:xfrm>
+                <a:off x="548640" y="1188720"/>
+                <a:ext cx="8229600" cy="1031051"/>
+              </a:xfrm>
+              <a:prstGeom prst="rect">
+                <a:avLst/>
+              </a:prstGeom>
+              <a:blipFill>
+                <a:blip r:embed="rId2"/>
+                <a:stretch>
+                  <a:fillRect l="-296" t="-1183" b="-56213"/>
+                </a:stretch>
+              </a:blipFill>
+            </p:spPr>
+            <p:txBody>
+              <a:bodyPr/>
+              <a:lstStyle/>
+              <a:p>
+                <a:r>
+                  <a:rPr lang="en-CA">
+                    <a:noFill/>
+                  </a:rPr>
+                  <a:t> </a:t>
+                </a:r>
+              </a:p>
+            </p:txBody>
+          </p:sp>
+        </mc:Fallback>
+      </mc:AlternateContent>
       <p:sp>
         <p:nvSpPr>
           <p:cNvPr id="6" name="Rounded Rectangle 5"/>
@@ -9169,6 +9679,7 @@
           <a:lstStyle/>
           <a:p>
             <a:pPr algn="ctr"/>
+            <a:endParaRPr/>
           </a:p>
         </p:txBody>
       </p:sp>
@@ -9272,6 +9783,7 @@
           <a:lstStyle/>
           <a:p>
             <a:pPr algn="ctr"/>
+            <a:endParaRPr/>
           </a:p>
         </p:txBody>
       </p:sp>
@@ -9390,7 +9902,7 @@
 </file>
 
 <file path=ppt/slides/slide9.xml><?xml version="1.0" encoding="utf-8"?>
-<p:sld xmlns:a="http://schemas.openxmlformats.org/drawingml/2006/main" xmlns:p="http://schemas.openxmlformats.org/presentationml/2006/main" xmlns:r="http://schemas.openxmlformats.org/officeDocument/2006/relationships">
+<p:sld xmlns:a="http://schemas.openxmlformats.org/drawingml/2006/main" xmlns:r="http://schemas.openxmlformats.org/officeDocument/2006/relationships" xmlns:p="http://schemas.openxmlformats.org/presentationml/2006/main">
   <p:cSld>
     <p:bg>
       <p:bgPr>
@@ -9406,7 +9918,14 @@
         <p:cNvGrpSpPr/>
         <p:nvPr/>
       </p:nvGrpSpPr>
-      <p:grpSpPr/>
+      <p:grpSpPr>
+        <a:xfrm>
+          <a:off x="0" y="0"/>
+          <a:ext cx="0" cy="0"/>
+          <a:chOff x="0" y="0"/>
+          <a:chExt cx="0" cy="0"/>
+        </a:xfrm>
+      </p:grpSpPr>
       <p:sp>
         <p:nvSpPr>
           <p:cNvPr id="2" name="Rectangle 1"/>
@@ -9448,6 +9967,7 @@
           <a:lstStyle/>
           <a:p>
             <a:pPr algn="ctr"/>
+            <a:endParaRPr/>
           </a:p>
         </p:txBody>
       </p:sp>
@@ -9495,7 +10015,7 @@
         <p:spPr>
           <a:xfrm>
             <a:off x="548640" y="1188720"/>
-            <a:ext cx="8229600" cy="548640"/>
+            <a:ext cx="8229600" cy="323165"/>
           </a:xfrm>
           <a:prstGeom prst="rect">
             <a:avLst/>
@@ -9508,9 +10028,8 @@
           </a:bodyPr>
           <a:lstStyle/>
           <a:p>
-            <a:pPr algn="l"/>
-            <a:r>
-              <a:rPr sz="1500" b="0" i="0">
+            <a:r>
+              <a:rPr sz="1500" b="0" i="0" dirty="0">
                 <a:solidFill>
                   <a:srgbClr val="000000"/>
                 </a:solidFill>
@@ -9518,6 +10037,21 @@
               </a:rPr>
               <a:t>Add a heuristic that looks ahead at execution quality</a:t>
             </a:r>
+            <a:r>
+              <a:rPr lang="en-CA" sz="1500" b="0" i="0" dirty="0">
+                <a:solidFill>
+                  <a:srgbClr val="000000"/>
+                </a:solidFill>
+                <a:latin typeface="Helvetica Neue"/>
+              </a:rPr>
+              <a:t>. </a:t>
+            </a:r>
+            <a:endParaRPr sz="1500" b="0" i="0" dirty="0">
+              <a:solidFill>
+                <a:srgbClr val="000000"/>
+              </a:solidFill>
+              <a:latin typeface="Helvetica Neue"/>
+            </a:endParaRPr>
           </a:p>
         </p:txBody>
       </p:sp>
@@ -9545,7 +10079,7 @@
           <a:p>
             <a:pPr algn="ctr"/>
             <a:r>
-              <a:rPr sz="2800" b="1" i="0">
+              <a:rPr sz="2800" b="1" i="0" dirty="0">
                 <a:solidFill>
                   <a:srgbClr val="173482"/>
                 </a:solidFill>
@@ -9597,6 +10131,7 @@
           <a:lstStyle/>
           <a:p>
             <a:pPr algn="ctr"/>
+            <a:endParaRPr/>
           </a:p>
         </p:txBody>
       </p:sp>
@@ -9635,6 +10170,12 @@
           </a:p>
           <a:p>
             <a:pPr algn="l"/>
+            <a:endParaRPr sz="1300" b="0" i="0">
+              <a:solidFill>
+                <a:srgbClr val="000000"/>
+              </a:solidFill>
+              <a:latin typeface="Helvetica Neue"/>
+            </a:endParaRPr>
           </a:p>
           <a:p>
             <a:pPr algn="l"/>
@@ -9662,6 +10203,12 @@
           </a:p>
           <a:p>
             <a:pPr algn="l"/>
+            <a:endParaRPr sz="1300" b="0" i="0">
+              <a:solidFill>
+                <a:srgbClr val="000000"/>
+              </a:solidFill>
+              <a:latin typeface="Helvetica Neue"/>
+            </a:endParaRPr>
           </a:p>
           <a:p>
             <a:pPr algn="l"/>
@@ -10038,4 +10585,10 @@
   </a:objectDefaults>
   <a:extraClrSchemeLst/>
 </a:theme>
+</file>
+
+<file path=docMetadata/LabelInfo.xml><?xml version="1.0" encoding="utf-8"?>
+<clbl:labelList xmlns:clbl="http://schemas.microsoft.com/office/2020/mipLabelMetadata">
+  <clbl:label id="{1a4d86c9-6ef8-4c81-b7a9-15a3140c062e}" enabled="1" method="Standard" siteId="{4bb44aac-867a-4be0-aa34-30794e8470dd}" contentBits="0" removed="0"/>
+</clbl:labelList>
 </file>
</xml_diff>